<commit_message>
Auto-build: 2026-03-12 21:59 UTC
</commit_message>
<xml_diff>
--- a/reports/2026-02.pptx
+++ b/reports/2026-02.pptx
@@ -7226,13 +7226,13 @@
             <a:r>
               <a:rPr lang="en-US" sz="1200" b="1" dirty="0">
                 <a:solidFill>
-                  <a:srgbClr val="718096"/>
+                  <a:srgbClr val="C0392B"/>
                 </a:solidFill>
                 <a:latin typeface="Calibri" pitchFamily="34" charset="0"/>
                 <a:ea typeface="Calibri" pitchFamily="34" charset="-122"/>
                 <a:cs typeface="Calibri" pitchFamily="34" charset="-120"/>
               </a:rPr>
-              <a:t>—</a:t>
+              <a:t>+66.7%</a:t>
             </a:r>
             <a:endParaRPr lang="en-US" sz="1200" dirty="0"/>
           </a:p>
@@ -7265,13 +7265,13 @@
             <a:r>
               <a:rPr lang="en-US" sz="1200" b="1" dirty="0">
                 <a:solidFill>
-                  <a:srgbClr val="718096"/>
+                  <a:srgbClr val="1A7A6E"/>
                 </a:solidFill>
                 <a:latin typeface="Calibri" pitchFamily="34" charset="0"/>
                 <a:ea typeface="Calibri" pitchFamily="34" charset="-122"/>
                 <a:cs typeface="Calibri" pitchFamily="34" charset="-120"/>
               </a:rPr>
-              <a:t>—</a:t>
+              <a:t>-8.8%</a:t>
             </a:r>
             <a:endParaRPr lang="en-US" sz="1200" dirty="0"/>
           </a:p>
@@ -7304,13 +7304,13 @@
             <a:r>
               <a:rPr lang="en-US" sz="1200" b="1" dirty="0">
                 <a:solidFill>
-                  <a:srgbClr val="718096"/>
+                  <a:srgbClr val="C0392B"/>
                 </a:solidFill>
                 <a:latin typeface="Calibri" pitchFamily="34" charset="0"/>
                 <a:ea typeface="Calibri" pitchFamily="34" charset="-122"/>
                 <a:cs typeface="Calibri" pitchFamily="34" charset="-120"/>
               </a:rPr>
-              <a:t>—</a:t>
+              <a:t>+21.2%</a:t>
             </a:r>
             <a:endParaRPr lang="en-US" sz="1200" dirty="0"/>
           </a:p>
@@ -8382,13 +8382,13 @@
             <a:r>
               <a:rPr lang="en-US" sz="1200" b="1" dirty="0">
                 <a:solidFill>
-                  <a:srgbClr val="718096"/>
+                  <a:srgbClr val="C0392B"/>
                 </a:solidFill>
                 <a:latin typeface="Calibri" pitchFamily="34" charset="0"/>
                 <a:ea typeface="Calibri" pitchFamily="34" charset="-122"/>
                 <a:cs typeface="Calibri" pitchFamily="34" charset="-120"/>
               </a:rPr>
-              <a:t>+9726 bps</a:t>
+              <a:t>+868 bps</a:t>
             </a:r>
             <a:endParaRPr lang="en-US" sz="1200" dirty="0"/>
           </a:p>
@@ -8421,13 +8421,13 @@
             <a:r>
               <a:rPr lang="en-US" sz="1200" b="1" dirty="0">
                 <a:solidFill>
-                  <a:srgbClr val="718096"/>
+                  <a:srgbClr val="C0392B"/>
                 </a:solidFill>
                 <a:latin typeface="Calibri" pitchFamily="34" charset="0"/>
                 <a:ea typeface="Calibri" pitchFamily="34" charset="-122"/>
                 <a:cs typeface="Calibri" pitchFamily="34" charset="-120"/>
               </a:rPr>
-              <a:t>+8331 bps</a:t>
+              <a:t>+21 bps</a:t>
             </a:r>
             <a:endParaRPr lang="en-US" sz="1200" dirty="0"/>
           </a:p>
@@ -8460,13 +8460,13 @@
             <a:r>
               <a:rPr lang="en-US" sz="1200" b="1" dirty="0">
                 <a:solidFill>
-                  <a:srgbClr val="718096"/>
+                  <a:srgbClr val="C0392B"/>
                 </a:solidFill>
                 <a:latin typeface="Calibri" pitchFamily="34" charset="0"/>
                 <a:ea typeface="Calibri" pitchFamily="34" charset="-122"/>
                 <a:cs typeface="Calibri" pitchFamily="34" charset="-120"/>
               </a:rPr>
-              <a:t>+6331 bps</a:t>
+              <a:t>+145 bps</a:t>
             </a:r>
             <a:endParaRPr lang="en-US" sz="1200" dirty="0"/>
           </a:p>
@@ -9538,13 +9538,13 @@
             <a:r>
               <a:rPr lang="en-US" sz="1200" b="1" dirty="0">
                 <a:solidFill>
-                  <a:srgbClr val="718096"/>
+                  <a:srgbClr val="C0392B"/>
                 </a:solidFill>
                 <a:latin typeface="Calibri" pitchFamily="34" charset="0"/>
                 <a:ea typeface="Calibri" pitchFamily="34" charset="-122"/>
                 <a:cs typeface="Calibri" pitchFamily="34" charset="-120"/>
               </a:rPr>
-              <a:t>—</a:t>
+              <a:t>+65.9%</a:t>
             </a:r>
             <a:endParaRPr lang="en-US" sz="1200" dirty="0"/>
           </a:p>
@@ -9577,13 +9577,13 @@
             <a:r>
               <a:rPr lang="en-US" sz="1200" b="1" dirty="0">
                 <a:solidFill>
-                  <a:srgbClr val="718096"/>
+                  <a:srgbClr val="C0392B"/>
                 </a:solidFill>
                 <a:latin typeface="Calibri" pitchFamily="34" charset="0"/>
                 <a:ea typeface="Calibri" pitchFamily="34" charset="-122"/>
                 <a:cs typeface="Calibri" pitchFamily="34" charset="-120"/>
               </a:rPr>
-              <a:t>—</a:t>
+              <a:t>+11.0%</a:t>
             </a:r>
             <a:endParaRPr lang="en-US" sz="1200" dirty="0"/>
           </a:p>
@@ -9616,13 +9616,13 @@
             <a:r>
               <a:rPr lang="en-US" sz="1200" b="1" dirty="0">
                 <a:solidFill>
-                  <a:srgbClr val="718096"/>
+                  <a:srgbClr val="C0392B"/>
                 </a:solidFill>
                 <a:latin typeface="Calibri" pitchFamily="34" charset="0"/>
                 <a:ea typeface="Calibri" pitchFamily="34" charset="-122"/>
                 <a:cs typeface="Calibri" pitchFamily="34" charset="-120"/>
               </a:rPr>
-              <a:t>—</a:t>
+              <a:t>+17.8%</a:t>
             </a:r>
             <a:endParaRPr lang="en-US" sz="1200" dirty="0"/>
           </a:p>
@@ -10759,7 +10759,7 @@
                 <a:ea typeface="Calibri" pitchFamily="34" charset="-122"/>
                 <a:cs typeface="Calibri" pitchFamily="34" charset="-120"/>
               </a:rPr>
-              <a:t>Total disbursed: $4,152,197 (+31.8% vs prior month).</a:t>
+              <a:t>Total disbursed: $4,152,197 (+5.4% vs prior month).</a:t>
             </a:r>
             <a:endParaRPr lang="en-US" sz="1200" dirty="0"/>
           </a:p>
@@ -11403,13 +11403,13 @@
             <a:r>
               <a:rPr lang="en-US" sz="1200" b="1" dirty="0">
                 <a:solidFill>
-                  <a:srgbClr val="718096"/>
+                  <a:srgbClr val="1A7A6E"/>
                 </a:solidFill>
                 <a:latin typeface="Calibri" pitchFamily="34" charset="0"/>
                 <a:ea typeface="Calibri" pitchFamily="34" charset="-122"/>
                 <a:cs typeface="Calibri" pitchFamily="34" charset="-120"/>
               </a:rPr>
-              <a:t>—</a:t>
+              <a:t>-6.5%</a:t>
             </a:r>
             <a:endParaRPr lang="en-US" sz="1200" dirty="0"/>
           </a:p>
@@ -11442,13 +11442,13 @@
             <a:r>
               <a:rPr lang="en-US" sz="1200" b="1" dirty="0">
                 <a:solidFill>
-                  <a:srgbClr val="718096"/>
+                  <a:srgbClr val="C0392B"/>
                 </a:solidFill>
                 <a:latin typeface="Calibri" pitchFamily="34" charset="0"/>
                 <a:ea typeface="Calibri" pitchFamily="34" charset="-122"/>
                 <a:cs typeface="Calibri" pitchFamily="34" charset="-120"/>
               </a:rPr>
-              <a:t>—</a:t>
+              <a:t>+16.9%</a:t>
             </a:r>
             <a:endParaRPr lang="en-US" sz="1200" dirty="0"/>
           </a:p>
@@ -11481,13 +11481,13 @@
             <a:r>
               <a:rPr lang="en-US" sz="1200" b="1" dirty="0">
                 <a:solidFill>
-                  <a:srgbClr val="718096"/>
+                  <a:srgbClr val="1A7A6E"/>
                 </a:solidFill>
                 <a:latin typeface="Calibri" pitchFamily="34" charset="0"/>
                 <a:ea typeface="Calibri" pitchFamily="34" charset="-122"/>
                 <a:cs typeface="Calibri" pitchFamily="34" charset="-120"/>
               </a:rPr>
-              <a:t>—</a:t>
+              <a:t>-24.5%</a:t>
             </a:r>
             <a:endParaRPr lang="en-US" sz="1200" dirty="0"/>
           </a:p>
@@ -11687,13 +11687,13 @@
             <a:r>
               <a:rPr lang="en-US" sz="1200" b="1" dirty="0">
                 <a:solidFill>
-                  <a:srgbClr val="718096"/>
+                  <a:srgbClr val="C0392B"/>
                 </a:solidFill>
                 <a:latin typeface="Calibri" pitchFamily="34" charset="0"/>
                 <a:ea typeface="Calibri" pitchFamily="34" charset="-122"/>
                 <a:cs typeface="Calibri" pitchFamily="34" charset="-120"/>
               </a:rPr>
-              <a:t>—</a:t>
+              <a:t>+34.1%</a:t>
             </a:r>
             <a:endParaRPr lang="en-US" sz="1200" dirty="0"/>
           </a:p>
@@ -11726,13 +11726,13 @@
             <a:r>
               <a:rPr lang="en-US" sz="1200" b="1" dirty="0">
                 <a:solidFill>
-                  <a:srgbClr val="718096"/>
+                  <a:srgbClr val="1A7A6E"/>
                 </a:solidFill>
                 <a:latin typeface="Calibri" pitchFamily="34" charset="0"/>
                 <a:ea typeface="Calibri" pitchFamily="34" charset="-122"/>
                 <a:cs typeface="Calibri" pitchFamily="34" charset="-120"/>
               </a:rPr>
-              <a:t>—</a:t>
+              <a:t>-33.3%</a:t>
             </a:r>
             <a:endParaRPr lang="en-US" sz="1200" dirty="0"/>
           </a:p>
@@ -11765,13 +11765,13 @@
             <a:r>
               <a:rPr lang="en-US" sz="1200" b="1" dirty="0">
                 <a:solidFill>
-                  <a:srgbClr val="718096"/>
+                  <a:srgbClr val="C0392B"/>
                 </a:solidFill>
                 <a:latin typeface="Calibri" pitchFamily="34" charset="0"/>
                 <a:ea typeface="Calibri" pitchFamily="34" charset="-122"/>
                 <a:cs typeface="Calibri" pitchFamily="34" charset="-120"/>
               </a:rPr>
-              <a:t>—</a:t>
+              <a:t>+78.3%</a:t>
             </a:r>
             <a:endParaRPr lang="en-US" sz="1200" dirty="0"/>
           </a:p>
@@ -12293,13 +12293,13 @@
             <a:r>
               <a:rPr lang="en-US" sz="1200" b="1" dirty="0">
                 <a:solidFill>
-                  <a:srgbClr val="718096"/>
+                  <a:srgbClr val="C0392B"/>
                 </a:solidFill>
                 <a:latin typeface="Calibri" pitchFamily="34" charset="0"/>
                 <a:ea typeface="Calibri" pitchFamily="34" charset="-122"/>
                 <a:cs typeface="Calibri" pitchFamily="34" charset="-120"/>
               </a:rPr>
-              <a:t>—</a:t>
+              <a:t>+18.2%</a:t>
             </a:r>
             <a:endParaRPr lang="en-US" sz="1200" dirty="0"/>
           </a:p>
@@ -12332,13 +12332,13 @@
             <a:r>
               <a:rPr lang="en-US" sz="1200" b="1" dirty="0">
                 <a:solidFill>
-                  <a:srgbClr val="718096"/>
+                  <a:srgbClr val="C0392B"/>
                 </a:solidFill>
                 <a:latin typeface="Calibri" pitchFamily="34" charset="0"/>
                 <a:ea typeface="Calibri" pitchFamily="34" charset="-122"/>
                 <a:cs typeface="Calibri" pitchFamily="34" charset="-120"/>
               </a:rPr>
-              <a:t>—</a:t>
+              <a:t>+14.0%</a:t>
             </a:r>
             <a:endParaRPr lang="en-US" sz="1200" dirty="0"/>
           </a:p>
@@ -12371,13 +12371,13 @@
             <a:r>
               <a:rPr lang="en-US" sz="1200" b="1" dirty="0">
                 <a:solidFill>
-                  <a:srgbClr val="718096"/>
+                  <a:srgbClr val="C0392B"/>
                 </a:solidFill>
                 <a:latin typeface="Calibri" pitchFamily="34" charset="0"/>
                 <a:ea typeface="Calibri" pitchFamily="34" charset="-122"/>
                 <a:cs typeface="Calibri" pitchFamily="34" charset="-120"/>
               </a:rPr>
-              <a:t>—</a:t>
+              <a:t>+7.5%</a:t>
             </a:r>
             <a:endParaRPr lang="en-US" sz="1200" dirty="0"/>
           </a:p>
@@ -12608,7 +12608,7 @@
                 <a:ea typeface="Century Gothic" pitchFamily="34" charset="-122"/>
                 <a:cs typeface="Century Gothic" pitchFamily="34" charset="-120"/>
               </a:rPr>
-              <a:t>+45.4%</a:t>
+              <a:t>+12.4%</a:t>
             </a:r>
             <a:endParaRPr lang="en-US" sz="2600" dirty="0"/>
           </a:p>
@@ -12775,7 +12775,7 @@
                 <a:ea typeface="Calibri" pitchFamily="34" charset="-122"/>
                 <a:cs typeface="Calibri" pitchFamily="34" charset="-120"/>
               </a:rPr>
-              <a:t>Total loan book: $13,661,650 (+45.4% vs prior month).</a:t>
+              <a:t>Total loan book: $13,661,650 (+12.4% vs prior month).</a:t>
             </a:r>
             <a:endParaRPr lang="en-US" sz="1200" dirty="0"/>
           </a:p>
@@ -14040,7 +14040,7 @@
                           <a:ea typeface="Calibri" pitchFamily="34" charset="-122"/>
                           <a:cs typeface="Calibri" pitchFamily="34" charset="-120"/>
                         </a:rPr>
-                        <a:t>0.0%</a:t>
+                        <a:t>11.1%</a:t>
                       </a:r>
                       <a:endParaRPr lang="en-US" sz="1200" dirty="0">
                         <a:latin typeface="Calibri" charset="0"/>
@@ -14176,7 +14176,7 @@
                           <a:ea typeface="Calibri" pitchFamily="34" charset="-122"/>
                           <a:cs typeface="Calibri" pitchFamily="34" charset="-120"/>
                         </a:rPr>
-                        <a:t>+1159 bps</a:t>
+                        <a:t>+51 bps</a:t>
                       </a:r>
                       <a:endParaRPr lang="en-US" sz="1200" dirty="0">
                         <a:latin typeface="Calibri" charset="0"/>
@@ -14314,7 +14314,7 @@
                           <a:ea typeface="Calibri" pitchFamily="34" charset="-122"/>
                           <a:cs typeface="Calibri" pitchFamily="34" charset="-120"/>
                         </a:rPr>
-                        <a:t>0.0%</a:t>
+                        <a:t>2.7%</a:t>
                       </a:r>
                       <a:endParaRPr lang="en-US" sz="1200" dirty="0">
                         <a:latin typeface="Calibri" charset="0"/>
@@ -14444,13 +14444,13 @@
                       <a:r>
                         <a:rPr lang="en-US" sz="1200" dirty="0">
                           <a:solidFill>
-                            <a:srgbClr val="C0392B"/>
+                            <a:srgbClr val="1A7A6E"/>
                           </a:solidFill>
                           <a:latin typeface="Calibri" pitchFamily="34" charset="0"/>
                           <a:ea typeface="Calibri" pitchFamily="34" charset="-122"/>
                           <a:cs typeface="Calibri" pitchFamily="34" charset="-120"/>
                         </a:rPr>
-                        <a:t>+225 bps</a:t>
+                        <a:t>-43 bps</a:t>
                       </a:r>
                       <a:endParaRPr lang="en-US" sz="1200" dirty="0">
                         <a:latin typeface="Calibri" charset="0"/>
@@ -14588,7 +14588,7 @@
                           <a:ea typeface="Calibri" pitchFamily="34" charset="-122"/>
                           <a:cs typeface="Calibri" pitchFamily="34" charset="-120"/>
                         </a:rPr>
-                        <a:t>0.0%</a:t>
+                        <a:t>15.7%</a:t>
                       </a:r>
                       <a:endParaRPr lang="en-US" sz="1200" dirty="0">
                         <a:latin typeface="Calibri" charset="0"/>
@@ -14724,7 +14724,7 @@
                           <a:ea typeface="Calibri" pitchFamily="34" charset="-122"/>
                           <a:cs typeface="Calibri" pitchFamily="34" charset="-120"/>
                         </a:rPr>
-                        <a:t>+1756 bps</a:t>
+                        <a:t>+184 bps</a:t>
                       </a:r>
                       <a:endParaRPr lang="en-US" sz="1200" dirty="0">
                         <a:latin typeface="Calibri" charset="0"/>
@@ -14862,7 +14862,7 @@
                           <a:ea typeface="Calibri" pitchFamily="34" charset="-122"/>
                           <a:cs typeface="Calibri" pitchFamily="34" charset="-120"/>
                         </a:rPr>
-                        <a:t>4.8%</a:t>
+                        <a:t>5.6%</a:t>
                       </a:r>
                       <a:endParaRPr lang="en-US" sz="1200" dirty="0">
                         <a:latin typeface="Calibri" charset="0"/>
@@ -14998,7 +14998,7 @@
                           <a:ea typeface="Calibri" pitchFamily="34" charset="-122"/>
                           <a:cs typeface="Calibri" pitchFamily="34" charset="-120"/>
                         </a:rPr>
-                        <a:t>+161 bps</a:t>
+                        <a:t>+81 bps</a:t>
                       </a:r>
                       <a:endParaRPr lang="en-US" sz="1200" dirty="0">
                         <a:latin typeface="Calibri" charset="0"/>
@@ -16296,7 +16296,7 @@
                           <a:ea typeface="Calibri" pitchFamily="34" charset="-122"/>
                           <a:cs typeface="Calibri" pitchFamily="34" charset="-120"/>
                         </a:rPr>
-                        <a:t>0.0%</a:t>
+                        <a:t>17.4%</a:t>
                       </a:r>
                       <a:endParaRPr lang="en-US" sz="1200" dirty="0">
                         <a:latin typeface="Calibri" charset="0"/>
@@ -16432,7 +16432,7 @@
                           <a:ea typeface="Calibri" pitchFamily="34" charset="-122"/>
                           <a:cs typeface="Calibri" pitchFamily="34" charset="-120"/>
                         </a:rPr>
-                        <a:t>+1875 bps</a:t>
+                        <a:t>+139 bps</a:t>
                       </a:r>
                       <a:endParaRPr lang="en-US" sz="1200" dirty="0">
                         <a:latin typeface="Calibri" charset="0"/>
@@ -16570,7 +16570,7 @@
                           <a:ea typeface="Calibri" pitchFamily="34" charset="-122"/>
                           <a:cs typeface="Calibri" pitchFamily="34" charset="-120"/>
                         </a:rPr>
-                        <a:t>0.0%</a:t>
+                        <a:t>2.0%</a:t>
                       </a:r>
                       <a:endParaRPr lang="en-US" sz="1200" dirty="0">
                         <a:latin typeface="Calibri" charset="0"/>
@@ -16700,13 +16700,13 @@
                       <a:r>
                         <a:rPr lang="en-US" sz="1200" dirty="0">
                           <a:solidFill>
-                            <a:srgbClr val="C0392B"/>
+                            <a:srgbClr val="1A7A6E"/>
                           </a:solidFill>
                           <a:latin typeface="Calibri" pitchFamily="34" charset="0"/>
                           <a:ea typeface="Calibri" pitchFamily="34" charset="-122"/>
                           <a:cs typeface="Calibri" pitchFamily="34" charset="-120"/>
                         </a:rPr>
-                        <a:t>+180 bps</a:t>
+                        <a:t>-20 bps</a:t>
                       </a:r>
                       <a:endParaRPr lang="en-US" sz="1200" dirty="0">
                         <a:latin typeface="Calibri" charset="0"/>
@@ -16844,7 +16844,7 @@
                           <a:ea typeface="Calibri" pitchFamily="34" charset="-122"/>
                           <a:cs typeface="Calibri" pitchFamily="34" charset="-120"/>
                         </a:rPr>
-                        <a:t>0.0%</a:t>
+                        <a:t>17.0%</a:t>
                       </a:r>
                       <a:endParaRPr lang="en-US" sz="1200" dirty="0">
                         <a:latin typeface="Calibri" charset="0"/>
@@ -16980,7 +16980,7 @@
                           <a:ea typeface="Calibri" pitchFamily="34" charset="-122"/>
                           <a:cs typeface="Calibri" pitchFamily="34" charset="-120"/>
                         </a:rPr>
-                        <a:t>+2170 bps</a:t>
+                        <a:t>+470 bps</a:t>
                       </a:r>
                       <a:endParaRPr lang="en-US" sz="1200" dirty="0">
                         <a:latin typeface="Calibri" charset="0"/>
@@ -17118,7 +17118,7 @@
                           <a:ea typeface="Calibri" pitchFamily="34" charset="-122"/>
                           <a:cs typeface="Calibri" pitchFamily="34" charset="-120"/>
                         </a:rPr>
-                        <a:t>7.4%</a:t>
+                        <a:t>8.1%</a:t>
                       </a:r>
                       <a:endParaRPr lang="en-US" sz="1200" dirty="0">
                         <a:latin typeface="Calibri" charset="0"/>
@@ -17254,7 +17254,7 @@
                           <a:ea typeface="Calibri" pitchFamily="34" charset="-122"/>
                           <a:cs typeface="Calibri" pitchFamily="34" charset="-120"/>
                         </a:rPr>
-                        <a:t>+182 bps</a:t>
+                        <a:t>+103 bps</a:t>
                       </a:r>
                       <a:endParaRPr lang="en-US" sz="1200" dirty="0">
                         <a:latin typeface="Calibri" charset="0"/>

</xml_diff>

<commit_message>
Auto-build: 2026-03-13 13:21 UTC
</commit_message>
<xml_diff>
--- a/reports/2026-02.pptx
+++ b/reports/2026-02.pptx
@@ -5330,7 +5330,7 @@
             <a:r>
               <a:rPr lang="en-US" sz="1200" b="1" dirty="0">
                 <a:solidFill>
-                  <a:srgbClr val="1A7A6E"/>
+                  <a:srgbClr val="C0392B"/>
                 </a:solidFill>
                 <a:latin typeface="Calibri" pitchFamily="34" charset="0"/>
                 <a:ea typeface="Calibri" pitchFamily="34" charset="-122"/>
@@ -5369,7 +5369,7 @@
             <a:r>
               <a:rPr lang="en-US" sz="1200" b="1" dirty="0">
                 <a:solidFill>
-                  <a:srgbClr val="1A7A6E"/>
+                  <a:srgbClr val="C0392B"/>
                 </a:solidFill>
                 <a:latin typeface="Calibri" pitchFamily="34" charset="0"/>
                 <a:ea typeface="Calibri" pitchFamily="34" charset="-122"/>
@@ -5408,7 +5408,7 @@
             <a:r>
               <a:rPr lang="en-US" sz="1200" b="1" dirty="0">
                 <a:solidFill>
-                  <a:srgbClr val="1A7A6E"/>
+                  <a:srgbClr val="C0392B"/>
                 </a:solidFill>
                 <a:latin typeface="Calibri" pitchFamily="34" charset="0"/>
                 <a:ea typeface="Calibri" pitchFamily="34" charset="-122"/>
@@ -5447,7 +5447,7 @@
             <a:r>
               <a:rPr lang="en-US" sz="1200" b="1" dirty="0">
                 <a:solidFill>
-                  <a:srgbClr val="1A7A6E"/>
+                  <a:srgbClr val="C0392B"/>
                 </a:solidFill>
                 <a:latin typeface="Calibri" pitchFamily="34" charset="0"/>
                 <a:ea typeface="Calibri" pitchFamily="34" charset="-122"/>
@@ -5486,7 +5486,7 @@
             <a:r>
               <a:rPr lang="en-US" sz="1200" b="1" dirty="0">
                 <a:solidFill>
-                  <a:srgbClr val="1A7A6E"/>
+                  <a:srgbClr val="C0392B"/>
                 </a:solidFill>
                 <a:latin typeface="Calibri" pitchFamily="34" charset="0"/>
                 <a:ea typeface="Calibri" pitchFamily="34" charset="-122"/>
@@ -5936,7 +5936,7 @@
             <a:r>
               <a:rPr lang="en-US" sz="1200" b="1" dirty="0">
                 <a:solidFill>
-                  <a:srgbClr val="C0392B"/>
+                  <a:srgbClr val="1A7A6E"/>
                 </a:solidFill>
                 <a:latin typeface="Calibri" pitchFamily="34" charset="0"/>
                 <a:ea typeface="Calibri" pitchFamily="34" charset="-122"/>
@@ -5957,6 +5957,45 @@
         <p:spPr>
           <a:xfrm>
             <a:off x="2514600" y="5943600"/>
+            <a:ext cx="2377440" cy="347472"/>
+          </a:xfrm>
+          <a:prstGeom prst="rect">
+            <a:avLst/>
+          </a:prstGeom>
+          <a:noFill/>
+          <a:ln/>
+        </p:spPr>
+        <p:txBody>
+          <a:bodyPr wrap="square" rtlCol="0" anchor="ctr"/>
+          <a:lstStyle/>
+          <a:p>
+            <a:pPr algn="ctr" indent="0" marL="0">
+              <a:buNone/>
+            </a:pPr>
+            <a:r>
+              <a:rPr lang="en-US" sz="1200" b="1" dirty="0">
+                <a:solidFill>
+                  <a:srgbClr val="1A7A6E"/>
+                </a:solidFill>
+                <a:latin typeface="Calibri" pitchFamily="34" charset="0"/>
+                <a:ea typeface="Calibri" pitchFamily="34" charset="-122"/>
+                <a:cs typeface="Calibri" pitchFamily="34" charset="-120"/>
+              </a:rPr>
+              <a:t>-3.8%</a:t>
+            </a:r>
+            <a:endParaRPr lang="en-US" sz="1200" dirty="0"/>
+          </a:p>
+        </p:txBody>
+      </p:sp>
+      <p:sp>
+        <p:nvSpPr>
+          <p:cNvPr id="17" name="Text 14"/>
+          <p:cNvSpPr/>
+          <p:nvPr/>
+        </p:nvSpPr>
+        <p:spPr>
+          <a:xfrm>
+            <a:off x="4892040" y="5943600"/>
             <a:ext cx="2377440" cy="347472"/>
           </a:xfrm>
           <a:prstGeom prst="rect">
@@ -5981,7 +6020,7 @@
                 <a:ea typeface="Calibri" pitchFamily="34" charset="-122"/>
                 <a:cs typeface="Calibri" pitchFamily="34" charset="-120"/>
               </a:rPr>
-              <a:t>-3.8%</a:t>
+              <a:t>+13.7%</a:t>
             </a:r>
             <a:endParaRPr lang="en-US" sz="1200" dirty="0"/>
           </a:p>
@@ -5989,13 +6028,13 @@
       </p:sp>
       <p:sp>
         <p:nvSpPr>
-          <p:cNvPr id="17" name="Text 14"/>
-          <p:cNvSpPr/>
-          <p:nvPr/>
-        </p:nvSpPr>
-        <p:spPr>
-          <a:xfrm>
-            <a:off x="4892040" y="5943600"/>
+          <p:cNvPr id="18" name="Text 15"/>
+          <p:cNvSpPr/>
+          <p:nvPr/>
+        </p:nvSpPr>
+        <p:spPr>
+          <a:xfrm>
+            <a:off x="7269480" y="5943600"/>
             <a:ext cx="2377440" cy="347472"/>
           </a:xfrm>
           <a:prstGeom prst="rect">
@@ -6014,13 +6053,13 @@
             <a:r>
               <a:rPr lang="en-US" sz="1200" b="1" dirty="0">
                 <a:solidFill>
-                  <a:srgbClr val="1A7A6E"/>
+                  <a:srgbClr val="C0392B"/>
                 </a:solidFill>
                 <a:latin typeface="Calibri" pitchFamily="34" charset="0"/>
                 <a:ea typeface="Calibri" pitchFamily="34" charset="-122"/>
                 <a:cs typeface="Calibri" pitchFamily="34" charset="-120"/>
               </a:rPr>
-              <a:t>+13.7%</a:t>
+              <a:t>+3.2%</a:t>
             </a:r>
             <a:endParaRPr lang="en-US" sz="1200" dirty="0"/>
           </a:p>
@@ -6028,13 +6067,13 @@
       </p:sp>
       <p:sp>
         <p:nvSpPr>
-          <p:cNvPr id="18" name="Text 15"/>
-          <p:cNvSpPr/>
-          <p:nvPr/>
-        </p:nvSpPr>
-        <p:spPr>
-          <a:xfrm>
-            <a:off x="7269480" y="5943600"/>
+          <p:cNvPr id="19" name="Text 16"/>
+          <p:cNvSpPr/>
+          <p:nvPr/>
+        </p:nvSpPr>
+        <p:spPr>
+          <a:xfrm>
+            <a:off x="9646920" y="5943600"/>
             <a:ext cx="2377440" cy="347472"/>
           </a:xfrm>
           <a:prstGeom prst="rect">
@@ -6053,46 +6092,7 @@
             <a:r>
               <a:rPr lang="en-US" sz="1200" b="1" dirty="0">
                 <a:solidFill>
-                  <a:srgbClr val="1A7A6E"/>
-                </a:solidFill>
-                <a:latin typeface="Calibri" pitchFamily="34" charset="0"/>
-                <a:ea typeface="Calibri" pitchFamily="34" charset="-122"/>
-                <a:cs typeface="Calibri" pitchFamily="34" charset="-120"/>
-              </a:rPr>
-              <a:t>+3.2%</a:t>
-            </a:r>
-            <a:endParaRPr lang="en-US" sz="1200" dirty="0"/>
-          </a:p>
-        </p:txBody>
-      </p:sp>
-      <p:sp>
-        <p:nvSpPr>
-          <p:cNvPr id="19" name="Text 16"/>
-          <p:cNvSpPr/>
-          <p:nvPr/>
-        </p:nvSpPr>
-        <p:spPr>
-          <a:xfrm>
-            <a:off x="9646920" y="5943600"/>
-            <a:ext cx="2377440" cy="347472"/>
-          </a:xfrm>
-          <a:prstGeom prst="rect">
-            <a:avLst/>
-          </a:prstGeom>
-          <a:noFill/>
-          <a:ln/>
-        </p:spPr>
-        <p:txBody>
-          <a:bodyPr wrap="square" rtlCol="0" anchor="ctr"/>
-          <a:lstStyle/>
-          <a:p>
-            <a:pPr algn="ctr" indent="0" marL="0">
-              <a:buNone/>
-            </a:pPr>
-            <a:r>
-              <a:rPr lang="en-US" sz="1200" b="1" dirty="0">
-                <a:solidFill>
-                  <a:srgbClr val="1A7A6E"/>
+                  <a:srgbClr val="C0392B"/>
                 </a:solidFill>
                 <a:latin typeface="Calibri" pitchFamily="34" charset="0"/>
                 <a:ea typeface="Calibri" pitchFamily="34" charset="-122"/>
@@ -6542,7 +6542,7 @@
             <a:r>
               <a:rPr lang="en-US" sz="1200" b="1" dirty="0">
                 <a:solidFill>
-                  <a:srgbClr val="C0392B"/>
+                  <a:srgbClr val="1A7A6E"/>
                 </a:solidFill>
                 <a:latin typeface="Calibri" pitchFamily="34" charset="0"/>
                 <a:ea typeface="Calibri" pitchFamily="34" charset="-122"/>
@@ -6563,6 +6563,84 @@
         <p:spPr>
           <a:xfrm>
             <a:off x="2514600" y="5943600"/>
+            <a:ext cx="2377440" cy="347472"/>
+          </a:xfrm>
+          <a:prstGeom prst="rect">
+            <a:avLst/>
+          </a:prstGeom>
+          <a:noFill/>
+          <a:ln/>
+        </p:spPr>
+        <p:txBody>
+          <a:bodyPr wrap="square" rtlCol="0" anchor="ctr"/>
+          <a:lstStyle/>
+          <a:p>
+            <a:pPr algn="ctr" indent="0" marL="0">
+              <a:buNone/>
+            </a:pPr>
+            <a:r>
+              <a:rPr lang="en-US" sz="1200" b="1" dirty="0">
+                <a:solidFill>
+                  <a:srgbClr val="C0392B"/>
+                </a:solidFill>
+                <a:latin typeface="Calibri" pitchFamily="34" charset="0"/>
+                <a:ea typeface="Calibri" pitchFamily="34" charset="-122"/>
+                <a:cs typeface="Calibri" pitchFamily="34" charset="-120"/>
+              </a:rPr>
+              <a:t>+68.2%</a:t>
+            </a:r>
+            <a:endParaRPr lang="en-US" sz="1200" dirty="0"/>
+          </a:p>
+        </p:txBody>
+      </p:sp>
+      <p:sp>
+        <p:nvSpPr>
+          <p:cNvPr id="17" name="Text 14"/>
+          <p:cNvSpPr/>
+          <p:nvPr/>
+        </p:nvSpPr>
+        <p:spPr>
+          <a:xfrm>
+            <a:off x="4892040" y="5943600"/>
+            <a:ext cx="2377440" cy="347472"/>
+          </a:xfrm>
+          <a:prstGeom prst="rect">
+            <a:avLst/>
+          </a:prstGeom>
+          <a:noFill/>
+          <a:ln/>
+        </p:spPr>
+        <p:txBody>
+          <a:bodyPr wrap="square" rtlCol="0" anchor="ctr"/>
+          <a:lstStyle/>
+          <a:p>
+            <a:pPr algn="ctr" indent="0" marL="0">
+              <a:buNone/>
+            </a:pPr>
+            <a:r>
+              <a:rPr lang="en-US" sz="1200" b="1" dirty="0">
+                <a:solidFill>
+                  <a:srgbClr val="C0392B"/>
+                </a:solidFill>
+                <a:latin typeface="Calibri" pitchFamily="34" charset="0"/>
+                <a:ea typeface="Calibri" pitchFamily="34" charset="-122"/>
+                <a:cs typeface="Calibri" pitchFamily="34" charset="-120"/>
+              </a:rPr>
+              <a:t>+30.4%</a:t>
+            </a:r>
+            <a:endParaRPr lang="en-US" sz="1200" dirty="0"/>
+          </a:p>
+        </p:txBody>
+      </p:sp>
+      <p:sp>
+        <p:nvSpPr>
+          <p:cNvPr id="18" name="Text 15"/>
+          <p:cNvSpPr/>
+          <p:nvPr/>
+        </p:nvSpPr>
+        <p:spPr>
+          <a:xfrm>
+            <a:off x="7269480" y="5943600"/>
             <a:ext cx="2377440" cy="347472"/>
           </a:xfrm>
           <a:prstGeom prst="rect">
@@ -6587,7 +6665,7 @@
                 <a:ea typeface="Calibri" pitchFamily="34" charset="-122"/>
                 <a:cs typeface="Calibri" pitchFamily="34" charset="-120"/>
               </a:rPr>
-              <a:t>+68.2%</a:t>
+              <a:t>-71.4%</a:t>
             </a:r>
             <a:endParaRPr lang="en-US" sz="1200" dirty="0"/>
           </a:p>
@@ -6595,13 +6673,13 @@
       </p:sp>
       <p:sp>
         <p:nvSpPr>
-          <p:cNvPr id="17" name="Text 14"/>
-          <p:cNvSpPr/>
-          <p:nvPr/>
-        </p:nvSpPr>
-        <p:spPr>
-          <a:xfrm>
-            <a:off x="4892040" y="5943600"/>
+          <p:cNvPr id="19" name="Text 16"/>
+          <p:cNvSpPr/>
+          <p:nvPr/>
+        </p:nvSpPr>
+        <p:spPr>
+          <a:xfrm>
+            <a:off x="9646920" y="5943600"/>
             <a:ext cx="2377440" cy="347472"/>
           </a:xfrm>
           <a:prstGeom prst="rect">
@@ -6621,84 +6699,6 @@
               <a:rPr lang="en-US" sz="1200" b="1" dirty="0">
                 <a:solidFill>
                   <a:srgbClr val="1A7A6E"/>
-                </a:solidFill>
-                <a:latin typeface="Calibri" pitchFamily="34" charset="0"/>
-                <a:ea typeface="Calibri" pitchFamily="34" charset="-122"/>
-                <a:cs typeface="Calibri" pitchFamily="34" charset="-120"/>
-              </a:rPr>
-              <a:t>+30.4%</a:t>
-            </a:r>
-            <a:endParaRPr lang="en-US" sz="1200" dirty="0"/>
-          </a:p>
-        </p:txBody>
-      </p:sp>
-      <p:sp>
-        <p:nvSpPr>
-          <p:cNvPr id="18" name="Text 15"/>
-          <p:cNvSpPr/>
-          <p:nvPr/>
-        </p:nvSpPr>
-        <p:spPr>
-          <a:xfrm>
-            <a:off x="7269480" y="5943600"/>
-            <a:ext cx="2377440" cy="347472"/>
-          </a:xfrm>
-          <a:prstGeom prst="rect">
-            <a:avLst/>
-          </a:prstGeom>
-          <a:noFill/>
-          <a:ln/>
-        </p:spPr>
-        <p:txBody>
-          <a:bodyPr wrap="square" rtlCol="0" anchor="ctr"/>
-          <a:lstStyle/>
-          <a:p>
-            <a:pPr algn="ctr" indent="0" marL="0">
-              <a:buNone/>
-            </a:pPr>
-            <a:r>
-              <a:rPr lang="en-US" sz="1200" b="1" dirty="0">
-                <a:solidFill>
-                  <a:srgbClr val="C0392B"/>
-                </a:solidFill>
-                <a:latin typeface="Calibri" pitchFamily="34" charset="0"/>
-                <a:ea typeface="Calibri" pitchFamily="34" charset="-122"/>
-                <a:cs typeface="Calibri" pitchFamily="34" charset="-120"/>
-              </a:rPr>
-              <a:t>-71.4%</a:t>
-            </a:r>
-            <a:endParaRPr lang="en-US" sz="1200" dirty="0"/>
-          </a:p>
-        </p:txBody>
-      </p:sp>
-      <p:sp>
-        <p:nvSpPr>
-          <p:cNvPr id="19" name="Text 16"/>
-          <p:cNvSpPr/>
-          <p:nvPr/>
-        </p:nvSpPr>
-        <p:spPr>
-          <a:xfrm>
-            <a:off x="9646920" y="5943600"/>
-            <a:ext cx="2377440" cy="347472"/>
-          </a:xfrm>
-          <a:prstGeom prst="rect">
-            <a:avLst/>
-          </a:prstGeom>
-          <a:noFill/>
-          <a:ln/>
-        </p:spPr>
-        <p:txBody>
-          <a:bodyPr wrap="square" rtlCol="0" anchor="ctr"/>
-          <a:lstStyle/>
-          <a:p>
-            <a:pPr algn="ctr" indent="0" marL="0">
-              <a:buNone/>
-            </a:pPr>
-            <a:r>
-              <a:rPr lang="en-US" sz="1200" b="1" dirty="0">
-                <a:solidFill>
-                  <a:srgbClr val="C0392B"/>
                 </a:solidFill>
                 <a:latin typeface="Calibri" pitchFamily="34" charset="0"/>
                 <a:ea typeface="Calibri" pitchFamily="34" charset="-122"/>
@@ -7148,7 +7148,7 @@
             <a:r>
               <a:rPr lang="en-US" sz="1200" b="1" dirty="0">
                 <a:solidFill>
-                  <a:srgbClr val="1A7A6E"/>
+                  <a:srgbClr val="C0392B"/>
                 </a:solidFill>
                 <a:latin typeface="Calibri" pitchFamily="34" charset="0"/>
                 <a:ea typeface="Calibri" pitchFamily="34" charset="-122"/>
@@ -7169,6 +7169,45 @@
         <p:spPr>
           <a:xfrm>
             <a:off x="1655064" y="5925312"/>
+            <a:ext cx="1517904" cy="347472"/>
+          </a:xfrm>
+          <a:prstGeom prst="rect">
+            <a:avLst/>
+          </a:prstGeom>
+          <a:noFill/>
+          <a:ln/>
+        </p:spPr>
+        <p:txBody>
+          <a:bodyPr wrap="square" rtlCol="0" anchor="ctr"/>
+          <a:lstStyle/>
+          <a:p>
+            <a:pPr algn="ctr" indent="0" marL="0">
+              <a:buNone/>
+            </a:pPr>
+            <a:r>
+              <a:rPr lang="en-US" sz="1200" b="1" dirty="0">
+                <a:solidFill>
+                  <a:srgbClr val="C0392B"/>
+                </a:solidFill>
+                <a:latin typeface="Calibri" pitchFamily="34" charset="0"/>
+                <a:ea typeface="Calibri" pitchFamily="34" charset="-122"/>
+                <a:cs typeface="Calibri" pitchFamily="34" charset="-120"/>
+              </a:rPr>
+              <a:t>-23.4%</a:t>
+            </a:r>
+            <a:endParaRPr lang="en-US" sz="1200" dirty="0"/>
+          </a:p>
+        </p:txBody>
+      </p:sp>
+      <p:sp>
+        <p:nvSpPr>
+          <p:cNvPr id="17" name="Text 14"/>
+          <p:cNvSpPr/>
+          <p:nvPr/>
+        </p:nvSpPr>
+        <p:spPr>
+          <a:xfrm>
+            <a:off x="3172968" y="5925312"/>
             <a:ext cx="1517904" cy="347472"/>
           </a:xfrm>
           <a:prstGeom prst="rect">
@@ -7193,7 +7232,7 @@
                 <a:ea typeface="Calibri" pitchFamily="34" charset="-122"/>
                 <a:cs typeface="Calibri" pitchFamily="34" charset="-120"/>
               </a:rPr>
-              <a:t>-23.4%</a:t>
+              <a:t>+66.7%</a:t>
             </a:r>
             <a:endParaRPr lang="en-US" sz="1200" dirty="0"/>
           </a:p>
@@ -7201,13 +7240,13 @@
       </p:sp>
       <p:sp>
         <p:nvSpPr>
-          <p:cNvPr id="17" name="Text 14"/>
-          <p:cNvSpPr/>
-          <p:nvPr/>
-        </p:nvSpPr>
-        <p:spPr>
-          <a:xfrm>
-            <a:off x="3172968" y="5925312"/>
+          <p:cNvPr id="18" name="Text 15"/>
+          <p:cNvSpPr/>
+          <p:nvPr/>
+        </p:nvSpPr>
+        <p:spPr>
+          <a:xfrm>
+            <a:off x="4690872" y="5925312"/>
             <a:ext cx="1517904" cy="347472"/>
           </a:xfrm>
           <a:prstGeom prst="rect">
@@ -7232,7 +7271,7 @@
                 <a:ea typeface="Calibri" pitchFamily="34" charset="-122"/>
                 <a:cs typeface="Calibri" pitchFamily="34" charset="-120"/>
               </a:rPr>
-              <a:t>+66.7%</a:t>
+              <a:t>-8.8%</a:t>
             </a:r>
             <a:endParaRPr lang="en-US" sz="1200" dirty="0"/>
           </a:p>
@@ -7240,13 +7279,13 @@
       </p:sp>
       <p:sp>
         <p:nvSpPr>
-          <p:cNvPr id="18" name="Text 15"/>
-          <p:cNvSpPr/>
-          <p:nvPr/>
-        </p:nvSpPr>
-        <p:spPr>
-          <a:xfrm>
-            <a:off x="4690872" y="5925312"/>
+          <p:cNvPr id="19" name="Text 16"/>
+          <p:cNvSpPr/>
+          <p:nvPr/>
+        </p:nvSpPr>
+        <p:spPr>
+          <a:xfrm>
+            <a:off x="6208776" y="5925312"/>
             <a:ext cx="1517904" cy="347472"/>
           </a:xfrm>
           <a:prstGeom prst="rect">
@@ -7266,45 +7305,6 @@
               <a:rPr lang="en-US" sz="1200" b="1" dirty="0">
                 <a:solidFill>
                   <a:srgbClr val="1A7A6E"/>
-                </a:solidFill>
-                <a:latin typeface="Calibri" pitchFamily="34" charset="0"/>
-                <a:ea typeface="Calibri" pitchFamily="34" charset="-122"/>
-                <a:cs typeface="Calibri" pitchFamily="34" charset="-120"/>
-              </a:rPr>
-              <a:t>-8.8%</a:t>
-            </a:r>
-            <a:endParaRPr lang="en-US" sz="1200" dirty="0"/>
-          </a:p>
-        </p:txBody>
-      </p:sp>
-      <p:sp>
-        <p:nvSpPr>
-          <p:cNvPr id="19" name="Text 16"/>
-          <p:cNvSpPr/>
-          <p:nvPr/>
-        </p:nvSpPr>
-        <p:spPr>
-          <a:xfrm>
-            <a:off x="6208776" y="5925312"/>
-            <a:ext cx="1517904" cy="347472"/>
-          </a:xfrm>
-          <a:prstGeom prst="rect">
-            <a:avLst/>
-          </a:prstGeom>
-          <a:noFill/>
-          <a:ln/>
-        </p:spPr>
-        <p:txBody>
-          <a:bodyPr wrap="square" rtlCol="0" anchor="ctr"/>
-          <a:lstStyle/>
-          <a:p>
-            <a:pPr algn="ctr" indent="0" marL="0">
-              <a:buNone/>
-            </a:pPr>
-            <a:r>
-              <a:rPr lang="en-US" sz="1200" b="1" dirty="0">
-                <a:solidFill>
-                  <a:srgbClr val="C0392B"/>
                 </a:solidFill>
                 <a:latin typeface="Calibri" pitchFamily="34" charset="0"/>
                 <a:ea typeface="Calibri" pitchFamily="34" charset="-122"/>
@@ -7676,7 +7676,7 @@
                 <a:ea typeface="Century Gothic" pitchFamily="34" charset="-122"/>
                 <a:cs typeface="Century Gothic" pitchFamily="34" charset="-120"/>
               </a:rPr>
-              <a:t>—</a:t>
+              <a:t>-6.9%</a:t>
             </a:r>
             <a:endParaRPr lang="en-US" sz="2600" dirty="0"/>
           </a:p>
@@ -8271,7 +8271,7 @@
                 <a:ea typeface="Century Gothic" pitchFamily="34" charset="-122"/>
                 <a:cs typeface="Century Gothic" pitchFamily="34" charset="-120"/>
               </a:rPr>
-              <a:t>Change from Prior Month (bps)</a:t>
+              <a:t>Trend vs Prior Month</a:t>
             </a:r>
             <a:endParaRPr lang="en-US" sz="1200" dirty="0"/>
           </a:p>
@@ -8286,6 +8286,45 @@
         <p:spPr>
           <a:xfrm>
             <a:off x="137160" y="5925312"/>
+            <a:ext cx="1517904" cy="347472"/>
+          </a:xfrm>
+          <a:prstGeom prst="rect">
+            <a:avLst/>
+          </a:prstGeom>
+          <a:noFill/>
+          <a:ln/>
+        </p:spPr>
+        <p:txBody>
+          <a:bodyPr wrap="square" rtlCol="0" anchor="ctr"/>
+          <a:lstStyle/>
+          <a:p>
+            <a:pPr algn="ctr" indent="0" marL="0">
+              <a:buNone/>
+            </a:pPr>
+            <a:r>
+              <a:rPr lang="en-US" sz="1200" b="1" dirty="0">
+                <a:solidFill>
+                  <a:srgbClr val="C0392B"/>
+                </a:solidFill>
+                <a:latin typeface="Calibri" pitchFamily="34" charset="0"/>
+                <a:ea typeface="Calibri" pitchFamily="34" charset="-122"/>
+                <a:cs typeface="Calibri" pitchFamily="34" charset="-120"/>
+              </a:rPr>
+              <a:t>↓</a:t>
+            </a:r>
+            <a:endParaRPr lang="en-US" sz="1200" dirty="0"/>
+          </a:p>
+        </p:txBody>
+      </p:sp>
+      <p:sp>
+        <p:nvSpPr>
+          <p:cNvPr id="16" name="Text 13"/>
+          <p:cNvSpPr/>
+          <p:nvPr/>
+        </p:nvSpPr>
+        <p:spPr>
+          <a:xfrm>
+            <a:off x="1655064" y="5925312"/>
             <a:ext cx="1517904" cy="347472"/>
           </a:xfrm>
           <a:prstGeom prst="rect">
@@ -8310,7 +8349,7 @@
                 <a:ea typeface="Calibri" pitchFamily="34" charset="-122"/>
                 <a:cs typeface="Calibri" pitchFamily="34" charset="-120"/>
               </a:rPr>
-              <a:t>-197 bps</a:t>
+              <a:t>↑</a:t>
             </a:r>
             <a:endParaRPr lang="en-US" sz="1200" dirty="0"/>
           </a:p>
@@ -8318,13 +8357,13 @@
       </p:sp>
       <p:sp>
         <p:nvSpPr>
-          <p:cNvPr id="16" name="Text 13"/>
-          <p:cNvSpPr/>
-          <p:nvPr/>
-        </p:nvSpPr>
-        <p:spPr>
-          <a:xfrm>
-            <a:off x="1655064" y="5925312"/>
+          <p:cNvPr id="17" name="Text 14"/>
+          <p:cNvSpPr/>
+          <p:nvPr/>
+        </p:nvSpPr>
+        <p:spPr>
+          <a:xfrm>
+            <a:off x="3172968" y="5925312"/>
             <a:ext cx="1517904" cy="347472"/>
           </a:xfrm>
           <a:prstGeom prst="rect">
@@ -8343,13 +8382,13 @@
             <a:r>
               <a:rPr lang="en-US" sz="1200" b="1" dirty="0">
                 <a:solidFill>
-                  <a:srgbClr val="C0392B"/>
+                  <a:srgbClr val="1A7A6E"/>
                 </a:solidFill>
                 <a:latin typeface="Calibri" pitchFamily="34" charset="0"/>
                 <a:ea typeface="Calibri" pitchFamily="34" charset="-122"/>
                 <a:cs typeface="Calibri" pitchFamily="34" charset="-120"/>
               </a:rPr>
-              <a:t>+421 bps</a:t>
+              <a:t>↑</a:t>
             </a:r>
             <a:endParaRPr lang="en-US" sz="1200" dirty="0"/>
           </a:p>
@@ -8357,13 +8396,13 @@
       </p:sp>
       <p:sp>
         <p:nvSpPr>
-          <p:cNvPr id="17" name="Text 14"/>
-          <p:cNvSpPr/>
-          <p:nvPr/>
-        </p:nvSpPr>
-        <p:spPr>
-          <a:xfrm>
-            <a:off x="3172968" y="5925312"/>
+          <p:cNvPr id="18" name="Text 15"/>
+          <p:cNvSpPr/>
+          <p:nvPr/>
+        </p:nvSpPr>
+        <p:spPr>
+          <a:xfrm>
+            <a:off x="4690872" y="5925312"/>
             <a:ext cx="1517904" cy="347472"/>
           </a:xfrm>
           <a:prstGeom prst="rect">
@@ -8382,13 +8421,13 @@
             <a:r>
               <a:rPr lang="en-US" sz="1200" b="1" dirty="0">
                 <a:solidFill>
-                  <a:srgbClr val="C0392B"/>
+                  <a:srgbClr val="1A7A6E"/>
                 </a:solidFill>
                 <a:latin typeface="Calibri" pitchFamily="34" charset="0"/>
                 <a:ea typeface="Calibri" pitchFamily="34" charset="-122"/>
                 <a:cs typeface="Calibri" pitchFamily="34" charset="-120"/>
               </a:rPr>
-              <a:t>+868 bps</a:t>
+              <a:t>↑</a:t>
             </a:r>
             <a:endParaRPr lang="en-US" sz="1200" dirty="0"/>
           </a:p>
@@ -8396,13 +8435,13 @@
       </p:sp>
       <p:sp>
         <p:nvSpPr>
-          <p:cNvPr id="18" name="Text 15"/>
-          <p:cNvSpPr/>
-          <p:nvPr/>
-        </p:nvSpPr>
-        <p:spPr>
-          <a:xfrm>
-            <a:off x="4690872" y="5925312"/>
+          <p:cNvPr id="19" name="Text 16"/>
+          <p:cNvSpPr/>
+          <p:nvPr/>
+        </p:nvSpPr>
+        <p:spPr>
+          <a:xfrm>
+            <a:off x="6208776" y="5925312"/>
             <a:ext cx="1517904" cy="347472"/>
           </a:xfrm>
           <a:prstGeom prst="rect">
@@ -8421,52 +8460,13 @@
             <a:r>
               <a:rPr lang="en-US" sz="1200" b="1" dirty="0">
                 <a:solidFill>
-                  <a:srgbClr val="C0392B"/>
+                  <a:srgbClr val="1A7A6E"/>
                 </a:solidFill>
                 <a:latin typeface="Calibri" pitchFamily="34" charset="0"/>
                 <a:ea typeface="Calibri" pitchFamily="34" charset="-122"/>
                 <a:cs typeface="Calibri" pitchFamily="34" charset="-120"/>
               </a:rPr>
-              <a:t>+21 bps</a:t>
-            </a:r>
-            <a:endParaRPr lang="en-US" sz="1200" dirty="0"/>
-          </a:p>
-        </p:txBody>
-      </p:sp>
-      <p:sp>
-        <p:nvSpPr>
-          <p:cNvPr id="19" name="Text 16"/>
-          <p:cNvSpPr/>
-          <p:nvPr/>
-        </p:nvSpPr>
-        <p:spPr>
-          <a:xfrm>
-            <a:off x="6208776" y="5925312"/>
-            <a:ext cx="1517904" cy="347472"/>
-          </a:xfrm>
-          <a:prstGeom prst="rect">
-            <a:avLst/>
-          </a:prstGeom>
-          <a:noFill/>
-          <a:ln/>
-        </p:spPr>
-        <p:txBody>
-          <a:bodyPr wrap="square" rtlCol="0" anchor="ctr"/>
-          <a:lstStyle/>
-          <a:p>
-            <a:pPr algn="ctr" indent="0" marL="0">
-              <a:buNone/>
-            </a:pPr>
-            <a:r>
-              <a:rPr lang="en-US" sz="1200" b="1" dirty="0">
-                <a:solidFill>
-                  <a:srgbClr val="C0392B"/>
-                </a:solidFill>
-                <a:latin typeface="Calibri" pitchFamily="34" charset="0"/>
-                <a:ea typeface="Calibri" pitchFamily="34" charset="-122"/>
-                <a:cs typeface="Calibri" pitchFamily="34" charset="-120"/>
-              </a:rPr>
-              <a:t>+145 bps</a:t>
+              <a:t>↑</a:t>
             </a:r>
             <a:endParaRPr lang="en-US" sz="1200" dirty="0"/>
           </a:p>
@@ -8826,13 +8826,13 @@
             <a:r>
               <a:rPr lang="en-US" sz="2600" b="1" dirty="0">
                 <a:solidFill>
-                  <a:srgbClr val="5D300F"/>
+                  <a:srgbClr val="1A7A6E"/>
                 </a:solidFill>
                 <a:latin typeface="Century Gothic" pitchFamily="34" charset="0"/>
                 <a:ea typeface="Century Gothic" pitchFamily="34" charset="-122"/>
                 <a:cs typeface="Century Gothic" pitchFamily="34" charset="-120"/>
               </a:rPr>
-              <a:t>+9215 bps</a:t>
+              <a:t>↑</a:t>
             </a:r>
             <a:endParaRPr lang="en-US" sz="2600" dirty="0"/>
           </a:p>
@@ -8871,7 +8871,7 @@
                 <a:ea typeface="Calibri" pitchFamily="34" charset="-122"/>
                 <a:cs typeface="Calibri" pitchFamily="34" charset="-120"/>
               </a:rPr>
-              <a:t>Change from Prior Month</a:t>
+              <a:t>Trend vs Prior Month</a:t>
             </a:r>
             <a:endParaRPr lang="en-US" sz="1200" dirty="0"/>
           </a:p>
@@ -9460,7 +9460,7 @@
             <a:r>
               <a:rPr lang="en-US" sz="1200" b="1" dirty="0">
                 <a:solidFill>
-                  <a:srgbClr val="1A7A6E"/>
+                  <a:srgbClr val="C0392B"/>
                 </a:solidFill>
                 <a:latin typeface="Calibri" pitchFamily="34" charset="0"/>
                 <a:ea typeface="Calibri" pitchFamily="34" charset="-122"/>
@@ -9499,7 +9499,7 @@
             <a:r>
               <a:rPr lang="en-US" sz="1200" b="1" dirty="0">
                 <a:solidFill>
-                  <a:srgbClr val="C0392B"/>
+                  <a:srgbClr val="1A7A6E"/>
                 </a:solidFill>
                 <a:latin typeface="Calibri" pitchFamily="34" charset="0"/>
                 <a:ea typeface="Calibri" pitchFamily="34" charset="-122"/>
@@ -9538,7 +9538,7 @@
             <a:r>
               <a:rPr lang="en-US" sz="1200" b="1" dirty="0">
                 <a:solidFill>
-                  <a:srgbClr val="C0392B"/>
+                  <a:srgbClr val="1A7A6E"/>
                 </a:solidFill>
                 <a:latin typeface="Calibri" pitchFamily="34" charset="0"/>
                 <a:ea typeface="Calibri" pitchFamily="34" charset="-122"/>
@@ -9577,7 +9577,7 @@
             <a:r>
               <a:rPr lang="en-US" sz="1200" b="1" dirty="0">
                 <a:solidFill>
-                  <a:srgbClr val="C0392B"/>
+                  <a:srgbClr val="1A7A6E"/>
                 </a:solidFill>
                 <a:latin typeface="Calibri" pitchFamily="34" charset="0"/>
                 <a:ea typeface="Calibri" pitchFamily="34" charset="-122"/>
@@ -9616,7 +9616,7 @@
             <a:r>
               <a:rPr lang="en-US" sz="1200" b="1" dirty="0">
                 <a:solidFill>
-                  <a:srgbClr val="C0392B"/>
+                  <a:srgbClr val="1A7A6E"/>
                 </a:solidFill>
                 <a:latin typeface="Calibri" pitchFamily="34" charset="0"/>
                 <a:ea typeface="Calibri" pitchFamily="34" charset="-122"/>
@@ -9853,7 +9853,7 @@
                 <a:ea typeface="Century Gothic" pitchFamily="34" charset="-122"/>
                 <a:cs typeface="Century Gothic" pitchFamily="34" charset="-120"/>
               </a:rPr>
-              <a:t>$11,897</a:t>
+              <a:t>51</a:t>
             </a:r>
             <a:endParaRPr lang="en-US" sz="2600" dirty="0"/>
           </a:p>
@@ -11325,7 +11325,7 @@
             <a:r>
               <a:rPr lang="en-US" sz="1200" b="1" dirty="0">
                 <a:solidFill>
-                  <a:srgbClr val="C0392B"/>
+                  <a:srgbClr val="1A7A6E"/>
                 </a:solidFill>
                 <a:latin typeface="Calibri" pitchFamily="34" charset="0"/>
                 <a:ea typeface="Calibri" pitchFamily="34" charset="-122"/>
@@ -11346,6 +11346,45 @@
         <p:spPr>
           <a:xfrm>
             <a:off x="1298448" y="5925312"/>
+            <a:ext cx="1161288" cy="347472"/>
+          </a:xfrm>
+          <a:prstGeom prst="rect">
+            <a:avLst/>
+          </a:prstGeom>
+          <a:noFill/>
+          <a:ln/>
+        </p:spPr>
+        <p:txBody>
+          <a:bodyPr wrap="square" rtlCol="0" anchor="ctr"/>
+          <a:lstStyle/>
+          <a:p>
+            <a:pPr algn="ctr" indent="0" marL="0">
+              <a:buNone/>
+            </a:pPr>
+            <a:r>
+              <a:rPr lang="en-US" sz="1200" b="1" dirty="0">
+                <a:solidFill>
+                  <a:srgbClr val="1A7A6E"/>
+                </a:solidFill>
+                <a:latin typeface="Calibri" pitchFamily="34" charset="0"/>
+                <a:ea typeface="Calibri" pitchFamily="34" charset="-122"/>
+                <a:cs typeface="Calibri" pitchFamily="34" charset="-120"/>
+              </a:rPr>
+              <a:t>+2.9%</a:t>
+            </a:r>
+            <a:endParaRPr lang="en-US" sz="1200" dirty="0"/>
+          </a:p>
+        </p:txBody>
+      </p:sp>
+      <p:sp>
+        <p:nvSpPr>
+          <p:cNvPr id="21" name="Text 17"/>
+          <p:cNvSpPr/>
+          <p:nvPr/>
+        </p:nvSpPr>
+        <p:spPr>
+          <a:xfrm>
+            <a:off x="2459736" y="5925312"/>
             <a:ext cx="1161288" cy="347472"/>
           </a:xfrm>
           <a:prstGeom prst="rect">
@@ -11370,7 +11409,7 @@
                 <a:ea typeface="Calibri" pitchFamily="34" charset="-122"/>
                 <a:cs typeface="Calibri" pitchFamily="34" charset="-120"/>
               </a:rPr>
-              <a:t>+2.9%</a:t>
+              <a:t>-6.5%</a:t>
             </a:r>
             <a:endParaRPr lang="en-US" sz="1200" dirty="0"/>
           </a:p>
@@ -11378,13 +11417,13 @@
       </p:sp>
       <p:sp>
         <p:nvSpPr>
-          <p:cNvPr id="21" name="Text 17"/>
-          <p:cNvSpPr/>
-          <p:nvPr/>
-        </p:nvSpPr>
-        <p:spPr>
-          <a:xfrm>
-            <a:off x="2459736" y="5925312"/>
+          <p:cNvPr id="22" name="Text 18"/>
+          <p:cNvSpPr/>
+          <p:nvPr/>
+        </p:nvSpPr>
+        <p:spPr>
+          <a:xfrm>
+            <a:off x="3621024" y="5925312"/>
             <a:ext cx="1161288" cy="347472"/>
           </a:xfrm>
           <a:prstGeom prst="rect">
@@ -11409,7 +11448,7 @@
                 <a:ea typeface="Calibri" pitchFamily="34" charset="-122"/>
                 <a:cs typeface="Calibri" pitchFamily="34" charset="-120"/>
               </a:rPr>
-              <a:t>-6.5%</a:t>
+              <a:t>+16.9%</a:t>
             </a:r>
             <a:endParaRPr lang="en-US" sz="1200" dirty="0"/>
           </a:p>
@@ -11417,13 +11456,13 @@
       </p:sp>
       <p:sp>
         <p:nvSpPr>
-          <p:cNvPr id="22" name="Text 18"/>
-          <p:cNvSpPr/>
-          <p:nvPr/>
-        </p:nvSpPr>
-        <p:spPr>
-          <a:xfrm>
-            <a:off x="3621024" y="5925312"/>
+          <p:cNvPr id="23" name="Text 19"/>
+          <p:cNvSpPr/>
+          <p:nvPr/>
+        </p:nvSpPr>
+        <p:spPr>
+          <a:xfrm>
+            <a:off x="4782312" y="5925312"/>
             <a:ext cx="1161288" cy="347472"/>
           </a:xfrm>
           <a:prstGeom prst="rect">
@@ -11443,45 +11482,6 @@
               <a:rPr lang="en-US" sz="1200" b="1" dirty="0">
                 <a:solidFill>
                   <a:srgbClr val="C0392B"/>
-                </a:solidFill>
-                <a:latin typeface="Calibri" pitchFamily="34" charset="0"/>
-                <a:ea typeface="Calibri" pitchFamily="34" charset="-122"/>
-                <a:cs typeface="Calibri" pitchFamily="34" charset="-120"/>
-              </a:rPr>
-              <a:t>+16.9%</a:t>
-            </a:r>
-            <a:endParaRPr lang="en-US" sz="1200" dirty="0"/>
-          </a:p>
-        </p:txBody>
-      </p:sp>
-      <p:sp>
-        <p:nvSpPr>
-          <p:cNvPr id="23" name="Text 19"/>
-          <p:cNvSpPr/>
-          <p:nvPr/>
-        </p:nvSpPr>
-        <p:spPr>
-          <a:xfrm>
-            <a:off x="4782312" y="5925312"/>
-            <a:ext cx="1161288" cy="347472"/>
-          </a:xfrm>
-          <a:prstGeom prst="rect">
-            <a:avLst/>
-          </a:prstGeom>
-          <a:noFill/>
-          <a:ln/>
-        </p:spPr>
-        <p:txBody>
-          <a:bodyPr wrap="square" rtlCol="0" anchor="ctr"/>
-          <a:lstStyle/>
-          <a:p>
-            <a:pPr algn="ctr" indent="0" marL="0">
-              <a:buNone/>
-            </a:pPr>
-            <a:r>
-              <a:rPr lang="en-US" sz="1200" b="1" dirty="0">
-                <a:solidFill>
-                  <a:srgbClr val="1A7A6E"/>
                 </a:solidFill>
                 <a:latin typeface="Calibri" pitchFamily="34" charset="0"/>
                 <a:ea typeface="Calibri" pitchFamily="34" charset="-122"/>
@@ -11609,7 +11609,7 @@
             <a:r>
               <a:rPr lang="en-US" sz="1200" b="1" dirty="0">
                 <a:solidFill>
-                  <a:srgbClr val="1A7A6E"/>
+                  <a:srgbClr val="C0392B"/>
                 </a:solidFill>
                 <a:latin typeface="Calibri" pitchFamily="34" charset="0"/>
                 <a:ea typeface="Calibri" pitchFamily="34" charset="-122"/>
@@ -11630,6 +11630,45 @@
         <p:spPr>
           <a:xfrm>
             <a:off x="7333488" y="5925312"/>
+            <a:ext cx="1161288" cy="347472"/>
+          </a:xfrm>
+          <a:prstGeom prst="rect">
+            <a:avLst/>
+          </a:prstGeom>
+          <a:noFill/>
+          <a:ln/>
+        </p:spPr>
+        <p:txBody>
+          <a:bodyPr wrap="square" rtlCol="0" anchor="ctr"/>
+          <a:lstStyle/>
+          <a:p>
+            <a:pPr algn="ctr" indent="0" marL="0">
+              <a:buNone/>
+            </a:pPr>
+            <a:r>
+              <a:rPr lang="en-US" sz="1200" b="1" dirty="0">
+                <a:solidFill>
+                  <a:srgbClr val="C0392B"/>
+                </a:solidFill>
+                <a:latin typeface="Calibri" pitchFamily="34" charset="0"/>
+                <a:ea typeface="Calibri" pitchFamily="34" charset="-122"/>
+                <a:cs typeface="Calibri" pitchFamily="34" charset="-120"/>
+              </a:rPr>
+              <a:t>-14.9%</a:t>
+            </a:r>
+            <a:endParaRPr lang="en-US" sz="1200" dirty="0"/>
+          </a:p>
+        </p:txBody>
+      </p:sp>
+      <p:sp>
+        <p:nvSpPr>
+          <p:cNvPr id="29" name="Text 25"/>
+          <p:cNvSpPr/>
+          <p:nvPr/>
+        </p:nvSpPr>
+        <p:spPr>
+          <a:xfrm>
+            <a:off x="8494776" y="5925312"/>
             <a:ext cx="1161288" cy="347472"/>
           </a:xfrm>
           <a:prstGeom prst="rect">
@@ -11654,7 +11693,7 @@
                 <a:ea typeface="Calibri" pitchFamily="34" charset="-122"/>
                 <a:cs typeface="Calibri" pitchFamily="34" charset="-120"/>
               </a:rPr>
-              <a:t>-14.9%</a:t>
+              <a:t>+34.1%</a:t>
             </a:r>
             <a:endParaRPr lang="en-US" sz="1200" dirty="0"/>
           </a:p>
@@ -11662,13 +11701,13 @@
       </p:sp>
       <p:sp>
         <p:nvSpPr>
-          <p:cNvPr id="29" name="Text 25"/>
-          <p:cNvSpPr/>
-          <p:nvPr/>
-        </p:nvSpPr>
-        <p:spPr>
-          <a:xfrm>
-            <a:off x="8494776" y="5925312"/>
+          <p:cNvPr id="30" name="Text 26"/>
+          <p:cNvSpPr/>
+          <p:nvPr/>
+        </p:nvSpPr>
+        <p:spPr>
+          <a:xfrm>
+            <a:off x="9656064" y="5925312"/>
             <a:ext cx="1161288" cy="347472"/>
           </a:xfrm>
           <a:prstGeom prst="rect">
@@ -11693,7 +11732,7 @@
                 <a:ea typeface="Calibri" pitchFamily="34" charset="-122"/>
                 <a:cs typeface="Calibri" pitchFamily="34" charset="-120"/>
               </a:rPr>
-              <a:t>+34.1%</a:t>
+              <a:t>-33.3%</a:t>
             </a:r>
             <a:endParaRPr lang="en-US" sz="1200" dirty="0"/>
           </a:p>
@@ -11701,13 +11740,13 @@
       </p:sp>
       <p:sp>
         <p:nvSpPr>
-          <p:cNvPr id="30" name="Text 26"/>
-          <p:cNvSpPr/>
-          <p:nvPr/>
-        </p:nvSpPr>
-        <p:spPr>
-          <a:xfrm>
-            <a:off x="9656064" y="5925312"/>
+          <p:cNvPr id="31" name="Text 27"/>
+          <p:cNvSpPr/>
+          <p:nvPr/>
+        </p:nvSpPr>
+        <p:spPr>
+          <a:xfrm>
+            <a:off x="10817352" y="5925312"/>
             <a:ext cx="1161288" cy="347472"/>
           </a:xfrm>
           <a:prstGeom prst="rect">
@@ -11727,45 +11766,6 @@
               <a:rPr lang="en-US" sz="1200" b="1" dirty="0">
                 <a:solidFill>
                   <a:srgbClr val="1A7A6E"/>
-                </a:solidFill>
-                <a:latin typeface="Calibri" pitchFamily="34" charset="0"/>
-                <a:ea typeface="Calibri" pitchFamily="34" charset="-122"/>
-                <a:cs typeface="Calibri" pitchFamily="34" charset="-120"/>
-              </a:rPr>
-              <a:t>-33.3%</a:t>
-            </a:r>
-            <a:endParaRPr lang="en-US" sz="1200" dirty="0"/>
-          </a:p>
-        </p:txBody>
-      </p:sp>
-      <p:sp>
-        <p:nvSpPr>
-          <p:cNvPr id="31" name="Text 27"/>
-          <p:cNvSpPr/>
-          <p:nvPr/>
-        </p:nvSpPr>
-        <p:spPr>
-          <a:xfrm>
-            <a:off x="10817352" y="5925312"/>
-            <a:ext cx="1161288" cy="347472"/>
-          </a:xfrm>
-          <a:prstGeom prst="rect">
-            <a:avLst/>
-          </a:prstGeom>
-          <a:noFill/>
-          <a:ln/>
-        </p:spPr>
-        <p:txBody>
-          <a:bodyPr wrap="square" rtlCol="0" anchor="ctr"/>
-          <a:lstStyle/>
-          <a:p>
-            <a:pPr algn="ctr" indent="0" marL="0">
-              <a:buNone/>
-            </a:pPr>
-            <a:r>
-              <a:rPr lang="en-US" sz="1200" b="1" dirty="0">
-                <a:solidFill>
-                  <a:srgbClr val="C0392B"/>
                 </a:solidFill>
                 <a:latin typeface="Calibri" pitchFamily="34" charset="0"/>
                 <a:ea typeface="Calibri" pitchFamily="34" charset="-122"/>
@@ -12215,7 +12215,7 @@
             <a:r>
               <a:rPr lang="en-US" sz="1200" b="1" dirty="0">
                 <a:solidFill>
-                  <a:srgbClr val="C0392B"/>
+                  <a:srgbClr val="1A7A6E"/>
                 </a:solidFill>
                 <a:latin typeface="Calibri" pitchFamily="34" charset="0"/>
                 <a:ea typeface="Calibri" pitchFamily="34" charset="-122"/>
@@ -12254,7 +12254,7 @@
             <a:r>
               <a:rPr lang="en-US" sz="1200" b="1" dirty="0">
                 <a:solidFill>
-                  <a:srgbClr val="C0392B"/>
+                  <a:srgbClr val="1A7A6E"/>
                 </a:solidFill>
                 <a:latin typeface="Calibri" pitchFamily="34" charset="0"/>
                 <a:ea typeface="Calibri" pitchFamily="34" charset="-122"/>
@@ -12293,7 +12293,7 @@
             <a:r>
               <a:rPr lang="en-US" sz="1200" b="1" dirty="0">
                 <a:solidFill>
-                  <a:srgbClr val="C0392B"/>
+                  <a:srgbClr val="1A7A6E"/>
                 </a:solidFill>
                 <a:latin typeface="Calibri" pitchFamily="34" charset="0"/>
                 <a:ea typeface="Calibri" pitchFamily="34" charset="-122"/>
@@ -12332,7 +12332,7 @@
             <a:r>
               <a:rPr lang="en-US" sz="1200" b="1" dirty="0">
                 <a:solidFill>
-                  <a:srgbClr val="C0392B"/>
+                  <a:srgbClr val="1A7A6E"/>
                 </a:solidFill>
                 <a:latin typeface="Calibri" pitchFamily="34" charset="0"/>
                 <a:ea typeface="Calibri" pitchFamily="34" charset="-122"/>
@@ -12371,7 +12371,7 @@
             <a:r>
               <a:rPr lang="en-US" sz="1200" b="1" dirty="0">
                 <a:solidFill>
-                  <a:srgbClr val="C0392B"/>
+                  <a:srgbClr val="1A7A6E"/>
                 </a:solidFill>
                 <a:latin typeface="Calibri" pitchFamily="34" charset="0"/>
                 <a:ea typeface="Calibri" pitchFamily="34" charset="-122"/>

</xml_diff>

<commit_message>
Auto-build: 2026-03-13 17:14 UTC
</commit_message>
<xml_diff>
--- a/reports/2026-02.pptx
+++ b/reports/2026-02.pptx
@@ -2062,19 +2062,19 @@
                 <c:formatCode>General</c:formatCode>
                 <c:ptCount val="5"/>
                 <c:pt idx="0">
-                  <c:v>2571</c:v>
+                  <c:v>1285</c:v>
                 </c:pt>
                 <c:pt idx="1">
-                  <c:v>2973</c:v>
+                  <c:v>1486</c:v>
                 </c:pt>
                 <c:pt idx="2">
-                  <c:v>2658</c:v>
+                  <c:v>1329</c:v>
                 </c:pt>
                 <c:pt idx="3">
-                  <c:v>1609</c:v>
+                  <c:v>805</c:v>
                 </c:pt>
                 <c:pt idx="4">
-                  <c:v>725</c:v>
+                  <c:v>363</c:v>
                 </c:pt>
               </c:numCache>
             </c:numRef>
@@ -2362,19 +2362,19 @@
                 <c:formatCode>General</c:formatCode>
                 <c:ptCount val="5"/>
                 <c:pt idx="0">
-                  <c:v>455</c:v>
+                  <c:v>227</c:v>
                 </c:pt>
                 <c:pt idx="1">
-                  <c:v>326</c:v>
+                  <c:v>163</c:v>
                 </c:pt>
                 <c:pt idx="2">
-                  <c:v>199</c:v>
+                  <c:v>99</c:v>
                 </c:pt>
                 <c:pt idx="3">
-                  <c:v>291</c:v>
+                  <c:v>145</c:v>
                 </c:pt>
                 <c:pt idx="4">
-                  <c:v>119</c:v>
+                  <c:v>60</c:v>
                 </c:pt>
               </c:numCache>
             </c:numRef>
@@ -5375,7 +5375,7 @@
                 <a:ea typeface="Calibri" pitchFamily="34" charset="-122"/>
                 <a:cs typeface="Calibri" pitchFamily="34" charset="-120"/>
               </a:rPr>
-              <a:t>+4.8%</a:t>
+              <a:t>+4.7%</a:t>
             </a:r>
             <a:endParaRPr lang="en-US" sz="1200" dirty="0"/>
           </a:p>
@@ -5453,7 +5453,7 @@
                 <a:ea typeface="Calibri" pitchFamily="34" charset="-122"/>
                 <a:cs typeface="Calibri" pitchFamily="34" charset="-120"/>
               </a:rPr>
-              <a:t>+6.1%</a:t>
+              <a:t>+6.2%</a:t>
             </a:r>
             <a:endParaRPr lang="en-US" sz="1200" dirty="0"/>
           </a:p>
@@ -5492,7 +5492,7 @@
                 <a:ea typeface="Calibri" pitchFamily="34" charset="-122"/>
                 <a:cs typeface="Calibri" pitchFamily="34" charset="-120"/>
               </a:rPr>
-              <a:t>+7.2%</a:t>
+              <a:t>+7.4%</a:t>
             </a:r>
             <a:endParaRPr lang="en-US" sz="1200" dirty="0"/>
           </a:p>
@@ -5942,7 +5942,7 @@
                 <a:ea typeface="Calibri" pitchFamily="34" charset="-122"/>
                 <a:cs typeface="Calibri" pitchFamily="34" charset="-120"/>
               </a:rPr>
-              <a:t>-21.0%</a:t>
+              <a:t>-21.2%</a:t>
             </a:r>
             <a:endParaRPr lang="en-US" sz="1200" dirty="0"/>
           </a:p>
@@ -5981,7 +5981,7 @@
                 <a:ea typeface="Calibri" pitchFamily="34" charset="-122"/>
                 <a:cs typeface="Calibri" pitchFamily="34" charset="-120"/>
               </a:rPr>
-              <a:t>-3.8%</a:t>
+              <a:t>-4.1%</a:t>
             </a:r>
             <a:endParaRPr lang="en-US" sz="1200" dirty="0"/>
           </a:p>
@@ -6020,7 +6020,7 @@
                 <a:ea typeface="Calibri" pitchFamily="34" charset="-122"/>
                 <a:cs typeface="Calibri" pitchFamily="34" charset="-120"/>
               </a:rPr>
-              <a:t>+13.7%</a:t>
+              <a:t>+12.5%</a:t>
             </a:r>
             <a:endParaRPr lang="en-US" sz="1200" dirty="0"/>
           </a:p>
@@ -6059,7 +6059,7 @@
                 <a:ea typeface="Calibri" pitchFamily="34" charset="-122"/>
                 <a:cs typeface="Calibri" pitchFamily="34" charset="-120"/>
               </a:rPr>
-              <a:t>+3.2%</a:t>
+              <a:t>+2.8%</a:t>
             </a:r>
             <a:endParaRPr lang="en-US" sz="1200" dirty="0"/>
           </a:p>
@@ -6098,7 +6098,7 @@
                 <a:ea typeface="Calibri" pitchFamily="34" charset="-122"/>
                 <a:cs typeface="Calibri" pitchFamily="34" charset="-120"/>
               </a:rPr>
-              <a:t>+12.3%</a:t>
+              <a:t>+13.2%</a:t>
             </a:r>
             <a:endParaRPr lang="en-US" sz="1200" dirty="0"/>
           </a:p>
@@ -9988,7 +9988,7 @@
                 <a:ea typeface="Century Gothic" pitchFamily="34" charset="-122"/>
                 <a:cs typeface="Century Gothic" pitchFamily="34" charset="-120"/>
               </a:rPr>
-              <a:t>—</a:t>
+              <a:t>+4.1%</a:t>
             </a:r>
             <a:endParaRPr lang="en-US" sz="2600" dirty="0"/>
           </a:p>
@@ -13354,7 +13354,7 @@
                           <a:ea typeface="Century Gothic" pitchFamily="34" charset="-122"/>
                           <a:cs typeface="Century Gothic" pitchFamily="34" charset="-120"/>
                         </a:rPr>
-                        <a:t>Change (bps)</a:t>
+                        <a:t>Trend</a:t>
                       </a:r>
                       <a:endParaRPr lang="en-US" sz="1200" dirty="0">
                         <a:latin typeface="Century Gothic" charset="0"/>
@@ -13628,7 +13628,7 @@
                           <a:ea typeface="Calibri" pitchFamily="34" charset="-122"/>
                           <a:cs typeface="Calibri" pitchFamily="34" charset="-120"/>
                         </a:rPr>
-                        <a:t>+195 bps</a:t>
+                        <a:t>↑</a:t>
                       </a:r>
                       <a:endParaRPr lang="en-US" sz="1200" dirty="0">
                         <a:latin typeface="Calibri" charset="0"/>
@@ -13902,7 +13902,7 @@
                           <a:ea typeface="Calibri" pitchFamily="34" charset="-122"/>
                           <a:cs typeface="Calibri" pitchFamily="34" charset="-120"/>
                         </a:rPr>
-                        <a:t>-57 bps</a:t>
+                        <a:t>↓</a:t>
                       </a:r>
                       <a:endParaRPr lang="en-US" sz="1200" dirty="0">
                         <a:latin typeface="Calibri" charset="0"/>
@@ -14176,7 +14176,7 @@
                           <a:ea typeface="Calibri" pitchFamily="34" charset="-122"/>
                           <a:cs typeface="Calibri" pitchFamily="34" charset="-120"/>
                         </a:rPr>
-                        <a:t>+51 bps</a:t>
+                        <a:t>↑</a:t>
                       </a:r>
                       <a:endParaRPr lang="en-US" sz="1200" dirty="0">
                         <a:latin typeface="Calibri" charset="0"/>
@@ -14450,7 +14450,7 @@
                           <a:ea typeface="Calibri" pitchFamily="34" charset="-122"/>
                           <a:cs typeface="Calibri" pitchFamily="34" charset="-120"/>
                         </a:rPr>
-                        <a:t>-43 bps</a:t>
+                        <a:t>↓</a:t>
                       </a:r>
                       <a:endParaRPr lang="en-US" sz="1200" dirty="0">
                         <a:latin typeface="Calibri" charset="0"/>
@@ -14724,7 +14724,7 @@
                           <a:ea typeface="Calibri" pitchFamily="34" charset="-122"/>
                           <a:cs typeface="Calibri" pitchFamily="34" charset="-120"/>
                         </a:rPr>
-                        <a:t>+184 bps</a:t>
+                        <a:t>↑</a:t>
                       </a:r>
                       <a:endParaRPr lang="en-US" sz="1200" dirty="0">
                         <a:latin typeface="Calibri" charset="0"/>
@@ -14998,7 +14998,7 @@
                           <a:ea typeface="Calibri" pitchFamily="34" charset="-122"/>
                           <a:cs typeface="Calibri" pitchFamily="34" charset="-120"/>
                         </a:rPr>
-                        <a:t>+81 bps</a:t>
+                        <a:t>↑</a:t>
                       </a:r>
                       <a:endParaRPr lang="en-US" sz="1200" dirty="0">
                         <a:latin typeface="Calibri" charset="0"/>
@@ -15610,7 +15610,7 @@
                           <a:ea typeface="Century Gothic" pitchFamily="34" charset="-122"/>
                           <a:cs typeface="Century Gothic" pitchFamily="34" charset="-120"/>
                         </a:rPr>
-                        <a:t>Change (bps)</a:t>
+                        <a:t>Trend</a:t>
                       </a:r>
                       <a:endParaRPr lang="en-US" sz="1200" dirty="0">
                         <a:latin typeface="Century Gothic" charset="0"/>
@@ -15884,7 +15884,7 @@
                           <a:ea typeface="Calibri" pitchFamily="34" charset="-122"/>
                           <a:cs typeface="Calibri" pitchFamily="34" charset="-120"/>
                         </a:rPr>
-                        <a:t>-15 bps</a:t>
+                        <a:t>↓</a:t>
                       </a:r>
                       <a:endParaRPr lang="en-US" sz="1200" dirty="0">
                         <a:latin typeface="Calibri" charset="0"/>
@@ -16158,7 +16158,7 @@
                           <a:ea typeface="Calibri" pitchFamily="34" charset="-122"/>
                           <a:cs typeface="Calibri" pitchFamily="34" charset="-120"/>
                         </a:rPr>
-                        <a:t>+257 bps</a:t>
+                        <a:t>↑</a:t>
                       </a:r>
                       <a:endParaRPr lang="en-US" sz="1200" dirty="0">
                         <a:latin typeface="Calibri" charset="0"/>
@@ -16432,7 +16432,7 @@
                           <a:ea typeface="Calibri" pitchFamily="34" charset="-122"/>
                           <a:cs typeface="Calibri" pitchFamily="34" charset="-120"/>
                         </a:rPr>
-                        <a:t>+139 bps</a:t>
+                        <a:t>↑</a:t>
                       </a:r>
                       <a:endParaRPr lang="en-US" sz="1200" dirty="0">
                         <a:latin typeface="Calibri" charset="0"/>
@@ -16706,7 +16706,7 @@
                           <a:ea typeface="Calibri" pitchFamily="34" charset="-122"/>
                           <a:cs typeface="Calibri" pitchFamily="34" charset="-120"/>
                         </a:rPr>
-                        <a:t>-20 bps</a:t>
+                        <a:t>↓</a:t>
                       </a:r>
                       <a:endParaRPr lang="en-US" sz="1200" dirty="0">
                         <a:latin typeface="Calibri" charset="0"/>
@@ -16980,7 +16980,7 @@
                           <a:ea typeface="Calibri" pitchFamily="34" charset="-122"/>
                           <a:cs typeface="Calibri" pitchFamily="34" charset="-120"/>
                         </a:rPr>
-                        <a:t>+470 bps</a:t>
+                        <a:t>↑</a:t>
                       </a:r>
                       <a:endParaRPr lang="en-US" sz="1200" dirty="0">
                         <a:latin typeface="Calibri" charset="0"/>
@@ -17254,7 +17254,7 @@
                           <a:ea typeface="Calibri" pitchFamily="34" charset="-122"/>
                           <a:cs typeface="Calibri" pitchFamily="34" charset="-120"/>
                         </a:rPr>
-                        <a:t>+103 bps</a:t>
+                        <a:t>↑</a:t>
                       </a:r>
                       <a:endParaRPr lang="en-US" sz="1200" dirty="0">
                         <a:latin typeface="Calibri" charset="0"/>

</xml_diff>

<commit_message>
Auto-build: 2026-03-14 10:19 UTC
</commit_message>
<xml_diff>
--- a/reports/2026-02.pptx
+++ b/reports/2026-02.pptx
@@ -537,13 +537,13 @@
                 <c:ptCount val="5"/>
                 <c:lvl>
                   <c:pt idx="0">
+                    <c:v>Uganda</c:v>
+                  </c:pt>
+                  <c:pt idx="1">
                     <c:v>Tanzania</c:v>
                   </c:pt>
-                  <c:pt idx="1">
+                  <c:pt idx="2">
                     <c:v>Kenya</c:v>
-                  </c:pt>
-                  <c:pt idx="2">
-                    <c:v>Uganda</c:v>
                   </c:pt>
                   <c:pt idx="3">
                     <c:v>Sierra Leone</c:v>
@@ -562,13 +562,13 @@
                 <c:formatCode>General</c:formatCode>
                 <c:ptCount val="5"/>
                 <c:pt idx="0">
+                  <c:v>0.972603</c:v>
+                </c:pt>
+                <c:pt idx="1">
                   <c:v>0.944763</c:v>
                 </c:pt>
-                <c:pt idx="1">
+                <c:pt idx="2">
                   <c:v>0.933149</c:v>
-                </c:pt>
-                <c:pt idx="2">
-                  <c:v>0.972603</c:v>
                 </c:pt>
                 <c:pt idx="3">
                   <c:v>0.833138</c:v>
@@ -843,10 +843,10 @@
                     <c:v>Kenya</c:v>
                   </c:pt>
                   <c:pt idx="2">
-                    <c:v>Uganda</c:v>
+                    <c:v>Sierra Leone</c:v>
                   </c:pt>
                   <c:pt idx="3">
-                    <c:v>Sierra Leone</c:v>
+                    <c:v>Uganda</c:v>
                   </c:pt>
                   <c:pt idx="4">
                     <c:v>Nigeria</c:v>
@@ -868,10 +868,10 @@
                   <c:v>1255542.636</c:v>
                 </c:pt>
                 <c:pt idx="2">
-                  <c:v>349353.9326</c:v>
+                  <c:v>548074.3098</c:v>
                 </c:pt>
                 <c:pt idx="3">
-                  <c:v>548074.3098</c:v>
+                  <c:v>349353.9326</c:v>
                 </c:pt>
                 <c:pt idx="4">
                   <c:v>97814.81481</c:v>
@@ -1143,10 +1143,10 @@
                     <c:v>Kenya</c:v>
                   </c:pt>
                   <c:pt idx="2">
-                    <c:v>Uganda</c:v>
+                    <c:v>Sierra Leone</c:v>
                   </c:pt>
                   <c:pt idx="3">
-                    <c:v>Sierra Leone</c:v>
+                    <c:v>Uganda</c:v>
                   </c:pt>
                   <c:pt idx="4">
                     <c:v>Nigeria</c:v>
@@ -1168,10 +1168,10 @@
                   <c:v>224.64531</c:v>
                 </c:pt>
                 <c:pt idx="2">
-                  <c:v>217.937575</c:v>
+                  <c:v>494.651904</c:v>
                 </c:pt>
                 <c:pt idx="3">
-                  <c:v>494.651904</c:v>
+                  <c:v>217.937575</c:v>
                 </c:pt>
                 <c:pt idx="4">
                   <c:v>171.304404</c:v>
@@ -1443,10 +1443,10 @@
                     <c:v>Kenya</c:v>
                   </c:pt>
                   <c:pt idx="2">
-                    <c:v>Uganda</c:v>
+                    <c:v>Sierra Leone</c:v>
                   </c:pt>
                   <c:pt idx="3">
-                    <c:v>Sierra Leone</c:v>
+                    <c:v>Uganda</c:v>
                   </c:pt>
                   <c:pt idx="4">
                     <c:v>Nigeria</c:v>
@@ -1468,10 +1468,10 @@
                   <c:v>114</c:v>
                 </c:pt>
                 <c:pt idx="2">
-                  <c:v>55</c:v>
+                  <c:v>26</c:v>
                 </c:pt>
                 <c:pt idx="3">
-                  <c:v>26</c:v>
+                  <c:v>55</c:v>
                 </c:pt>
                 <c:pt idx="4">
                   <c:v>41</c:v>
@@ -1743,10 +1743,10 @@
                     <c:v>Kenya</c:v>
                   </c:pt>
                   <c:pt idx="2">
-                    <c:v>Uganda</c:v>
+                    <c:v>Sierra Leone</c:v>
                   </c:pt>
                   <c:pt idx="3">
-                    <c:v>Sierra Leone</c:v>
+                    <c:v>Uganda</c:v>
                   </c:pt>
                   <c:pt idx="4">
                     <c:v>Nigeria</c:v>
@@ -1768,10 +1768,10 @@
                   <c:v>4177694.043</c:v>
                 </c:pt>
                 <c:pt idx="2">
-                  <c:v>1328495.447</c:v>
+                  <c:v>1332374.784</c:v>
                 </c:pt>
                 <c:pt idx="3">
-                  <c:v>1332374.784</c:v>
+                  <c:v>1328495.447</c:v>
                 </c:pt>
                 <c:pt idx="4">
                   <c:v>504260.5</c:v>
@@ -2037,19 +2037,19 @@
                 <c:ptCount val="5"/>
                 <c:lvl>
                   <c:pt idx="0">
+                    <c:v>Nigeria</c:v>
+                  </c:pt>
+                  <c:pt idx="1">
+                    <c:v>Sierra Leone</c:v>
+                  </c:pt>
+                  <c:pt idx="2">
                     <c:v>Tanzania</c:v>
                   </c:pt>
-                  <c:pt idx="1">
-                    <c:v>Kenya</c:v>
-                  </c:pt>
-                  <c:pt idx="2">
+                  <c:pt idx="3">
                     <c:v>Uganda</c:v>
                   </c:pt>
-                  <c:pt idx="3">
-                    <c:v>Sierra Leone</c:v>
-                  </c:pt>
                   <c:pt idx="4">
-                    <c:v>Nigeria</c:v>
+                    <c:v>Kenya</c:v>
                   </c:pt>
                 </c:lvl>
               </c:multiLvlStrCache>
@@ -2062,19 +2062,19 @@
                 <c:formatCode>General</c:formatCode>
                 <c:ptCount val="5"/>
                 <c:pt idx="0">
+                  <c:v>363</c:v>
+                </c:pt>
+                <c:pt idx="1">
+                  <c:v>805</c:v>
+                </c:pt>
+                <c:pt idx="2">
                   <c:v>1285</c:v>
                 </c:pt>
-                <c:pt idx="1">
-                  <c:v>1486</c:v>
-                </c:pt>
-                <c:pt idx="2">
+                <c:pt idx="3">
                   <c:v>1329</c:v>
                 </c:pt>
-                <c:pt idx="3">
-                  <c:v>805</c:v>
-                </c:pt>
                 <c:pt idx="4">
-                  <c:v>363</c:v>
+                  <c:v>1486</c:v>
                 </c:pt>
               </c:numCache>
             </c:numRef>
@@ -2337,19 +2337,19 @@
                 <c:ptCount val="5"/>
                 <c:lvl>
                   <c:pt idx="0">
-                    <c:v>Tanzania</c:v>
+                    <c:v>Nigeria</c:v>
                   </c:pt>
                   <c:pt idx="1">
+                    <c:v>Uganda</c:v>
+                  </c:pt>
+                  <c:pt idx="2">
+                    <c:v>Sierra Leone</c:v>
+                  </c:pt>
+                  <c:pt idx="3">
                     <c:v>Kenya</c:v>
                   </c:pt>
-                  <c:pt idx="2">
-                    <c:v>Uganda</c:v>
-                  </c:pt>
-                  <c:pt idx="3">
-                    <c:v>Sierra Leone</c:v>
-                  </c:pt>
                   <c:pt idx="4">
-                    <c:v>Nigeria</c:v>
+                    <c:v>Tanzania</c:v>
                   </c:pt>
                 </c:lvl>
               </c:multiLvlStrCache>
@@ -2362,19 +2362,19 @@
                 <c:formatCode>General</c:formatCode>
                 <c:ptCount val="5"/>
                 <c:pt idx="0">
-                  <c:v>227</c:v>
+                  <c:v>60</c:v>
                 </c:pt>
                 <c:pt idx="1">
+                  <c:v>99</c:v>
+                </c:pt>
+                <c:pt idx="2">
+                  <c:v>145</c:v>
+                </c:pt>
+                <c:pt idx="3">
                   <c:v>163</c:v>
                 </c:pt>
-                <c:pt idx="2">
-                  <c:v>99</c:v>
-                </c:pt>
-                <c:pt idx="3">
-                  <c:v>145</c:v>
-                </c:pt>
                 <c:pt idx="4">
-                  <c:v>60</c:v>
+                  <c:v>227</c:v>
                 </c:pt>
               </c:numCache>
             </c:numRef>
@@ -2637,16 +2637,16 @@
                 <c:ptCount val="5"/>
                 <c:lvl>
                   <c:pt idx="0">
-                    <c:v>Tanzania</c:v>
+                    <c:v>Sierra Leone</c:v>
                   </c:pt>
                   <c:pt idx="1">
+                    <c:v>Uganda</c:v>
+                  </c:pt>
+                  <c:pt idx="2">
                     <c:v>Kenya</c:v>
                   </c:pt>
-                  <c:pt idx="2">
-                    <c:v>Uganda</c:v>
-                  </c:pt>
                   <c:pt idx="3">
-                    <c:v>Sierra Leone</c:v>
+                    <c:v>Tanzania</c:v>
                   </c:pt>
                   <c:pt idx="4">
                     <c:v>Nigeria</c:v>
@@ -2662,16 +2662,16 @@
                 <c:formatCode>General</c:formatCode>
                 <c:ptCount val="5"/>
                 <c:pt idx="0">
-                  <c:v>43</c:v>
+                  <c:v>6</c:v>
                 </c:pt>
                 <c:pt idx="1">
+                  <c:v>30</c:v>
+                </c:pt>
+                <c:pt idx="2">
                   <c:v>37</c:v>
                 </c:pt>
-                <c:pt idx="2">
-                  <c:v>30</c:v>
-                </c:pt>
                 <c:pt idx="3">
-                  <c:v>6</c:v>
+                  <c:v>43</c:v>
                 </c:pt>
                 <c:pt idx="4">
                   <c:v>49</c:v>
@@ -4847,7 +4847,7 @@
                 <a:ea typeface="Calibri" pitchFamily="34" charset="-122"/>
                 <a:cs typeface="Calibri" pitchFamily="34" charset="-120"/>
               </a:rPr>
-              <a:t>Prepared: March 13, 2026</a:t>
+              <a:t>Prepared: March 14, 2026</a:t>
             </a:r>
             <a:endParaRPr lang="en-US" sz="1200" dirty="0"/>
           </a:p>
@@ -5297,7 +5297,7 @@
                 <a:ea typeface="Century Gothic" pitchFamily="34" charset="-122"/>
                 <a:cs typeface="Century Gothic" pitchFamily="34" charset="-120"/>
               </a:rPr>
-              <a:t>% Change from Prior Month</a:t>
+              <a:t>% Change in Cost per Team vs Prior Month</a:t>
             </a:r>
             <a:endParaRPr lang="en-US" sz="1200" dirty="0"/>
           </a:p>
@@ -5312,6 +5312,84 @@
         <p:spPr>
           <a:xfrm>
             <a:off x="137160" y="5943600"/>
+            <a:ext cx="2377440" cy="347472"/>
+          </a:xfrm>
+          <a:prstGeom prst="rect">
+            <a:avLst/>
+          </a:prstGeom>
+          <a:noFill/>
+          <a:ln/>
+        </p:spPr>
+        <p:txBody>
+          <a:bodyPr wrap="square" rtlCol="0" anchor="ctr"/>
+          <a:lstStyle/>
+          <a:p>
+            <a:pPr algn="ctr" indent="0" marL="0">
+              <a:buNone/>
+            </a:pPr>
+            <a:r>
+              <a:rPr lang="en-US" sz="1200" b="1" dirty="0">
+                <a:solidFill>
+                  <a:srgbClr val="C0392B"/>
+                </a:solidFill>
+                <a:latin typeface="Calibri" pitchFamily="34" charset="0"/>
+                <a:ea typeface="Calibri" pitchFamily="34" charset="-122"/>
+                <a:cs typeface="Calibri" pitchFamily="34" charset="-120"/>
+              </a:rPr>
+              <a:t>+7.4%</a:t>
+            </a:r>
+            <a:endParaRPr lang="en-US" sz="1200" dirty="0"/>
+          </a:p>
+        </p:txBody>
+      </p:sp>
+      <p:sp>
+        <p:nvSpPr>
+          <p:cNvPr id="16" name="Text 13"/>
+          <p:cNvSpPr/>
+          <p:nvPr/>
+        </p:nvSpPr>
+        <p:spPr>
+          <a:xfrm>
+            <a:off x="2514600" y="5943600"/>
+            <a:ext cx="2377440" cy="347472"/>
+          </a:xfrm>
+          <a:prstGeom prst="rect">
+            <a:avLst/>
+          </a:prstGeom>
+          <a:noFill/>
+          <a:ln/>
+        </p:spPr>
+        <p:txBody>
+          <a:bodyPr wrap="square" rtlCol="0" anchor="ctr"/>
+          <a:lstStyle/>
+          <a:p>
+            <a:pPr algn="ctr" indent="0" marL="0">
+              <a:buNone/>
+            </a:pPr>
+            <a:r>
+              <a:rPr lang="en-US" sz="1200" b="1" dirty="0">
+                <a:solidFill>
+                  <a:srgbClr val="C0392B"/>
+                </a:solidFill>
+                <a:latin typeface="Calibri" pitchFamily="34" charset="0"/>
+                <a:ea typeface="Calibri" pitchFamily="34" charset="-122"/>
+                <a:cs typeface="Calibri" pitchFamily="34" charset="-120"/>
+              </a:rPr>
+              <a:t>+6.2%</a:t>
+            </a:r>
+            <a:endParaRPr lang="en-US" sz="1200" dirty="0"/>
+          </a:p>
+        </p:txBody>
+      </p:sp>
+      <p:sp>
+        <p:nvSpPr>
+          <p:cNvPr id="17" name="Text 14"/>
+          <p:cNvSpPr/>
+          <p:nvPr/>
+        </p:nvSpPr>
+        <p:spPr>
+          <a:xfrm>
+            <a:off x="4892040" y="5943600"/>
             <a:ext cx="2377440" cy="347472"/>
           </a:xfrm>
           <a:prstGeom prst="rect">
@@ -5344,52 +5422,13 @@
       </p:sp>
       <p:sp>
         <p:nvSpPr>
-          <p:cNvPr id="16" name="Text 13"/>
-          <p:cNvSpPr/>
-          <p:nvPr/>
-        </p:nvSpPr>
-        <p:spPr>
-          <a:xfrm>
-            <a:off x="2514600" y="5943600"/>
-            <a:ext cx="2377440" cy="347472"/>
-          </a:xfrm>
-          <a:prstGeom prst="rect">
-            <a:avLst/>
-          </a:prstGeom>
-          <a:noFill/>
-          <a:ln/>
-        </p:spPr>
-        <p:txBody>
-          <a:bodyPr wrap="square" rtlCol="0" anchor="ctr"/>
-          <a:lstStyle/>
-          <a:p>
-            <a:pPr algn="ctr" indent="0" marL="0">
-              <a:buNone/>
-            </a:pPr>
-            <a:r>
-              <a:rPr lang="en-US" sz="1200" b="1" dirty="0">
-                <a:solidFill>
-                  <a:srgbClr val="C0392B"/>
-                </a:solidFill>
-                <a:latin typeface="Calibri" pitchFamily="34" charset="0"/>
-                <a:ea typeface="Calibri" pitchFamily="34" charset="-122"/>
-                <a:cs typeface="Calibri" pitchFamily="34" charset="-120"/>
-              </a:rPr>
-              <a:t>+4.7%</a:t>
-            </a:r>
-            <a:endParaRPr lang="en-US" sz="1200" dirty="0"/>
-          </a:p>
-        </p:txBody>
-      </p:sp>
-      <p:sp>
-        <p:nvSpPr>
-          <p:cNvPr id="17" name="Text 14"/>
-          <p:cNvSpPr/>
-          <p:nvPr/>
-        </p:nvSpPr>
-        <p:spPr>
-          <a:xfrm>
-            <a:off x="4892040" y="5943600"/>
+          <p:cNvPr id="18" name="Text 15"/>
+          <p:cNvSpPr/>
+          <p:nvPr/>
+        </p:nvSpPr>
+        <p:spPr>
+          <a:xfrm>
+            <a:off x="7269480" y="5943600"/>
             <a:ext cx="2377440" cy="347472"/>
           </a:xfrm>
           <a:prstGeom prst="rect">
@@ -5422,13 +5461,13 @@
       </p:sp>
       <p:sp>
         <p:nvSpPr>
-          <p:cNvPr id="18" name="Text 15"/>
-          <p:cNvSpPr/>
-          <p:nvPr/>
-        </p:nvSpPr>
-        <p:spPr>
-          <a:xfrm>
-            <a:off x="7269480" y="5943600"/>
+          <p:cNvPr id="19" name="Text 16"/>
+          <p:cNvSpPr/>
+          <p:nvPr/>
+        </p:nvSpPr>
+        <p:spPr>
+          <a:xfrm>
+            <a:off x="9646920" y="5943600"/>
             <a:ext cx="2377440" cy="347472"/>
           </a:xfrm>
           <a:prstGeom prst="rect">
@@ -5453,46 +5492,7 @@
                 <a:ea typeface="Calibri" pitchFamily="34" charset="-122"/>
                 <a:cs typeface="Calibri" pitchFamily="34" charset="-120"/>
               </a:rPr>
-              <a:t>+6.2%</a:t>
-            </a:r>
-            <a:endParaRPr lang="en-US" sz="1200" dirty="0"/>
-          </a:p>
-        </p:txBody>
-      </p:sp>
-      <p:sp>
-        <p:nvSpPr>
-          <p:cNvPr id="19" name="Text 16"/>
-          <p:cNvSpPr/>
-          <p:nvPr/>
-        </p:nvSpPr>
-        <p:spPr>
-          <a:xfrm>
-            <a:off x="9646920" y="5943600"/>
-            <a:ext cx="2377440" cy="347472"/>
-          </a:xfrm>
-          <a:prstGeom prst="rect">
-            <a:avLst/>
-          </a:prstGeom>
-          <a:noFill/>
-          <a:ln/>
-        </p:spPr>
-        <p:txBody>
-          <a:bodyPr wrap="square" rtlCol="0" anchor="ctr"/>
-          <a:lstStyle/>
-          <a:p>
-            <a:pPr algn="ctr" indent="0" marL="0">
-              <a:buNone/>
-            </a:pPr>
-            <a:r>
-              <a:rPr lang="en-US" sz="1200" b="1" dirty="0">
-                <a:solidFill>
-                  <a:srgbClr val="C0392B"/>
-                </a:solidFill>
-                <a:latin typeface="Calibri" pitchFamily="34" charset="0"/>
-                <a:ea typeface="Calibri" pitchFamily="34" charset="-122"/>
-                <a:cs typeface="Calibri" pitchFamily="34" charset="-120"/>
-              </a:rPr>
-              <a:t>+7.4%</a:t>
+              <a:t>+4.7%</a:t>
             </a:r>
             <a:endParaRPr lang="en-US" sz="1200" dirty="0"/>
           </a:p>
@@ -5812,7 +5812,7 @@
         </p:nvGraphicFramePr>
         <p:xfrm>
           <a:off x="137160" y="841248"/>
-          <a:ext cx="11887200" cy="4754880"/>
+          <a:ext cx="11887200" cy="4297680"/>
         </p:xfrm>
         <a:graphic xmlns:a="http://schemas.openxmlformats.org/drawingml/2006/main">
           <a:graphicData uri="http://schemas.openxmlformats.org/drawingml/2006/chart">
@@ -5828,7 +5828,7 @@
         </p:nvSpPr>
         <p:spPr>
           <a:xfrm>
-            <a:off x="0" y="5641848"/>
+            <a:off x="0" y="5184648"/>
             <a:ext cx="12161520" cy="292608"/>
           </a:xfrm>
           <a:prstGeom prst="rect">
@@ -5853,7 +5853,7 @@
         </p:nvSpPr>
         <p:spPr>
           <a:xfrm>
-            <a:off x="0" y="5641848"/>
+            <a:off x="0" y="5184648"/>
             <a:ext cx="54864" cy="292608"/>
           </a:xfrm>
           <a:prstGeom prst="rect">
@@ -5878,7 +5878,7 @@
         </p:nvSpPr>
         <p:spPr>
           <a:xfrm>
-            <a:off x="109728" y="5641848"/>
+            <a:off x="109728" y="5184648"/>
             <a:ext cx="12051792" cy="292608"/>
           </a:xfrm>
           <a:prstGeom prst="rect">
@@ -5903,7 +5903,7 @@
                 <a:ea typeface="Century Gothic" pitchFamily="34" charset="-122"/>
                 <a:cs typeface="Century Gothic" pitchFamily="34" charset="-120"/>
               </a:rPr>
-              <a:t>% Change from Prior Month</a:t>
+              <a:t>% Change in Cost per Team vs Prior Month</a:t>
             </a:r>
             <a:endParaRPr lang="en-US" sz="1200" dirty="0"/>
           </a:p>
@@ -5917,7 +5917,163 @@
         </p:nvSpPr>
         <p:spPr>
           <a:xfrm>
-            <a:off x="137160" y="5943600"/>
+            <a:off x="137160" y="5486400"/>
+            <a:ext cx="2377440" cy="347472"/>
+          </a:xfrm>
+          <a:prstGeom prst="rect">
+            <a:avLst/>
+          </a:prstGeom>
+          <a:noFill/>
+          <a:ln/>
+        </p:spPr>
+        <p:txBody>
+          <a:bodyPr wrap="square" rtlCol="0" anchor="ctr"/>
+          <a:lstStyle/>
+          <a:p>
+            <a:pPr algn="ctr" indent="0" marL="0">
+              <a:buNone/>
+            </a:pPr>
+            <a:r>
+              <a:rPr lang="en-US" sz="1200" b="1" dirty="0">
+                <a:solidFill>
+                  <a:srgbClr val="C0392B"/>
+                </a:solidFill>
+                <a:latin typeface="Calibri" pitchFamily="34" charset="0"/>
+                <a:ea typeface="Calibri" pitchFamily="34" charset="-122"/>
+                <a:cs typeface="Calibri" pitchFamily="34" charset="-120"/>
+              </a:rPr>
+              <a:t>+13.2%</a:t>
+            </a:r>
+            <a:endParaRPr lang="en-US" sz="1200" dirty="0"/>
+          </a:p>
+        </p:txBody>
+      </p:sp>
+      <p:sp>
+        <p:nvSpPr>
+          <p:cNvPr id="16" name="Text 13"/>
+          <p:cNvSpPr/>
+          <p:nvPr/>
+        </p:nvSpPr>
+        <p:spPr>
+          <a:xfrm>
+            <a:off x="2514600" y="5486400"/>
+            <a:ext cx="2377440" cy="347472"/>
+          </a:xfrm>
+          <a:prstGeom prst="rect">
+            <a:avLst/>
+          </a:prstGeom>
+          <a:noFill/>
+          <a:ln/>
+        </p:spPr>
+        <p:txBody>
+          <a:bodyPr wrap="square" rtlCol="0" anchor="ctr"/>
+          <a:lstStyle/>
+          <a:p>
+            <a:pPr algn="ctr" indent="0" marL="0">
+              <a:buNone/>
+            </a:pPr>
+            <a:r>
+              <a:rPr lang="en-US" sz="1200" b="1" dirty="0">
+                <a:solidFill>
+                  <a:srgbClr val="C0392B"/>
+                </a:solidFill>
+                <a:latin typeface="Calibri" pitchFamily="34" charset="0"/>
+                <a:ea typeface="Calibri" pitchFamily="34" charset="-122"/>
+                <a:cs typeface="Calibri" pitchFamily="34" charset="-120"/>
+              </a:rPr>
+              <a:t>+12.5%</a:t>
+            </a:r>
+            <a:endParaRPr lang="en-US" sz="1200" dirty="0"/>
+          </a:p>
+        </p:txBody>
+      </p:sp>
+      <p:sp>
+        <p:nvSpPr>
+          <p:cNvPr id="17" name="Text 14"/>
+          <p:cNvSpPr/>
+          <p:nvPr/>
+        </p:nvSpPr>
+        <p:spPr>
+          <a:xfrm>
+            <a:off x="4892040" y="5486400"/>
+            <a:ext cx="2377440" cy="347472"/>
+          </a:xfrm>
+          <a:prstGeom prst="rect">
+            <a:avLst/>
+          </a:prstGeom>
+          <a:noFill/>
+          <a:ln/>
+        </p:spPr>
+        <p:txBody>
+          <a:bodyPr wrap="square" rtlCol="0" anchor="ctr"/>
+          <a:lstStyle/>
+          <a:p>
+            <a:pPr algn="ctr" indent="0" marL="0">
+              <a:buNone/>
+            </a:pPr>
+            <a:r>
+              <a:rPr lang="en-US" sz="1200" b="1" dirty="0">
+                <a:solidFill>
+                  <a:srgbClr val="C0392B"/>
+                </a:solidFill>
+                <a:latin typeface="Calibri" pitchFamily="34" charset="0"/>
+                <a:ea typeface="Calibri" pitchFamily="34" charset="-122"/>
+                <a:cs typeface="Calibri" pitchFamily="34" charset="-120"/>
+              </a:rPr>
+              <a:t>+2.8%</a:t>
+            </a:r>
+            <a:endParaRPr lang="en-US" sz="1200" dirty="0"/>
+          </a:p>
+        </p:txBody>
+      </p:sp>
+      <p:sp>
+        <p:nvSpPr>
+          <p:cNvPr id="18" name="Text 15"/>
+          <p:cNvSpPr/>
+          <p:nvPr/>
+        </p:nvSpPr>
+        <p:spPr>
+          <a:xfrm>
+            <a:off x="7269480" y="5486400"/>
+            <a:ext cx="2377440" cy="347472"/>
+          </a:xfrm>
+          <a:prstGeom prst="rect">
+            <a:avLst/>
+          </a:prstGeom>
+          <a:noFill/>
+          <a:ln/>
+        </p:spPr>
+        <p:txBody>
+          <a:bodyPr wrap="square" rtlCol="0" anchor="ctr"/>
+          <a:lstStyle/>
+          <a:p>
+            <a:pPr algn="ctr" indent="0" marL="0">
+              <a:buNone/>
+            </a:pPr>
+            <a:r>
+              <a:rPr lang="en-US" sz="1200" b="1" dirty="0">
+                <a:solidFill>
+                  <a:srgbClr val="1A7A6E"/>
+                </a:solidFill>
+                <a:latin typeface="Calibri" pitchFamily="34" charset="0"/>
+                <a:ea typeface="Calibri" pitchFamily="34" charset="-122"/>
+                <a:cs typeface="Calibri" pitchFamily="34" charset="-120"/>
+              </a:rPr>
+              <a:t>-4.1%</a:t>
+            </a:r>
+            <a:endParaRPr lang="en-US" sz="1200" dirty="0"/>
+          </a:p>
+        </p:txBody>
+      </p:sp>
+      <p:sp>
+        <p:nvSpPr>
+          <p:cNvPr id="19" name="Text 16"/>
+          <p:cNvSpPr/>
+          <p:nvPr/>
+        </p:nvSpPr>
+        <p:spPr>
+          <a:xfrm>
+            <a:off x="9646920" y="5486400"/>
             <a:ext cx="2377440" cy="347472"/>
           </a:xfrm>
           <a:prstGeom prst="rect">
@@ -5950,13 +6106,102 @@
       </p:sp>
       <p:sp>
         <p:nvSpPr>
-          <p:cNvPr id="16" name="Text 13"/>
-          <p:cNvSpPr/>
-          <p:nvPr/>
-        </p:nvSpPr>
-        <p:spPr>
-          <a:xfrm>
-            <a:off x="2514600" y="5943600"/>
+          <p:cNvPr id="20" name="Shape 17"/>
+          <p:cNvSpPr/>
+          <p:nvPr/>
+        </p:nvSpPr>
+        <p:spPr>
+          <a:xfrm>
+            <a:off x="0" y="5897880"/>
+            <a:ext cx="12161520" cy="292608"/>
+          </a:xfrm>
+          <a:prstGeom prst="rect">
+            <a:avLst/>
+          </a:prstGeom>
+          <a:solidFill>
+            <a:srgbClr val="FFF9D9"/>
+          </a:solidFill>
+          <a:ln w="12700">
+            <a:solidFill>
+              <a:srgbClr val="F0E0B8"/>
+            </a:solidFill>
+            <a:prstDash val="solid"/>
+          </a:ln>
+        </p:spPr>
+      </p:sp>
+      <p:sp>
+        <p:nvSpPr>
+          <p:cNvPr id="21" name="Shape 18"/>
+          <p:cNvSpPr/>
+          <p:nvPr/>
+        </p:nvSpPr>
+        <p:spPr>
+          <a:xfrm>
+            <a:off x="0" y="5897880"/>
+            <a:ext cx="54864" cy="292608"/>
+          </a:xfrm>
+          <a:prstGeom prst="rect">
+            <a:avLst/>
+          </a:prstGeom>
+          <a:solidFill>
+            <a:srgbClr val="5D300F"/>
+          </a:solidFill>
+          <a:ln w="12700">
+            <a:solidFill>
+              <a:srgbClr val="5D300F"/>
+            </a:solidFill>
+            <a:prstDash val="solid"/>
+          </a:ln>
+        </p:spPr>
+      </p:sp>
+      <p:sp>
+        <p:nvSpPr>
+          <p:cNvPr id="22" name="Text 19"/>
+          <p:cNvSpPr/>
+          <p:nvPr/>
+        </p:nvSpPr>
+        <p:spPr>
+          <a:xfrm>
+            <a:off x="109728" y="5897880"/>
+            <a:ext cx="12051792" cy="292608"/>
+          </a:xfrm>
+          <a:prstGeom prst="rect">
+            <a:avLst/>
+          </a:prstGeom>
+          <a:noFill/>
+          <a:ln/>
+        </p:spPr>
+        <p:txBody>
+          <a:bodyPr wrap="square" lIns="0" tIns="0" rIns="0" bIns="0" rtlCol="0" anchor="ctr"/>
+          <a:lstStyle/>
+          <a:p>
+            <a:pPr indent="0" marL="0">
+              <a:buNone/>
+            </a:pPr>
+            <a:r>
+              <a:rPr lang="en-US" sz="1200" b="1" dirty="0">
+                <a:solidFill>
+                  <a:srgbClr val="5D300F"/>
+                </a:solidFill>
+                <a:latin typeface="Century Gothic" pitchFamily="34" charset="0"/>
+                <a:ea typeface="Century Gothic" pitchFamily="34" charset="-122"/>
+                <a:cs typeface="Century Gothic" pitchFamily="34" charset="-120"/>
+              </a:rPr>
+              <a:t>% Change in Disb per Team vs Prior Month</a:t>
+            </a:r>
+            <a:endParaRPr lang="en-US" sz="1200" dirty="0"/>
+          </a:p>
+        </p:txBody>
+      </p:sp>
+      <p:sp>
+        <p:nvSpPr>
+          <p:cNvPr id="23" name="Text 20"/>
+          <p:cNvSpPr/>
+          <p:nvPr/>
+        </p:nvSpPr>
+        <p:spPr>
+          <a:xfrm>
+            <a:off x="137160" y="6199632"/>
             <a:ext cx="2377440" cy="347472"/>
           </a:xfrm>
           <a:prstGeom prst="rect">
@@ -5981,7 +6226,7 @@
                 <a:ea typeface="Calibri" pitchFamily="34" charset="-122"/>
                 <a:cs typeface="Calibri" pitchFamily="34" charset="-120"/>
               </a:rPr>
-              <a:t>-4.1%</a:t>
+              <a:t>+78.3%</a:t>
             </a:r>
             <a:endParaRPr lang="en-US" sz="1200" dirty="0"/>
           </a:p>
@@ -5989,13 +6234,52 @@
       </p:sp>
       <p:sp>
         <p:nvSpPr>
-          <p:cNvPr id="17" name="Text 14"/>
-          <p:cNvSpPr/>
-          <p:nvPr/>
-        </p:nvSpPr>
-        <p:spPr>
-          <a:xfrm>
-            <a:off x="4892040" y="5943600"/>
+          <p:cNvPr id="24" name="Text 21"/>
+          <p:cNvSpPr/>
+          <p:nvPr/>
+        </p:nvSpPr>
+        <p:spPr>
+          <a:xfrm>
+            <a:off x="2514600" y="6199632"/>
+            <a:ext cx="2377440" cy="347472"/>
+          </a:xfrm>
+          <a:prstGeom prst="rect">
+            <a:avLst/>
+          </a:prstGeom>
+          <a:noFill/>
+          <a:ln/>
+        </p:spPr>
+        <p:txBody>
+          <a:bodyPr wrap="square" rtlCol="0" anchor="ctr"/>
+          <a:lstStyle/>
+          <a:p>
+            <a:pPr algn="ctr" indent="0" marL="0">
+              <a:buNone/>
+            </a:pPr>
+            <a:r>
+              <a:rPr lang="en-US" sz="1200" b="1" dirty="0">
+                <a:solidFill>
+                  <a:srgbClr val="1A7A6E"/>
+                </a:solidFill>
+                <a:latin typeface="Calibri" pitchFamily="34" charset="0"/>
+                <a:ea typeface="Calibri" pitchFamily="34" charset="-122"/>
+                <a:cs typeface="Calibri" pitchFamily="34" charset="-120"/>
+              </a:rPr>
+              <a:t>+34.1%</a:t>
+            </a:r>
+            <a:endParaRPr lang="en-US" sz="1200" dirty="0"/>
+          </a:p>
+        </p:txBody>
+      </p:sp>
+      <p:sp>
+        <p:nvSpPr>
+          <p:cNvPr id="25" name="Text 22"/>
+          <p:cNvSpPr/>
+          <p:nvPr/>
+        </p:nvSpPr>
+        <p:spPr>
+          <a:xfrm>
+            <a:off x="4892040" y="6199632"/>
             <a:ext cx="2377440" cy="347472"/>
           </a:xfrm>
           <a:prstGeom prst="rect">
@@ -6020,7 +6304,7 @@
                 <a:ea typeface="Calibri" pitchFamily="34" charset="-122"/>
                 <a:cs typeface="Calibri" pitchFamily="34" charset="-120"/>
               </a:rPr>
-              <a:t>+12.5%</a:t>
+              <a:t>-33.3%</a:t>
             </a:r>
             <a:endParaRPr lang="en-US" sz="1200" dirty="0"/>
           </a:p>
@@ -6028,13 +6312,13 @@
       </p:sp>
       <p:sp>
         <p:nvSpPr>
-          <p:cNvPr id="18" name="Text 15"/>
-          <p:cNvSpPr/>
-          <p:nvPr/>
-        </p:nvSpPr>
-        <p:spPr>
-          <a:xfrm>
-            <a:off x="7269480" y="5943600"/>
+          <p:cNvPr id="26" name="Text 23"/>
+          <p:cNvSpPr/>
+          <p:nvPr/>
+        </p:nvSpPr>
+        <p:spPr>
+          <a:xfrm>
+            <a:off x="7269480" y="6199632"/>
             <a:ext cx="2377440" cy="347472"/>
           </a:xfrm>
           <a:prstGeom prst="rect">
@@ -6059,7 +6343,7 @@
                 <a:ea typeface="Calibri" pitchFamily="34" charset="-122"/>
                 <a:cs typeface="Calibri" pitchFamily="34" charset="-120"/>
               </a:rPr>
-              <a:t>+2.8%</a:t>
+              <a:t>-14.9%</a:t>
             </a:r>
             <a:endParaRPr lang="en-US" sz="1200" dirty="0"/>
           </a:p>
@@ -6067,13 +6351,13 @@
       </p:sp>
       <p:sp>
         <p:nvSpPr>
-          <p:cNvPr id="19" name="Text 16"/>
-          <p:cNvSpPr/>
-          <p:nvPr/>
-        </p:nvSpPr>
-        <p:spPr>
-          <a:xfrm>
-            <a:off x="9646920" y="5943600"/>
+          <p:cNvPr id="27" name="Text 24"/>
+          <p:cNvSpPr/>
+          <p:nvPr/>
+        </p:nvSpPr>
+        <p:spPr>
+          <a:xfrm>
+            <a:off x="9646920" y="6199632"/>
             <a:ext cx="2377440" cy="347472"/>
           </a:xfrm>
           <a:prstGeom prst="rect">
@@ -6098,7 +6382,7 @@
                 <a:ea typeface="Calibri" pitchFamily="34" charset="-122"/>
                 <a:cs typeface="Calibri" pitchFamily="34" charset="-120"/>
               </a:rPr>
-              <a:t>+13.2%</a:t>
+              <a:t>-40.2%</a:t>
             </a:r>
             <a:endParaRPr lang="en-US" sz="1200" dirty="0"/>
           </a:p>
@@ -6418,7 +6702,7 @@
         </p:nvGraphicFramePr>
         <p:xfrm>
           <a:off x="137160" y="841248"/>
-          <a:ext cx="11887200" cy="4754880"/>
+          <a:ext cx="11887200" cy="4297680"/>
         </p:xfrm>
         <a:graphic xmlns:a="http://schemas.openxmlformats.org/drawingml/2006/main">
           <a:graphicData uri="http://schemas.openxmlformats.org/drawingml/2006/chart">
@@ -6434,7 +6718,7 @@
         </p:nvSpPr>
         <p:spPr>
           <a:xfrm>
-            <a:off x="0" y="5641848"/>
+            <a:off x="0" y="5184648"/>
             <a:ext cx="12161520" cy="292608"/>
           </a:xfrm>
           <a:prstGeom prst="rect">
@@ -6459,7 +6743,7 @@
         </p:nvSpPr>
         <p:spPr>
           <a:xfrm>
-            <a:off x="0" y="5641848"/>
+            <a:off x="0" y="5184648"/>
             <a:ext cx="54864" cy="292608"/>
           </a:xfrm>
           <a:prstGeom prst="rect">
@@ -6484,7 +6768,7 @@
         </p:nvSpPr>
         <p:spPr>
           <a:xfrm>
-            <a:off x="109728" y="5641848"/>
+            <a:off x="109728" y="5184648"/>
             <a:ext cx="12051792" cy="292608"/>
           </a:xfrm>
           <a:prstGeom prst="rect">
@@ -6509,7 +6793,7 @@
                 <a:ea typeface="Century Gothic" pitchFamily="34" charset="-122"/>
                 <a:cs typeface="Century Gothic" pitchFamily="34" charset="-120"/>
               </a:rPr>
-              <a:t>% Change from Prior Month</a:t>
+              <a:t>% Change in Cost per Team vs Prior Month</a:t>
             </a:r>
             <a:endParaRPr lang="en-US" sz="1200" dirty="0"/>
           </a:p>
@@ -6523,7 +6807,124 @@
         </p:nvSpPr>
         <p:spPr>
           <a:xfrm>
-            <a:off x="137160" y="5943600"/>
+            <a:off x="137160" y="5486400"/>
+            <a:ext cx="2377440" cy="347472"/>
+          </a:xfrm>
+          <a:prstGeom prst="rect">
+            <a:avLst/>
+          </a:prstGeom>
+          <a:noFill/>
+          <a:ln/>
+        </p:spPr>
+        <p:txBody>
+          <a:bodyPr wrap="square" rtlCol="0" anchor="ctr"/>
+          <a:lstStyle/>
+          <a:p>
+            <a:pPr algn="ctr" indent="0" marL="0">
+              <a:buNone/>
+            </a:pPr>
+            <a:r>
+              <a:rPr lang="en-US" sz="1200" b="1" dirty="0">
+                <a:solidFill>
+                  <a:srgbClr val="1A7A6E"/>
+                </a:solidFill>
+                <a:latin typeface="Calibri" pitchFamily="34" charset="0"/>
+                <a:ea typeface="Calibri" pitchFamily="34" charset="-122"/>
+                <a:cs typeface="Calibri" pitchFamily="34" charset="-120"/>
+              </a:rPr>
+              <a:t>-71.4%</a:t>
+            </a:r>
+            <a:endParaRPr lang="en-US" sz="1200" dirty="0"/>
+          </a:p>
+        </p:txBody>
+      </p:sp>
+      <p:sp>
+        <p:nvSpPr>
+          <p:cNvPr id="16" name="Text 13"/>
+          <p:cNvSpPr/>
+          <p:nvPr/>
+        </p:nvSpPr>
+        <p:spPr>
+          <a:xfrm>
+            <a:off x="2514600" y="5486400"/>
+            <a:ext cx="2377440" cy="347472"/>
+          </a:xfrm>
+          <a:prstGeom prst="rect">
+            <a:avLst/>
+          </a:prstGeom>
+          <a:noFill/>
+          <a:ln/>
+        </p:spPr>
+        <p:txBody>
+          <a:bodyPr wrap="square" rtlCol="0" anchor="ctr"/>
+          <a:lstStyle/>
+          <a:p>
+            <a:pPr algn="ctr" indent="0" marL="0">
+              <a:buNone/>
+            </a:pPr>
+            <a:r>
+              <a:rPr lang="en-US" sz="1200" b="1" dirty="0">
+                <a:solidFill>
+                  <a:srgbClr val="C0392B"/>
+                </a:solidFill>
+                <a:latin typeface="Calibri" pitchFamily="34" charset="0"/>
+                <a:ea typeface="Calibri" pitchFamily="34" charset="-122"/>
+                <a:cs typeface="Calibri" pitchFamily="34" charset="-120"/>
+              </a:rPr>
+              <a:t>+30.4%</a:t>
+            </a:r>
+            <a:endParaRPr lang="en-US" sz="1200" dirty="0"/>
+          </a:p>
+        </p:txBody>
+      </p:sp>
+      <p:sp>
+        <p:nvSpPr>
+          <p:cNvPr id="17" name="Text 14"/>
+          <p:cNvSpPr/>
+          <p:nvPr/>
+        </p:nvSpPr>
+        <p:spPr>
+          <a:xfrm>
+            <a:off x="4892040" y="5486400"/>
+            <a:ext cx="2377440" cy="347472"/>
+          </a:xfrm>
+          <a:prstGeom prst="rect">
+            <a:avLst/>
+          </a:prstGeom>
+          <a:noFill/>
+          <a:ln/>
+        </p:spPr>
+        <p:txBody>
+          <a:bodyPr wrap="square" rtlCol="0" anchor="ctr"/>
+          <a:lstStyle/>
+          <a:p>
+            <a:pPr algn="ctr" indent="0" marL="0">
+              <a:buNone/>
+            </a:pPr>
+            <a:r>
+              <a:rPr lang="en-US" sz="1200" b="1" dirty="0">
+                <a:solidFill>
+                  <a:srgbClr val="C0392B"/>
+                </a:solidFill>
+                <a:latin typeface="Calibri" pitchFamily="34" charset="0"/>
+                <a:ea typeface="Calibri" pitchFamily="34" charset="-122"/>
+                <a:cs typeface="Calibri" pitchFamily="34" charset="-120"/>
+              </a:rPr>
+              <a:t>+68.2%</a:t>
+            </a:r>
+            <a:endParaRPr lang="en-US" sz="1200" dirty="0"/>
+          </a:p>
+        </p:txBody>
+      </p:sp>
+      <p:sp>
+        <p:nvSpPr>
+          <p:cNvPr id="18" name="Text 15"/>
+          <p:cNvSpPr/>
+          <p:nvPr/>
+        </p:nvSpPr>
+        <p:spPr>
+          <a:xfrm>
+            <a:off x="7269480" y="5486400"/>
             <a:ext cx="2377440" cy="347472"/>
           </a:xfrm>
           <a:prstGeom prst="rect">
@@ -6556,130 +6957,13 @@
       </p:sp>
       <p:sp>
         <p:nvSpPr>
-          <p:cNvPr id="16" name="Text 13"/>
-          <p:cNvSpPr/>
-          <p:nvPr/>
-        </p:nvSpPr>
-        <p:spPr>
-          <a:xfrm>
-            <a:off x="2514600" y="5943600"/>
-            <a:ext cx="2377440" cy="347472"/>
-          </a:xfrm>
-          <a:prstGeom prst="rect">
-            <a:avLst/>
-          </a:prstGeom>
-          <a:noFill/>
-          <a:ln/>
-        </p:spPr>
-        <p:txBody>
-          <a:bodyPr wrap="square" rtlCol="0" anchor="ctr"/>
-          <a:lstStyle/>
-          <a:p>
-            <a:pPr algn="ctr" indent="0" marL="0">
-              <a:buNone/>
-            </a:pPr>
-            <a:r>
-              <a:rPr lang="en-US" sz="1200" b="1" dirty="0">
-                <a:solidFill>
-                  <a:srgbClr val="C0392B"/>
-                </a:solidFill>
-                <a:latin typeface="Calibri" pitchFamily="34" charset="0"/>
-                <a:ea typeface="Calibri" pitchFamily="34" charset="-122"/>
-                <a:cs typeface="Calibri" pitchFamily="34" charset="-120"/>
-              </a:rPr>
-              <a:t>+68.2%</a:t>
-            </a:r>
-            <a:endParaRPr lang="en-US" sz="1200" dirty="0"/>
-          </a:p>
-        </p:txBody>
-      </p:sp>
-      <p:sp>
-        <p:nvSpPr>
-          <p:cNvPr id="17" name="Text 14"/>
-          <p:cNvSpPr/>
-          <p:nvPr/>
-        </p:nvSpPr>
-        <p:spPr>
-          <a:xfrm>
-            <a:off x="4892040" y="5943600"/>
-            <a:ext cx="2377440" cy="347472"/>
-          </a:xfrm>
-          <a:prstGeom prst="rect">
-            <a:avLst/>
-          </a:prstGeom>
-          <a:noFill/>
-          <a:ln/>
-        </p:spPr>
-        <p:txBody>
-          <a:bodyPr wrap="square" rtlCol="0" anchor="ctr"/>
-          <a:lstStyle/>
-          <a:p>
-            <a:pPr algn="ctr" indent="0" marL="0">
-              <a:buNone/>
-            </a:pPr>
-            <a:r>
-              <a:rPr lang="en-US" sz="1200" b="1" dirty="0">
-                <a:solidFill>
-                  <a:srgbClr val="C0392B"/>
-                </a:solidFill>
-                <a:latin typeface="Calibri" pitchFamily="34" charset="0"/>
-                <a:ea typeface="Calibri" pitchFamily="34" charset="-122"/>
-                <a:cs typeface="Calibri" pitchFamily="34" charset="-120"/>
-              </a:rPr>
-              <a:t>+30.4%</a:t>
-            </a:r>
-            <a:endParaRPr lang="en-US" sz="1200" dirty="0"/>
-          </a:p>
-        </p:txBody>
-      </p:sp>
-      <p:sp>
-        <p:nvSpPr>
-          <p:cNvPr id="18" name="Text 15"/>
-          <p:cNvSpPr/>
-          <p:nvPr/>
-        </p:nvSpPr>
-        <p:spPr>
-          <a:xfrm>
-            <a:off x="7269480" y="5943600"/>
-            <a:ext cx="2377440" cy="347472"/>
-          </a:xfrm>
-          <a:prstGeom prst="rect">
-            <a:avLst/>
-          </a:prstGeom>
-          <a:noFill/>
-          <a:ln/>
-        </p:spPr>
-        <p:txBody>
-          <a:bodyPr wrap="square" rtlCol="0" anchor="ctr"/>
-          <a:lstStyle/>
-          <a:p>
-            <a:pPr algn="ctr" indent="0" marL="0">
-              <a:buNone/>
-            </a:pPr>
-            <a:r>
-              <a:rPr lang="en-US" sz="1200" b="1" dirty="0">
-                <a:solidFill>
-                  <a:srgbClr val="1A7A6E"/>
-                </a:solidFill>
-                <a:latin typeface="Calibri" pitchFamily="34" charset="0"/>
-                <a:ea typeface="Calibri" pitchFamily="34" charset="-122"/>
-                <a:cs typeface="Calibri" pitchFamily="34" charset="-120"/>
-              </a:rPr>
-              <a:t>-71.4%</a:t>
-            </a:r>
-            <a:endParaRPr lang="en-US" sz="1200" dirty="0"/>
-          </a:p>
-        </p:txBody>
-      </p:sp>
-      <p:sp>
-        <p:nvSpPr>
           <p:cNvPr id="19" name="Text 16"/>
           <p:cNvSpPr/>
           <p:nvPr/>
         </p:nvSpPr>
         <p:spPr>
           <a:xfrm>
-            <a:off x="9646920" y="5943600"/>
+            <a:off x="9646920" y="5486400"/>
             <a:ext cx="2377440" cy="347472"/>
           </a:xfrm>
           <a:prstGeom prst="rect">
@@ -6705,6 +6989,290 @@
                 <a:cs typeface="Calibri" pitchFamily="34" charset="-120"/>
               </a:rPr>
               <a:t>-27.9%</a:t>
+            </a:r>
+            <a:endParaRPr lang="en-US" sz="1200" dirty="0"/>
+          </a:p>
+        </p:txBody>
+      </p:sp>
+      <p:sp>
+        <p:nvSpPr>
+          <p:cNvPr id="20" name="Shape 17"/>
+          <p:cNvSpPr/>
+          <p:nvPr/>
+        </p:nvSpPr>
+        <p:spPr>
+          <a:xfrm>
+            <a:off x="0" y="5897880"/>
+            <a:ext cx="12161520" cy="292608"/>
+          </a:xfrm>
+          <a:prstGeom prst="rect">
+            <a:avLst/>
+          </a:prstGeom>
+          <a:solidFill>
+            <a:srgbClr val="FFF9D9"/>
+          </a:solidFill>
+          <a:ln w="12700">
+            <a:solidFill>
+              <a:srgbClr val="F0E0B8"/>
+            </a:solidFill>
+            <a:prstDash val="solid"/>
+          </a:ln>
+        </p:spPr>
+      </p:sp>
+      <p:sp>
+        <p:nvSpPr>
+          <p:cNvPr id="21" name="Shape 18"/>
+          <p:cNvSpPr/>
+          <p:nvPr/>
+        </p:nvSpPr>
+        <p:spPr>
+          <a:xfrm>
+            <a:off x="0" y="5897880"/>
+            <a:ext cx="54864" cy="292608"/>
+          </a:xfrm>
+          <a:prstGeom prst="rect">
+            <a:avLst/>
+          </a:prstGeom>
+          <a:solidFill>
+            <a:srgbClr val="5D300F"/>
+          </a:solidFill>
+          <a:ln w="12700">
+            <a:solidFill>
+              <a:srgbClr val="5D300F"/>
+            </a:solidFill>
+            <a:prstDash val="solid"/>
+          </a:ln>
+        </p:spPr>
+      </p:sp>
+      <p:sp>
+        <p:nvSpPr>
+          <p:cNvPr id="22" name="Text 19"/>
+          <p:cNvSpPr/>
+          <p:nvPr/>
+        </p:nvSpPr>
+        <p:spPr>
+          <a:xfrm>
+            <a:off x="109728" y="5897880"/>
+            <a:ext cx="12051792" cy="292608"/>
+          </a:xfrm>
+          <a:prstGeom prst="rect">
+            <a:avLst/>
+          </a:prstGeom>
+          <a:noFill/>
+          <a:ln/>
+        </p:spPr>
+        <p:txBody>
+          <a:bodyPr wrap="square" lIns="0" tIns="0" rIns="0" bIns="0" rtlCol="0" anchor="ctr"/>
+          <a:lstStyle/>
+          <a:p>
+            <a:pPr indent="0" marL="0">
+              <a:buNone/>
+            </a:pPr>
+            <a:r>
+              <a:rPr lang="en-US" sz="1200" b="1" dirty="0">
+                <a:solidFill>
+                  <a:srgbClr val="5D300F"/>
+                </a:solidFill>
+                <a:latin typeface="Century Gothic" pitchFamily="34" charset="0"/>
+                <a:ea typeface="Century Gothic" pitchFamily="34" charset="-122"/>
+                <a:cs typeface="Century Gothic" pitchFamily="34" charset="-120"/>
+              </a:rPr>
+              <a:t>% Change in Disb per Team vs Prior Month</a:t>
+            </a:r>
+            <a:endParaRPr lang="en-US" sz="1200" dirty="0"/>
+          </a:p>
+        </p:txBody>
+      </p:sp>
+      <p:sp>
+        <p:nvSpPr>
+          <p:cNvPr id="23" name="Text 20"/>
+          <p:cNvSpPr/>
+          <p:nvPr/>
+        </p:nvSpPr>
+        <p:spPr>
+          <a:xfrm>
+            <a:off x="137160" y="6199632"/>
+            <a:ext cx="2377440" cy="347472"/>
+          </a:xfrm>
+          <a:prstGeom prst="rect">
+            <a:avLst/>
+          </a:prstGeom>
+          <a:noFill/>
+          <a:ln/>
+        </p:spPr>
+        <p:txBody>
+          <a:bodyPr wrap="square" rtlCol="0" anchor="ctr"/>
+          <a:lstStyle/>
+          <a:p>
+            <a:pPr algn="ctr" indent="0" marL="0">
+              <a:buNone/>
+            </a:pPr>
+            <a:r>
+              <a:rPr lang="en-US" sz="1200" b="1" dirty="0">
+                <a:solidFill>
+                  <a:srgbClr val="C0392B"/>
+                </a:solidFill>
+                <a:latin typeface="Calibri" pitchFamily="34" charset="0"/>
+                <a:ea typeface="Calibri" pitchFamily="34" charset="-122"/>
+                <a:cs typeface="Calibri" pitchFamily="34" charset="-120"/>
+              </a:rPr>
+              <a:t>-33.3%</a:t>
+            </a:r>
+            <a:endParaRPr lang="en-US" sz="1200" dirty="0"/>
+          </a:p>
+        </p:txBody>
+      </p:sp>
+      <p:sp>
+        <p:nvSpPr>
+          <p:cNvPr id="24" name="Text 21"/>
+          <p:cNvSpPr/>
+          <p:nvPr/>
+        </p:nvSpPr>
+        <p:spPr>
+          <a:xfrm>
+            <a:off x="2514600" y="6199632"/>
+            <a:ext cx="2377440" cy="347472"/>
+          </a:xfrm>
+          <a:prstGeom prst="rect">
+            <a:avLst/>
+          </a:prstGeom>
+          <a:noFill/>
+          <a:ln/>
+        </p:spPr>
+        <p:txBody>
+          <a:bodyPr wrap="square" rtlCol="0" anchor="ctr"/>
+          <a:lstStyle/>
+          <a:p>
+            <a:pPr algn="ctr" indent="0" marL="0">
+              <a:buNone/>
+            </a:pPr>
+            <a:r>
+              <a:rPr lang="en-US" sz="1200" b="1" dirty="0">
+                <a:solidFill>
+                  <a:srgbClr val="1A7A6E"/>
+                </a:solidFill>
+                <a:latin typeface="Calibri" pitchFamily="34" charset="0"/>
+                <a:ea typeface="Calibri" pitchFamily="34" charset="-122"/>
+                <a:cs typeface="Calibri" pitchFamily="34" charset="-120"/>
+              </a:rPr>
+              <a:t>+34.1%</a:t>
+            </a:r>
+            <a:endParaRPr lang="en-US" sz="1200" dirty="0"/>
+          </a:p>
+        </p:txBody>
+      </p:sp>
+      <p:sp>
+        <p:nvSpPr>
+          <p:cNvPr id="25" name="Text 22"/>
+          <p:cNvSpPr/>
+          <p:nvPr/>
+        </p:nvSpPr>
+        <p:spPr>
+          <a:xfrm>
+            <a:off x="4892040" y="6199632"/>
+            <a:ext cx="2377440" cy="347472"/>
+          </a:xfrm>
+          <a:prstGeom prst="rect">
+            <a:avLst/>
+          </a:prstGeom>
+          <a:noFill/>
+          <a:ln/>
+        </p:spPr>
+        <p:txBody>
+          <a:bodyPr wrap="square" rtlCol="0" anchor="ctr"/>
+          <a:lstStyle/>
+          <a:p>
+            <a:pPr algn="ctr" indent="0" marL="0">
+              <a:buNone/>
+            </a:pPr>
+            <a:r>
+              <a:rPr lang="en-US" sz="1200" b="1" dirty="0">
+                <a:solidFill>
+                  <a:srgbClr val="C0392B"/>
+                </a:solidFill>
+                <a:latin typeface="Calibri" pitchFamily="34" charset="0"/>
+                <a:ea typeface="Calibri" pitchFamily="34" charset="-122"/>
+                <a:cs typeface="Calibri" pitchFamily="34" charset="-120"/>
+              </a:rPr>
+              <a:t>-14.9%</a:t>
+            </a:r>
+            <a:endParaRPr lang="en-US" sz="1200" dirty="0"/>
+          </a:p>
+        </p:txBody>
+      </p:sp>
+      <p:sp>
+        <p:nvSpPr>
+          <p:cNvPr id="26" name="Text 23"/>
+          <p:cNvSpPr/>
+          <p:nvPr/>
+        </p:nvSpPr>
+        <p:spPr>
+          <a:xfrm>
+            <a:off x="7269480" y="6199632"/>
+            <a:ext cx="2377440" cy="347472"/>
+          </a:xfrm>
+          <a:prstGeom prst="rect">
+            <a:avLst/>
+          </a:prstGeom>
+          <a:noFill/>
+          <a:ln/>
+        </p:spPr>
+        <p:txBody>
+          <a:bodyPr wrap="square" rtlCol="0" anchor="ctr"/>
+          <a:lstStyle/>
+          <a:p>
+            <a:pPr algn="ctr" indent="0" marL="0">
+              <a:buNone/>
+            </a:pPr>
+            <a:r>
+              <a:rPr lang="en-US" sz="1200" b="1" dirty="0">
+                <a:solidFill>
+                  <a:srgbClr val="C0392B"/>
+                </a:solidFill>
+                <a:latin typeface="Calibri" pitchFamily="34" charset="0"/>
+                <a:ea typeface="Calibri" pitchFamily="34" charset="-122"/>
+                <a:cs typeface="Calibri" pitchFamily="34" charset="-120"/>
+              </a:rPr>
+              <a:t>-40.2%</a:t>
+            </a:r>
+            <a:endParaRPr lang="en-US" sz="1200" dirty="0"/>
+          </a:p>
+        </p:txBody>
+      </p:sp>
+      <p:sp>
+        <p:nvSpPr>
+          <p:cNvPr id="27" name="Text 24"/>
+          <p:cNvSpPr/>
+          <p:nvPr/>
+        </p:nvSpPr>
+        <p:spPr>
+          <a:xfrm>
+            <a:off x="9646920" y="6199632"/>
+            <a:ext cx="2377440" cy="347472"/>
+          </a:xfrm>
+          <a:prstGeom prst="rect">
+            <a:avLst/>
+          </a:prstGeom>
+          <a:noFill/>
+          <a:ln/>
+        </p:spPr>
+        <p:txBody>
+          <a:bodyPr wrap="square" rtlCol="0" anchor="ctr"/>
+          <a:lstStyle/>
+          <a:p>
+            <a:pPr algn="ctr" indent="0" marL="0">
+              <a:buNone/>
+            </a:pPr>
+            <a:r>
+              <a:rPr lang="en-US" sz="1200" b="1" dirty="0">
+                <a:solidFill>
+                  <a:srgbClr val="1A7A6E"/>
+                </a:solidFill>
+                <a:latin typeface="Calibri" pitchFamily="34" charset="0"/>
+                <a:ea typeface="Calibri" pitchFamily="34" charset="-122"/>
+                <a:cs typeface="Calibri" pitchFamily="34" charset="-120"/>
+              </a:rPr>
+              <a:t>+78.3%</a:t>
             </a:r>
             <a:endParaRPr lang="en-US" sz="1200" dirty="0"/>
           </a:p>
@@ -8304,13 +8872,13 @@
             <a:r>
               <a:rPr lang="en-US" sz="1200" b="1" dirty="0">
                 <a:solidFill>
-                  <a:srgbClr val="C0392B"/>
+                  <a:srgbClr val="1A7A6E"/>
                 </a:solidFill>
                 <a:latin typeface="Calibri" pitchFamily="34" charset="0"/>
                 <a:ea typeface="Calibri" pitchFamily="34" charset="-122"/>
                 <a:cs typeface="Calibri" pitchFamily="34" charset="-120"/>
               </a:rPr>
-              <a:t>↓</a:t>
+              <a:t>↑</a:t>
             </a:r>
             <a:endParaRPr lang="en-US" sz="1200" dirty="0"/>
           </a:p>
@@ -8343,13 +8911,13 @@
             <a:r>
               <a:rPr lang="en-US" sz="1200" b="1" dirty="0">
                 <a:solidFill>
-                  <a:srgbClr val="1A7A6E"/>
+                  <a:srgbClr val="C0392B"/>
                 </a:solidFill>
                 <a:latin typeface="Calibri" pitchFamily="34" charset="0"/>
                 <a:ea typeface="Calibri" pitchFamily="34" charset="-122"/>
                 <a:cs typeface="Calibri" pitchFamily="34" charset="-120"/>
               </a:rPr>
-              <a:t>↑</a:t>
+              <a:t>↓</a:t>
             </a:r>
             <a:endParaRPr lang="en-US" sz="1200" dirty="0"/>
           </a:p>
@@ -9544,7 +10112,7 @@
                 <a:ea typeface="Calibri" pitchFamily="34" charset="-122"/>
                 <a:cs typeface="Calibri" pitchFamily="34" charset="-120"/>
               </a:rPr>
-              <a:t>+65.9%</a:t>
+              <a:t>+11.0%</a:t>
             </a:r>
             <a:endParaRPr lang="en-US" sz="1200" dirty="0"/>
           </a:p>
@@ -9583,7 +10151,7 @@
                 <a:ea typeface="Calibri" pitchFamily="34" charset="-122"/>
                 <a:cs typeface="Calibri" pitchFamily="34" charset="-120"/>
               </a:rPr>
-              <a:t>+11.0%</a:t>
+              <a:t>+65.9%</a:t>
             </a:r>
             <a:endParaRPr lang="en-US" sz="1200" dirty="0"/>
           </a:p>
@@ -10386,6 +10954,109 @@
                 <a:ea typeface="Calibri" pitchFamily="34" charset="-122"/>
                 <a:cs typeface="Calibri" pitchFamily="34" charset="-120"/>
               </a:rPr>
+              <a:t>Sierra Leone</a:t>
+            </a:r>
+            <a:endParaRPr lang="en-US" sz="1200" dirty="0"/>
+          </a:p>
+        </p:txBody>
+      </p:sp>
+      <p:sp>
+        <p:nvSpPr>
+          <p:cNvPr id="43" name="Text 40"/>
+          <p:cNvSpPr/>
+          <p:nvPr/>
+        </p:nvSpPr>
+        <p:spPr>
+          <a:xfrm>
+            <a:off x="10661904" y="4389120"/>
+            <a:ext cx="1234440" cy="310896"/>
+          </a:xfrm>
+          <a:prstGeom prst="rect">
+            <a:avLst/>
+          </a:prstGeom>
+          <a:noFill/>
+          <a:ln/>
+        </p:spPr>
+        <p:txBody>
+          <a:bodyPr wrap="square" rtlCol="0" anchor="ctr"/>
+          <a:lstStyle/>
+          <a:p>
+            <a:pPr algn="ctr" indent="0" marL="0">
+              <a:buNone/>
+            </a:pPr>
+            <a:r>
+              <a:rPr lang="en-US" sz="1200" b="1" dirty="0">
+                <a:solidFill>
+                  <a:srgbClr val="5D300F"/>
+                </a:solidFill>
+                <a:latin typeface="Century Gothic" pitchFamily="34" charset="0"/>
+                <a:ea typeface="Century Gothic" pitchFamily="34" charset="-122"/>
+                <a:cs typeface="Century Gothic" pitchFamily="34" charset="-120"/>
+              </a:rPr>
+              <a:t>33</a:t>
+            </a:r>
+            <a:endParaRPr lang="en-US" sz="1200" dirty="0"/>
+          </a:p>
+        </p:txBody>
+      </p:sp>
+      <p:sp>
+        <p:nvSpPr>
+          <p:cNvPr id="44" name="Shape 41"/>
+          <p:cNvSpPr/>
+          <p:nvPr/>
+        </p:nvSpPr>
+        <p:spPr>
+          <a:xfrm>
+            <a:off x="7955280" y="4791456"/>
+            <a:ext cx="1234440" cy="566928"/>
+          </a:xfrm>
+          <a:prstGeom prst="rect">
+            <a:avLst/>
+          </a:prstGeom>
+          <a:solidFill>
+            <a:srgbClr val="FFF9D9"/>
+          </a:solidFill>
+          <a:ln w="12700">
+            <a:solidFill>
+              <a:srgbClr val="D6CFC4"/>
+            </a:solidFill>
+            <a:prstDash val="solid"/>
+          </a:ln>
+        </p:spPr>
+      </p:sp>
+      <p:sp>
+        <p:nvSpPr>
+          <p:cNvPr id="45" name="Text 42"/>
+          <p:cNvSpPr/>
+          <p:nvPr/>
+        </p:nvSpPr>
+        <p:spPr>
+          <a:xfrm>
+            <a:off x="7955280" y="4791456"/>
+            <a:ext cx="1234440" cy="256032"/>
+          </a:xfrm>
+          <a:prstGeom prst="rect">
+            <a:avLst/>
+          </a:prstGeom>
+          <a:noFill/>
+          <a:ln/>
+        </p:spPr>
+        <p:txBody>
+          <a:bodyPr wrap="square" rtlCol="0" anchor="b"/>
+          <a:lstStyle/>
+          <a:p>
+            <a:pPr algn="ctr" indent="0" marL="0">
+              <a:buNone/>
+            </a:pPr>
+            <a:r>
+              <a:rPr lang="en-US" sz="1200" dirty="0">
+                <a:solidFill>
+                  <a:srgbClr val="718096"/>
+                </a:solidFill>
+                <a:latin typeface="Calibri" pitchFamily="34" charset="0"/>
+                <a:ea typeface="Calibri" pitchFamily="34" charset="-122"/>
+                <a:cs typeface="Calibri" pitchFamily="34" charset="-120"/>
+              </a:rPr>
               <a:t>Uganda</a:t>
             </a:r>
             <a:endParaRPr lang="en-US" sz="1200" dirty="0"/>
@@ -10394,13 +11065,13 @@
       </p:sp>
       <p:sp>
         <p:nvSpPr>
-          <p:cNvPr id="43" name="Text 40"/>
-          <p:cNvSpPr/>
-          <p:nvPr/>
-        </p:nvSpPr>
-        <p:spPr>
-          <a:xfrm>
-            <a:off x="10661904" y="4389120"/>
+          <p:cNvPr id="46" name="Text 43"/>
+          <p:cNvSpPr/>
+          <p:nvPr/>
+        </p:nvSpPr>
+        <p:spPr>
+          <a:xfrm>
+            <a:off x="7955280" y="5047488"/>
             <a:ext cx="1234440" cy="310896"/>
           </a:xfrm>
           <a:prstGeom prst="rect">
@@ -10426,109 +11097,6 @@
                 <a:cs typeface="Century Gothic" pitchFamily="34" charset="-120"/>
               </a:rPr>
               <a:t>39</a:t>
-            </a:r>
-            <a:endParaRPr lang="en-US" sz="1200" dirty="0"/>
-          </a:p>
-        </p:txBody>
-      </p:sp>
-      <p:sp>
-        <p:nvSpPr>
-          <p:cNvPr id="44" name="Shape 41"/>
-          <p:cNvSpPr/>
-          <p:nvPr/>
-        </p:nvSpPr>
-        <p:spPr>
-          <a:xfrm>
-            <a:off x="7955280" y="4791456"/>
-            <a:ext cx="1234440" cy="566928"/>
-          </a:xfrm>
-          <a:prstGeom prst="rect">
-            <a:avLst/>
-          </a:prstGeom>
-          <a:solidFill>
-            <a:srgbClr val="FFF9D9"/>
-          </a:solidFill>
-          <a:ln w="12700">
-            <a:solidFill>
-              <a:srgbClr val="D6CFC4"/>
-            </a:solidFill>
-            <a:prstDash val="solid"/>
-          </a:ln>
-        </p:spPr>
-      </p:sp>
-      <p:sp>
-        <p:nvSpPr>
-          <p:cNvPr id="45" name="Text 42"/>
-          <p:cNvSpPr/>
-          <p:nvPr/>
-        </p:nvSpPr>
-        <p:spPr>
-          <a:xfrm>
-            <a:off x="7955280" y="4791456"/>
-            <a:ext cx="1234440" cy="256032"/>
-          </a:xfrm>
-          <a:prstGeom prst="rect">
-            <a:avLst/>
-          </a:prstGeom>
-          <a:noFill/>
-          <a:ln/>
-        </p:spPr>
-        <p:txBody>
-          <a:bodyPr wrap="square" rtlCol="0" anchor="b"/>
-          <a:lstStyle/>
-          <a:p>
-            <a:pPr algn="ctr" indent="0" marL="0">
-              <a:buNone/>
-            </a:pPr>
-            <a:r>
-              <a:rPr lang="en-US" sz="1200" dirty="0">
-                <a:solidFill>
-                  <a:srgbClr val="718096"/>
-                </a:solidFill>
-                <a:latin typeface="Calibri" pitchFamily="34" charset="0"/>
-                <a:ea typeface="Calibri" pitchFamily="34" charset="-122"/>
-                <a:cs typeface="Calibri" pitchFamily="34" charset="-120"/>
-              </a:rPr>
-              <a:t>Sierra Leone</a:t>
-            </a:r>
-            <a:endParaRPr lang="en-US" sz="1200" dirty="0"/>
-          </a:p>
-        </p:txBody>
-      </p:sp>
-      <p:sp>
-        <p:nvSpPr>
-          <p:cNvPr id="46" name="Text 43"/>
-          <p:cNvSpPr/>
-          <p:nvPr/>
-        </p:nvSpPr>
-        <p:spPr>
-          <a:xfrm>
-            <a:off x="7955280" y="5047488"/>
-            <a:ext cx="1234440" cy="310896"/>
-          </a:xfrm>
-          <a:prstGeom prst="rect">
-            <a:avLst/>
-          </a:prstGeom>
-          <a:noFill/>
-          <a:ln/>
-        </p:spPr>
-        <p:txBody>
-          <a:bodyPr wrap="square" rtlCol="0" anchor="ctr"/>
-          <a:lstStyle/>
-          <a:p>
-            <a:pPr algn="ctr" indent="0" marL="0">
-              <a:buNone/>
-            </a:pPr>
-            <a:r>
-              <a:rPr lang="en-US" sz="1200" b="1" dirty="0">
-                <a:solidFill>
-                  <a:srgbClr val="5D300F"/>
-                </a:solidFill>
-                <a:latin typeface="Century Gothic" pitchFamily="34" charset="0"/>
-                <a:ea typeface="Century Gothic" pitchFamily="34" charset="-122"/>
-                <a:cs typeface="Century Gothic" pitchFamily="34" charset="-120"/>
-              </a:rPr>
-              <a:t>33</a:t>
             </a:r>
             <a:endParaRPr lang="en-US" sz="1200" dirty="0"/>
           </a:p>
@@ -11403,13 +11971,13 @@
             <a:r>
               <a:rPr lang="en-US" sz="1200" b="1" dirty="0">
                 <a:solidFill>
-                  <a:srgbClr val="C0392B"/>
+                  <a:srgbClr val="1A7A6E"/>
                 </a:solidFill>
                 <a:latin typeface="Calibri" pitchFamily="34" charset="0"/>
                 <a:ea typeface="Calibri" pitchFamily="34" charset="-122"/>
                 <a:cs typeface="Calibri" pitchFamily="34" charset="-120"/>
               </a:rPr>
-              <a:t>-6.5%</a:t>
+              <a:t>+16.9%</a:t>
             </a:r>
             <a:endParaRPr lang="en-US" sz="1200" dirty="0"/>
           </a:p>
@@ -11442,13 +12010,13 @@
             <a:r>
               <a:rPr lang="en-US" sz="1200" b="1" dirty="0">
                 <a:solidFill>
-                  <a:srgbClr val="1A7A6E"/>
+                  <a:srgbClr val="C0392B"/>
                 </a:solidFill>
                 <a:latin typeface="Calibri" pitchFamily="34" charset="0"/>
                 <a:ea typeface="Calibri" pitchFamily="34" charset="-122"/>
                 <a:cs typeface="Calibri" pitchFamily="34" charset="-120"/>
               </a:rPr>
-              <a:t>+16.9%</a:t>
+              <a:t>-6.5%</a:t>
             </a:r>
             <a:endParaRPr lang="en-US" sz="1200" dirty="0"/>
           </a:p>
@@ -11687,13 +12255,13 @@
             <a:r>
               <a:rPr lang="en-US" sz="1200" b="1" dirty="0">
                 <a:solidFill>
-                  <a:srgbClr val="1A7A6E"/>
+                  <a:srgbClr val="C0392B"/>
                 </a:solidFill>
                 <a:latin typeface="Calibri" pitchFamily="34" charset="0"/>
                 <a:ea typeface="Calibri" pitchFamily="34" charset="-122"/>
                 <a:cs typeface="Calibri" pitchFamily="34" charset="-120"/>
               </a:rPr>
-              <a:t>+34.1%</a:t>
+              <a:t>-33.3%</a:t>
             </a:r>
             <a:endParaRPr lang="en-US" sz="1200" dirty="0"/>
           </a:p>
@@ -11726,13 +12294,13 @@
             <a:r>
               <a:rPr lang="en-US" sz="1200" b="1" dirty="0">
                 <a:solidFill>
-                  <a:srgbClr val="C0392B"/>
+                  <a:srgbClr val="1A7A6E"/>
                 </a:solidFill>
                 <a:latin typeface="Calibri" pitchFamily="34" charset="0"/>
                 <a:ea typeface="Calibri" pitchFamily="34" charset="-122"/>
                 <a:cs typeface="Calibri" pitchFamily="34" charset="-120"/>
               </a:rPr>
-              <a:t>-33.3%</a:t>
+              <a:t>+34.1%</a:t>
             </a:r>
             <a:endParaRPr lang="en-US" sz="1200" dirty="0"/>
           </a:p>
@@ -12299,7 +12867,7 @@
                 <a:ea typeface="Calibri" pitchFamily="34" charset="-122"/>
                 <a:cs typeface="Calibri" pitchFamily="34" charset="-120"/>
               </a:rPr>
-              <a:t>+18.2%</a:t>
+              <a:t>+14.0%</a:t>
             </a:r>
             <a:endParaRPr lang="en-US" sz="1200" dirty="0"/>
           </a:p>
@@ -12338,7 +12906,7 @@
                 <a:ea typeface="Calibri" pitchFamily="34" charset="-122"/>
                 <a:cs typeface="Calibri" pitchFamily="34" charset="-120"/>
               </a:rPr>
-              <a:t>+14.0%</a:t>
+              <a:t>+18.2%</a:t>
             </a:r>
             <a:endParaRPr lang="en-US" sz="1200" dirty="0"/>
           </a:p>
@@ -13424,7 +13992,7 @@
                           <a:ea typeface="Century Gothic" pitchFamily="34" charset="-122"/>
                           <a:cs typeface="Century Gothic" pitchFamily="34" charset="-120"/>
                         </a:rPr>
-                        <a:t>Tanzania</a:t>
+                        <a:t>Sierra Leone</a:t>
                       </a:r>
                       <a:endParaRPr lang="en-US" sz="1200" dirty="0">
                         <a:latin typeface="Century Gothic" charset="0"/>
@@ -13492,7 +14060,7 @@
                           <a:ea typeface="Calibri" pitchFamily="34" charset="-122"/>
                           <a:cs typeface="Calibri" pitchFamily="34" charset="-120"/>
                         </a:rPr>
-                        <a:t>4.5%</a:t>
+                        <a:t>2.7%</a:t>
                       </a:r>
                       <a:endParaRPr lang="en-US" sz="1200" dirty="0">
                         <a:latin typeface="Calibri" charset="0"/>
@@ -13560,7 +14128,7 @@
                           <a:ea typeface="Calibri" pitchFamily="34" charset="-122"/>
                           <a:cs typeface="Calibri" pitchFamily="34" charset="-120"/>
                         </a:rPr>
-                        <a:t>6.5%</a:t>
+                        <a:t>2.2%</a:t>
                       </a:r>
                       <a:endParaRPr lang="en-US" sz="1200" dirty="0">
                         <a:latin typeface="Calibri" charset="0"/>
@@ -13622,13 +14190,13 @@
                       <a:r>
                         <a:rPr lang="en-US" sz="1200" dirty="0">
                           <a:solidFill>
-                            <a:srgbClr val="C0392B"/>
+                            <a:srgbClr val="1A7A6E"/>
                           </a:solidFill>
                           <a:latin typeface="Calibri" pitchFamily="34" charset="0"/>
                           <a:ea typeface="Calibri" pitchFamily="34" charset="-122"/>
                           <a:cs typeface="Calibri" pitchFamily="34" charset="-120"/>
                         </a:rPr>
-                        <a:t>↑</a:t>
+                        <a:t>↓</a:t>
                       </a:r>
                       <a:endParaRPr lang="en-US" sz="1200" dirty="0">
                         <a:latin typeface="Calibri" charset="0"/>
@@ -13972,7 +14540,7 @@
                           <a:ea typeface="Century Gothic" pitchFamily="34" charset="-122"/>
                           <a:cs typeface="Century Gothic" pitchFamily="34" charset="-120"/>
                         </a:rPr>
-                        <a:t>Uganda</a:t>
+                        <a:t>Tanzania</a:t>
                       </a:r>
                       <a:endParaRPr lang="en-US" sz="1200" dirty="0">
                         <a:latin typeface="Century Gothic" charset="0"/>
@@ -14040,7 +14608,7 @@
                           <a:ea typeface="Calibri" pitchFamily="34" charset="-122"/>
                           <a:cs typeface="Calibri" pitchFamily="34" charset="-120"/>
                         </a:rPr>
-                        <a:t>11.1%</a:t>
+                        <a:t>4.5%</a:t>
                       </a:r>
                       <a:endParaRPr lang="en-US" sz="1200" dirty="0">
                         <a:latin typeface="Calibri" charset="0"/>
@@ -14108,7 +14676,7 @@
                           <a:ea typeface="Calibri" pitchFamily="34" charset="-122"/>
                           <a:cs typeface="Calibri" pitchFamily="34" charset="-120"/>
                         </a:rPr>
-                        <a:t>11.6%</a:t>
+                        <a:t>6.5%</a:t>
                       </a:r>
                       <a:endParaRPr lang="en-US" sz="1200" dirty="0">
                         <a:latin typeface="Calibri" charset="0"/>
@@ -14246,7 +14814,7 @@
                           <a:ea typeface="Century Gothic" pitchFamily="34" charset="-122"/>
                           <a:cs typeface="Century Gothic" pitchFamily="34" charset="-120"/>
                         </a:rPr>
-                        <a:t>Sierra Leone</a:t>
+                        <a:t>Uganda</a:t>
                       </a:r>
                       <a:endParaRPr lang="en-US" sz="1200" dirty="0">
                         <a:latin typeface="Century Gothic" charset="0"/>
@@ -14314,7 +14882,7 @@
                           <a:ea typeface="Calibri" pitchFamily="34" charset="-122"/>
                           <a:cs typeface="Calibri" pitchFamily="34" charset="-120"/>
                         </a:rPr>
-                        <a:t>2.7%</a:t>
+                        <a:t>11.1%</a:t>
                       </a:r>
                       <a:endParaRPr lang="en-US" sz="1200" dirty="0">
                         <a:latin typeface="Calibri" charset="0"/>
@@ -14382,7 +14950,7 @@
                           <a:ea typeface="Calibri" pitchFamily="34" charset="-122"/>
                           <a:cs typeface="Calibri" pitchFamily="34" charset="-120"/>
                         </a:rPr>
-                        <a:t>2.2%</a:t>
+                        <a:t>11.6%</a:t>
                       </a:r>
                       <a:endParaRPr lang="en-US" sz="1200" dirty="0">
                         <a:latin typeface="Calibri" charset="0"/>
@@ -14444,13 +15012,13 @@
                       <a:r>
                         <a:rPr lang="en-US" sz="1200" dirty="0">
                           <a:solidFill>
-                            <a:srgbClr val="1A7A6E"/>
+                            <a:srgbClr val="C0392B"/>
                           </a:solidFill>
                           <a:latin typeface="Calibri" pitchFamily="34" charset="0"/>
                           <a:ea typeface="Calibri" pitchFamily="34" charset="-122"/>
                           <a:cs typeface="Calibri" pitchFamily="34" charset="-120"/>
                         </a:rPr>
-                        <a:t>↓</a:t>
+                        <a:t>↑</a:t>
                       </a:r>
                       <a:endParaRPr lang="en-US" sz="1200" dirty="0">
                         <a:latin typeface="Calibri" charset="0"/>
@@ -15680,7 +16248,7 @@
                           <a:ea typeface="Century Gothic" pitchFamily="34" charset="-122"/>
                           <a:cs typeface="Century Gothic" pitchFamily="34" charset="-120"/>
                         </a:rPr>
-                        <a:t>Tanzania</a:t>
+                        <a:t>Sierra Leone</a:t>
                       </a:r>
                       <a:endParaRPr lang="en-US" sz="1200" dirty="0">
                         <a:latin typeface="Century Gothic" charset="0"/>
@@ -15748,7 +16316,7 @@
                           <a:ea typeface="Calibri" pitchFamily="34" charset="-122"/>
                           <a:cs typeface="Calibri" pitchFamily="34" charset="-120"/>
                         </a:rPr>
-                        <a:t>8.2%</a:t>
+                        <a:t>2.0%</a:t>
                       </a:r>
                       <a:endParaRPr lang="en-US" sz="1200" dirty="0">
                         <a:latin typeface="Calibri" charset="0"/>
@@ -15816,7 +16384,7 @@
                           <a:ea typeface="Calibri" pitchFamily="34" charset="-122"/>
                           <a:cs typeface="Calibri" pitchFamily="34" charset="-120"/>
                         </a:rPr>
-                        <a:t>8.0%</a:t>
+                        <a:t>1.8%</a:t>
                       </a:r>
                       <a:endParaRPr lang="en-US" sz="1200" dirty="0">
                         <a:latin typeface="Calibri" charset="0"/>
@@ -15954,6 +16522,280 @@
                           <a:ea typeface="Century Gothic" pitchFamily="34" charset="-122"/>
                           <a:cs typeface="Century Gothic" pitchFamily="34" charset="-120"/>
                         </a:rPr>
+                        <a:t>Tanzania</a:t>
+                      </a:r>
+                      <a:endParaRPr lang="en-US" sz="1200" dirty="0">
+                        <a:latin typeface="Century Gothic" charset="0"/>
+                        <a:ea typeface="Century Gothic" charset="0"/>
+                        <a:cs typeface="Century Gothic" charset="0"/>
+                      </a:endParaRPr>
+                    </a:p>
+                  </a:txBody>
+                  <a:tcPr marL="91440" marR="91440" marT="45720" marB="45720" anchor="ctr">
+                    <a:lnL w="6350" cap="flat" cmpd="sng" algn="ctr">
+                      <a:solidFill>
+                        <a:srgbClr val="D6CFC4"/>
+                      </a:solidFill>
+                      <a:prstDash val="solid"/>
+                      <a:round/>
+                      <a:headEnd type="none" w="med" len="med"/>
+                      <a:tailEnd type="none" w="med" len="med"/>
+                    </a:lnL>
+                    <a:lnR w="6350" cap="flat" cmpd="sng" algn="ctr">
+                      <a:solidFill>
+                        <a:srgbClr val="D6CFC4"/>
+                      </a:solidFill>
+                      <a:prstDash val="solid"/>
+                      <a:round/>
+                      <a:headEnd type="none" w="med" len="med"/>
+                      <a:tailEnd type="none" w="med" len="med"/>
+                    </a:lnR>
+                    <a:lnT w="6350" cap="flat" cmpd="sng" algn="ctr">
+                      <a:solidFill>
+                        <a:srgbClr val="D6CFC4"/>
+                      </a:solidFill>
+                      <a:prstDash val="solid"/>
+                      <a:round/>
+                      <a:headEnd type="none" w="med" len="med"/>
+                      <a:tailEnd type="none" w="med" len="med"/>
+                    </a:lnT>
+                    <a:lnB w="6350" cap="flat" cmpd="sng" algn="ctr">
+                      <a:solidFill>
+                        <a:srgbClr val="D6CFC4"/>
+                      </a:solidFill>
+                      <a:prstDash val="solid"/>
+                      <a:round/>
+                      <a:headEnd type="none" w="med" len="med"/>
+                      <a:tailEnd type="none" w="med" len="med"/>
+                    </a:lnB>
+                    <a:solidFill>
+                      <a:srgbClr val="FFF9D9"/>
+                    </a:solidFill>
+                  </a:tcPr>
+                </a:tc>
+                <a:tc>
+                  <a:txBody>
+                    <a:bodyPr/>
+                    <a:lstStyle/>
+                    <a:p>
+                      <a:pPr algn="ctr" indent="0" marL="0">
+                        <a:buNone/>
+                      </a:pPr>
+                      <a:r>
+                        <a:rPr lang="en-US" sz="1200" dirty="0">
+                          <a:solidFill>
+                            <a:srgbClr val="2D2A26"/>
+                          </a:solidFill>
+                          <a:latin typeface="Calibri" pitchFamily="34" charset="0"/>
+                          <a:ea typeface="Calibri" pitchFamily="34" charset="-122"/>
+                          <a:cs typeface="Calibri" pitchFamily="34" charset="-120"/>
+                        </a:rPr>
+                        <a:t>8.2%</a:t>
+                      </a:r>
+                      <a:endParaRPr lang="en-US" sz="1200" dirty="0">
+                        <a:latin typeface="Calibri" charset="0"/>
+                        <a:ea typeface="Calibri" charset="0"/>
+                        <a:cs typeface="Calibri" charset="0"/>
+                      </a:endParaRPr>
+                    </a:p>
+                  </a:txBody>
+                  <a:tcPr marL="91440" marR="91440" marT="45720" marB="45720" anchor="ctr">
+                    <a:lnL w="6350" cap="flat" cmpd="sng" algn="ctr">
+                      <a:solidFill>
+                        <a:srgbClr val="D6CFC4"/>
+                      </a:solidFill>
+                      <a:prstDash val="solid"/>
+                      <a:round/>
+                      <a:headEnd type="none" w="med" len="med"/>
+                      <a:tailEnd type="none" w="med" len="med"/>
+                    </a:lnL>
+                    <a:lnR w="6350" cap="flat" cmpd="sng" algn="ctr">
+                      <a:solidFill>
+                        <a:srgbClr val="D6CFC4"/>
+                      </a:solidFill>
+                      <a:prstDash val="solid"/>
+                      <a:round/>
+                      <a:headEnd type="none" w="med" len="med"/>
+                      <a:tailEnd type="none" w="med" len="med"/>
+                    </a:lnR>
+                    <a:lnT w="6350" cap="flat" cmpd="sng" algn="ctr">
+                      <a:solidFill>
+                        <a:srgbClr val="D6CFC4"/>
+                      </a:solidFill>
+                      <a:prstDash val="solid"/>
+                      <a:round/>
+                      <a:headEnd type="none" w="med" len="med"/>
+                      <a:tailEnd type="none" w="med" len="med"/>
+                    </a:lnT>
+                    <a:lnB w="6350" cap="flat" cmpd="sng" algn="ctr">
+                      <a:solidFill>
+                        <a:srgbClr val="D6CFC4"/>
+                      </a:solidFill>
+                      <a:prstDash val="solid"/>
+                      <a:round/>
+                      <a:headEnd type="none" w="med" len="med"/>
+                      <a:tailEnd type="none" w="med" len="med"/>
+                    </a:lnB>
+                    <a:solidFill>
+                      <a:srgbClr val="FFF9D9"/>
+                    </a:solidFill>
+                  </a:tcPr>
+                </a:tc>
+                <a:tc>
+                  <a:txBody>
+                    <a:bodyPr/>
+                    <a:lstStyle/>
+                    <a:p>
+                      <a:pPr algn="ctr" indent="0" marL="0">
+                        <a:buNone/>
+                      </a:pPr>
+                      <a:r>
+                        <a:rPr lang="en-US" sz="1200" dirty="0">
+                          <a:solidFill>
+                            <a:srgbClr val="2D2A26"/>
+                          </a:solidFill>
+                          <a:latin typeface="Calibri" pitchFamily="34" charset="0"/>
+                          <a:ea typeface="Calibri" pitchFamily="34" charset="-122"/>
+                          <a:cs typeface="Calibri" pitchFamily="34" charset="-120"/>
+                        </a:rPr>
+                        <a:t>8.0%</a:t>
+                      </a:r>
+                      <a:endParaRPr lang="en-US" sz="1200" dirty="0">
+                        <a:latin typeface="Calibri" charset="0"/>
+                        <a:ea typeface="Calibri" charset="0"/>
+                        <a:cs typeface="Calibri" charset="0"/>
+                      </a:endParaRPr>
+                    </a:p>
+                  </a:txBody>
+                  <a:tcPr marL="91440" marR="91440" marT="45720" marB="45720" anchor="ctr">
+                    <a:lnL w="6350" cap="flat" cmpd="sng" algn="ctr">
+                      <a:solidFill>
+                        <a:srgbClr val="D6CFC4"/>
+                      </a:solidFill>
+                      <a:prstDash val="solid"/>
+                      <a:round/>
+                      <a:headEnd type="none" w="med" len="med"/>
+                      <a:tailEnd type="none" w="med" len="med"/>
+                    </a:lnL>
+                    <a:lnR w="6350" cap="flat" cmpd="sng" algn="ctr">
+                      <a:solidFill>
+                        <a:srgbClr val="D6CFC4"/>
+                      </a:solidFill>
+                      <a:prstDash val="solid"/>
+                      <a:round/>
+                      <a:headEnd type="none" w="med" len="med"/>
+                      <a:tailEnd type="none" w="med" len="med"/>
+                    </a:lnR>
+                    <a:lnT w="6350" cap="flat" cmpd="sng" algn="ctr">
+                      <a:solidFill>
+                        <a:srgbClr val="D6CFC4"/>
+                      </a:solidFill>
+                      <a:prstDash val="solid"/>
+                      <a:round/>
+                      <a:headEnd type="none" w="med" len="med"/>
+                      <a:tailEnd type="none" w="med" len="med"/>
+                    </a:lnT>
+                    <a:lnB w="6350" cap="flat" cmpd="sng" algn="ctr">
+                      <a:solidFill>
+                        <a:srgbClr val="D6CFC4"/>
+                      </a:solidFill>
+                      <a:prstDash val="solid"/>
+                      <a:round/>
+                      <a:headEnd type="none" w="med" len="med"/>
+                      <a:tailEnd type="none" w="med" len="med"/>
+                    </a:lnB>
+                    <a:solidFill>
+                      <a:srgbClr val="FFF9D9"/>
+                    </a:solidFill>
+                  </a:tcPr>
+                </a:tc>
+                <a:tc>
+                  <a:txBody>
+                    <a:bodyPr/>
+                    <a:lstStyle/>
+                    <a:p>
+                      <a:pPr algn="ctr" indent="0" marL="0">
+                        <a:buNone/>
+                      </a:pPr>
+                      <a:r>
+                        <a:rPr lang="en-US" sz="1200" dirty="0">
+                          <a:solidFill>
+                            <a:srgbClr val="1A7A6E"/>
+                          </a:solidFill>
+                          <a:latin typeface="Calibri" pitchFamily="34" charset="0"/>
+                          <a:ea typeface="Calibri" pitchFamily="34" charset="-122"/>
+                          <a:cs typeface="Calibri" pitchFamily="34" charset="-120"/>
+                        </a:rPr>
+                        <a:t>↓</a:t>
+                      </a:r>
+                      <a:endParaRPr lang="en-US" sz="1200" dirty="0">
+                        <a:latin typeface="Calibri" charset="0"/>
+                        <a:ea typeface="Calibri" charset="0"/>
+                        <a:cs typeface="Calibri" charset="0"/>
+                      </a:endParaRPr>
+                    </a:p>
+                  </a:txBody>
+                  <a:tcPr marL="91440" marR="91440" marT="45720" marB="45720" anchor="ctr">
+                    <a:lnL w="6350" cap="flat" cmpd="sng" algn="ctr">
+                      <a:solidFill>
+                        <a:srgbClr val="D6CFC4"/>
+                      </a:solidFill>
+                      <a:prstDash val="solid"/>
+                      <a:round/>
+                      <a:headEnd type="none" w="med" len="med"/>
+                      <a:tailEnd type="none" w="med" len="med"/>
+                    </a:lnL>
+                    <a:lnR w="6350" cap="flat" cmpd="sng" algn="ctr">
+                      <a:solidFill>
+                        <a:srgbClr val="D6CFC4"/>
+                      </a:solidFill>
+                      <a:prstDash val="solid"/>
+                      <a:round/>
+                      <a:headEnd type="none" w="med" len="med"/>
+                      <a:tailEnd type="none" w="med" len="med"/>
+                    </a:lnR>
+                    <a:lnT w="6350" cap="flat" cmpd="sng" algn="ctr">
+                      <a:solidFill>
+                        <a:srgbClr val="D6CFC4"/>
+                      </a:solidFill>
+                      <a:prstDash val="solid"/>
+                      <a:round/>
+                      <a:headEnd type="none" w="med" len="med"/>
+                      <a:tailEnd type="none" w="med" len="med"/>
+                    </a:lnT>
+                    <a:lnB w="6350" cap="flat" cmpd="sng" algn="ctr">
+                      <a:solidFill>
+                        <a:srgbClr val="D6CFC4"/>
+                      </a:solidFill>
+                      <a:prstDash val="solid"/>
+                      <a:round/>
+                      <a:headEnd type="none" w="med" len="med"/>
+                      <a:tailEnd type="none" w="med" len="med"/>
+                    </a:lnB>
+                    <a:solidFill>
+                      <a:srgbClr val="FFF9D9"/>
+                    </a:solidFill>
+                  </a:tcPr>
+                </a:tc>
+              </a:tr>
+              <a:tr h="384048">
+                <a:tc>
+                  <a:txBody>
+                    <a:bodyPr/>
+                    <a:lstStyle/>
+                    <a:p>
+                      <a:pPr algn="l" indent="0" marL="0">
+                        <a:buNone/>
+                      </a:pPr>
+                      <a:r>
+                        <a:rPr lang="en-US" sz="1200" b="1" dirty="0">
+                          <a:solidFill>
+                            <a:srgbClr val="2D2A26"/>
+                          </a:solidFill>
+                          <a:latin typeface="Century Gothic" pitchFamily="34" charset="0"/>
+                          <a:ea typeface="Century Gothic" pitchFamily="34" charset="-122"/>
+                          <a:cs typeface="Century Gothic" pitchFamily="34" charset="-120"/>
+                        </a:rPr>
                         <a:t>Kenya</a:t>
                       </a:r>
                       <a:endParaRPr lang="en-US" sz="1200" dirty="0">
@@ -16001,7 +16843,7 @@
                       <a:tailEnd type="none" w="med" len="med"/>
                     </a:lnB>
                     <a:solidFill>
-                      <a:srgbClr val="FFF9D9"/>
+                      <a:srgbClr val="FFFFFF"/>
                     </a:solidFill>
                   </a:tcPr>
                 </a:tc>
@@ -16069,7 +16911,7 @@
                       <a:tailEnd type="none" w="med" len="med"/>
                     </a:lnB>
                     <a:solidFill>
-                      <a:srgbClr val="FFF9D9"/>
+                      <a:srgbClr val="FFFFFF"/>
                     </a:solidFill>
                   </a:tcPr>
                 </a:tc>
@@ -16091,280 +16933,6 @@
                           <a:cs typeface="Calibri" pitchFamily="34" charset="-120"/>
                         </a:rPr>
                         <a:t>8.8%</a:t>
-                      </a:r>
-                      <a:endParaRPr lang="en-US" sz="1200" dirty="0">
-                        <a:latin typeface="Calibri" charset="0"/>
-                        <a:ea typeface="Calibri" charset="0"/>
-                        <a:cs typeface="Calibri" charset="0"/>
-                      </a:endParaRPr>
-                    </a:p>
-                  </a:txBody>
-                  <a:tcPr marL="91440" marR="91440" marT="45720" marB="45720" anchor="ctr">
-                    <a:lnL w="6350" cap="flat" cmpd="sng" algn="ctr">
-                      <a:solidFill>
-                        <a:srgbClr val="D6CFC4"/>
-                      </a:solidFill>
-                      <a:prstDash val="solid"/>
-                      <a:round/>
-                      <a:headEnd type="none" w="med" len="med"/>
-                      <a:tailEnd type="none" w="med" len="med"/>
-                    </a:lnL>
-                    <a:lnR w="6350" cap="flat" cmpd="sng" algn="ctr">
-                      <a:solidFill>
-                        <a:srgbClr val="D6CFC4"/>
-                      </a:solidFill>
-                      <a:prstDash val="solid"/>
-                      <a:round/>
-                      <a:headEnd type="none" w="med" len="med"/>
-                      <a:tailEnd type="none" w="med" len="med"/>
-                    </a:lnR>
-                    <a:lnT w="6350" cap="flat" cmpd="sng" algn="ctr">
-                      <a:solidFill>
-                        <a:srgbClr val="D6CFC4"/>
-                      </a:solidFill>
-                      <a:prstDash val="solid"/>
-                      <a:round/>
-                      <a:headEnd type="none" w="med" len="med"/>
-                      <a:tailEnd type="none" w="med" len="med"/>
-                    </a:lnT>
-                    <a:lnB w="6350" cap="flat" cmpd="sng" algn="ctr">
-                      <a:solidFill>
-                        <a:srgbClr val="D6CFC4"/>
-                      </a:solidFill>
-                      <a:prstDash val="solid"/>
-                      <a:round/>
-                      <a:headEnd type="none" w="med" len="med"/>
-                      <a:tailEnd type="none" w="med" len="med"/>
-                    </a:lnB>
-                    <a:solidFill>
-                      <a:srgbClr val="FFF9D9"/>
-                    </a:solidFill>
-                  </a:tcPr>
-                </a:tc>
-                <a:tc>
-                  <a:txBody>
-                    <a:bodyPr/>
-                    <a:lstStyle/>
-                    <a:p>
-                      <a:pPr algn="ctr" indent="0" marL="0">
-                        <a:buNone/>
-                      </a:pPr>
-                      <a:r>
-                        <a:rPr lang="en-US" sz="1200" dirty="0">
-                          <a:solidFill>
-                            <a:srgbClr val="C0392B"/>
-                          </a:solidFill>
-                          <a:latin typeface="Calibri" pitchFamily="34" charset="0"/>
-                          <a:ea typeface="Calibri" pitchFamily="34" charset="-122"/>
-                          <a:cs typeface="Calibri" pitchFamily="34" charset="-120"/>
-                        </a:rPr>
-                        <a:t>↑</a:t>
-                      </a:r>
-                      <a:endParaRPr lang="en-US" sz="1200" dirty="0">
-                        <a:latin typeface="Calibri" charset="0"/>
-                        <a:ea typeface="Calibri" charset="0"/>
-                        <a:cs typeface="Calibri" charset="0"/>
-                      </a:endParaRPr>
-                    </a:p>
-                  </a:txBody>
-                  <a:tcPr marL="91440" marR="91440" marT="45720" marB="45720" anchor="ctr">
-                    <a:lnL w="6350" cap="flat" cmpd="sng" algn="ctr">
-                      <a:solidFill>
-                        <a:srgbClr val="D6CFC4"/>
-                      </a:solidFill>
-                      <a:prstDash val="solid"/>
-                      <a:round/>
-                      <a:headEnd type="none" w="med" len="med"/>
-                      <a:tailEnd type="none" w="med" len="med"/>
-                    </a:lnL>
-                    <a:lnR w="6350" cap="flat" cmpd="sng" algn="ctr">
-                      <a:solidFill>
-                        <a:srgbClr val="D6CFC4"/>
-                      </a:solidFill>
-                      <a:prstDash val="solid"/>
-                      <a:round/>
-                      <a:headEnd type="none" w="med" len="med"/>
-                      <a:tailEnd type="none" w="med" len="med"/>
-                    </a:lnR>
-                    <a:lnT w="6350" cap="flat" cmpd="sng" algn="ctr">
-                      <a:solidFill>
-                        <a:srgbClr val="D6CFC4"/>
-                      </a:solidFill>
-                      <a:prstDash val="solid"/>
-                      <a:round/>
-                      <a:headEnd type="none" w="med" len="med"/>
-                      <a:tailEnd type="none" w="med" len="med"/>
-                    </a:lnT>
-                    <a:lnB w="6350" cap="flat" cmpd="sng" algn="ctr">
-                      <a:solidFill>
-                        <a:srgbClr val="D6CFC4"/>
-                      </a:solidFill>
-                      <a:prstDash val="solid"/>
-                      <a:round/>
-                      <a:headEnd type="none" w="med" len="med"/>
-                      <a:tailEnd type="none" w="med" len="med"/>
-                    </a:lnB>
-                    <a:solidFill>
-                      <a:srgbClr val="FFF9D9"/>
-                    </a:solidFill>
-                  </a:tcPr>
-                </a:tc>
-              </a:tr>
-              <a:tr h="384048">
-                <a:tc>
-                  <a:txBody>
-                    <a:bodyPr/>
-                    <a:lstStyle/>
-                    <a:p>
-                      <a:pPr algn="l" indent="0" marL="0">
-                        <a:buNone/>
-                      </a:pPr>
-                      <a:r>
-                        <a:rPr lang="en-US" sz="1200" b="1" dirty="0">
-                          <a:solidFill>
-                            <a:srgbClr val="2D2A26"/>
-                          </a:solidFill>
-                          <a:latin typeface="Century Gothic" pitchFamily="34" charset="0"/>
-                          <a:ea typeface="Century Gothic" pitchFamily="34" charset="-122"/>
-                          <a:cs typeface="Century Gothic" pitchFamily="34" charset="-120"/>
-                        </a:rPr>
-                        <a:t>Uganda</a:t>
-                      </a:r>
-                      <a:endParaRPr lang="en-US" sz="1200" dirty="0">
-                        <a:latin typeface="Century Gothic" charset="0"/>
-                        <a:ea typeface="Century Gothic" charset="0"/>
-                        <a:cs typeface="Century Gothic" charset="0"/>
-                      </a:endParaRPr>
-                    </a:p>
-                  </a:txBody>
-                  <a:tcPr marL="91440" marR="91440" marT="45720" marB="45720" anchor="ctr">
-                    <a:lnL w="6350" cap="flat" cmpd="sng" algn="ctr">
-                      <a:solidFill>
-                        <a:srgbClr val="D6CFC4"/>
-                      </a:solidFill>
-                      <a:prstDash val="solid"/>
-                      <a:round/>
-                      <a:headEnd type="none" w="med" len="med"/>
-                      <a:tailEnd type="none" w="med" len="med"/>
-                    </a:lnL>
-                    <a:lnR w="6350" cap="flat" cmpd="sng" algn="ctr">
-                      <a:solidFill>
-                        <a:srgbClr val="D6CFC4"/>
-                      </a:solidFill>
-                      <a:prstDash val="solid"/>
-                      <a:round/>
-                      <a:headEnd type="none" w="med" len="med"/>
-                      <a:tailEnd type="none" w="med" len="med"/>
-                    </a:lnR>
-                    <a:lnT w="6350" cap="flat" cmpd="sng" algn="ctr">
-                      <a:solidFill>
-                        <a:srgbClr val="D6CFC4"/>
-                      </a:solidFill>
-                      <a:prstDash val="solid"/>
-                      <a:round/>
-                      <a:headEnd type="none" w="med" len="med"/>
-                      <a:tailEnd type="none" w="med" len="med"/>
-                    </a:lnT>
-                    <a:lnB w="6350" cap="flat" cmpd="sng" algn="ctr">
-                      <a:solidFill>
-                        <a:srgbClr val="D6CFC4"/>
-                      </a:solidFill>
-                      <a:prstDash val="solid"/>
-                      <a:round/>
-                      <a:headEnd type="none" w="med" len="med"/>
-                      <a:tailEnd type="none" w="med" len="med"/>
-                    </a:lnB>
-                    <a:solidFill>
-                      <a:srgbClr val="FFFFFF"/>
-                    </a:solidFill>
-                  </a:tcPr>
-                </a:tc>
-                <a:tc>
-                  <a:txBody>
-                    <a:bodyPr/>
-                    <a:lstStyle/>
-                    <a:p>
-                      <a:pPr algn="ctr" indent="0" marL="0">
-                        <a:buNone/>
-                      </a:pPr>
-                      <a:r>
-                        <a:rPr lang="en-US" sz="1200" dirty="0">
-                          <a:solidFill>
-                            <a:srgbClr val="2D2A26"/>
-                          </a:solidFill>
-                          <a:latin typeface="Calibri" pitchFamily="34" charset="0"/>
-                          <a:ea typeface="Calibri" pitchFamily="34" charset="-122"/>
-                          <a:cs typeface="Calibri" pitchFamily="34" charset="-120"/>
-                        </a:rPr>
-                        <a:t>17.4%</a:t>
-                      </a:r>
-                      <a:endParaRPr lang="en-US" sz="1200" dirty="0">
-                        <a:latin typeface="Calibri" charset="0"/>
-                        <a:ea typeface="Calibri" charset="0"/>
-                        <a:cs typeface="Calibri" charset="0"/>
-                      </a:endParaRPr>
-                    </a:p>
-                  </a:txBody>
-                  <a:tcPr marL="91440" marR="91440" marT="45720" marB="45720" anchor="ctr">
-                    <a:lnL w="6350" cap="flat" cmpd="sng" algn="ctr">
-                      <a:solidFill>
-                        <a:srgbClr val="D6CFC4"/>
-                      </a:solidFill>
-                      <a:prstDash val="solid"/>
-                      <a:round/>
-                      <a:headEnd type="none" w="med" len="med"/>
-                      <a:tailEnd type="none" w="med" len="med"/>
-                    </a:lnL>
-                    <a:lnR w="6350" cap="flat" cmpd="sng" algn="ctr">
-                      <a:solidFill>
-                        <a:srgbClr val="D6CFC4"/>
-                      </a:solidFill>
-                      <a:prstDash val="solid"/>
-                      <a:round/>
-                      <a:headEnd type="none" w="med" len="med"/>
-                      <a:tailEnd type="none" w="med" len="med"/>
-                    </a:lnR>
-                    <a:lnT w="6350" cap="flat" cmpd="sng" algn="ctr">
-                      <a:solidFill>
-                        <a:srgbClr val="D6CFC4"/>
-                      </a:solidFill>
-                      <a:prstDash val="solid"/>
-                      <a:round/>
-                      <a:headEnd type="none" w="med" len="med"/>
-                      <a:tailEnd type="none" w="med" len="med"/>
-                    </a:lnT>
-                    <a:lnB w="6350" cap="flat" cmpd="sng" algn="ctr">
-                      <a:solidFill>
-                        <a:srgbClr val="D6CFC4"/>
-                      </a:solidFill>
-                      <a:prstDash val="solid"/>
-                      <a:round/>
-                      <a:headEnd type="none" w="med" len="med"/>
-                      <a:tailEnd type="none" w="med" len="med"/>
-                    </a:lnB>
-                    <a:solidFill>
-                      <a:srgbClr val="FFFFFF"/>
-                    </a:solidFill>
-                  </a:tcPr>
-                </a:tc>
-                <a:tc>
-                  <a:txBody>
-                    <a:bodyPr/>
-                    <a:lstStyle/>
-                    <a:p>
-                      <a:pPr algn="ctr" indent="0" marL="0">
-                        <a:buNone/>
-                      </a:pPr>
-                      <a:r>
-                        <a:rPr lang="en-US" sz="1200" dirty="0">
-                          <a:solidFill>
-                            <a:srgbClr val="2D2A26"/>
-                          </a:solidFill>
-                          <a:latin typeface="Calibri" pitchFamily="34" charset="0"/>
-                          <a:ea typeface="Calibri" pitchFamily="34" charset="-122"/>
-                          <a:cs typeface="Calibri" pitchFamily="34" charset="-120"/>
-                        </a:rPr>
-                        <a:t>18.8%</a:t>
                       </a:r>
                       <a:endParaRPr lang="en-US" sz="1200" dirty="0">
                         <a:latin typeface="Calibri" charset="0"/>
@@ -16502,7 +17070,7 @@
                           <a:ea typeface="Century Gothic" pitchFamily="34" charset="-122"/>
                           <a:cs typeface="Century Gothic" pitchFamily="34" charset="-120"/>
                         </a:rPr>
-                        <a:t>Sierra Leone</a:t>
+                        <a:t>Uganda</a:t>
                       </a:r>
                       <a:endParaRPr lang="en-US" sz="1200" dirty="0">
                         <a:latin typeface="Century Gothic" charset="0"/>
@@ -16570,7 +17138,7 @@
                           <a:ea typeface="Calibri" pitchFamily="34" charset="-122"/>
                           <a:cs typeface="Calibri" pitchFamily="34" charset="-120"/>
                         </a:rPr>
-                        <a:t>2.0%</a:t>
+                        <a:t>17.4%</a:t>
                       </a:r>
                       <a:endParaRPr lang="en-US" sz="1200" dirty="0">
                         <a:latin typeface="Calibri" charset="0"/>
@@ -16638,7 +17206,7 @@
                           <a:ea typeface="Calibri" pitchFamily="34" charset="-122"/>
                           <a:cs typeface="Calibri" pitchFamily="34" charset="-120"/>
                         </a:rPr>
-                        <a:t>1.8%</a:t>
+                        <a:t>18.8%</a:t>
                       </a:r>
                       <a:endParaRPr lang="en-US" sz="1200" dirty="0">
                         <a:latin typeface="Calibri" charset="0"/>
@@ -16700,13 +17268,13 @@
                       <a:r>
                         <a:rPr lang="en-US" sz="1200" dirty="0">
                           <a:solidFill>
-                            <a:srgbClr val="1A7A6E"/>
+                            <a:srgbClr val="C0392B"/>
                           </a:solidFill>
                           <a:latin typeface="Calibri" pitchFamily="34" charset="0"/>
                           <a:ea typeface="Calibri" pitchFamily="34" charset="-122"/>
                           <a:cs typeface="Calibri" pitchFamily="34" charset="-120"/>
                         </a:rPr>
-                        <a:t>↓</a:t>
+                        <a:t>↑</a:t>
                       </a:r>
                       <a:endParaRPr lang="en-US" sz="1200" dirty="0">
                         <a:latin typeface="Calibri" charset="0"/>
@@ -19099,6 +19667,484 @@
                           <a:ea typeface="Century Gothic" pitchFamily="34" charset="-122"/>
                           <a:cs typeface="Century Gothic" pitchFamily="34" charset="-120"/>
                         </a:rPr>
+                        <a:t>Sierra Leone</a:t>
+                      </a:r>
+                      <a:endParaRPr lang="en-US" sz="1200" dirty="0">
+                        <a:latin typeface="Century Gothic" charset="0"/>
+                        <a:ea typeface="Century Gothic" charset="0"/>
+                        <a:cs typeface="Century Gothic" charset="0"/>
+                      </a:endParaRPr>
+                    </a:p>
+                  </a:txBody>
+                  <a:tcPr marL="91440" marR="91440" marT="45720" marB="45720" anchor="ctr">
+                    <a:lnL w="6350" cap="flat" cmpd="sng" algn="ctr">
+                      <a:solidFill>
+                        <a:srgbClr val="D6CFC4"/>
+                      </a:solidFill>
+                      <a:prstDash val="solid"/>
+                      <a:round/>
+                      <a:headEnd type="none" w="med" len="med"/>
+                      <a:tailEnd type="none" w="med" len="med"/>
+                    </a:lnL>
+                    <a:lnR w="6350" cap="flat" cmpd="sng" algn="ctr">
+                      <a:solidFill>
+                        <a:srgbClr val="D6CFC4"/>
+                      </a:solidFill>
+                      <a:prstDash val="solid"/>
+                      <a:round/>
+                      <a:headEnd type="none" w="med" len="med"/>
+                      <a:tailEnd type="none" w="med" len="med"/>
+                    </a:lnR>
+                    <a:lnT w="6350" cap="flat" cmpd="sng" algn="ctr">
+                      <a:solidFill>
+                        <a:srgbClr val="D6CFC4"/>
+                      </a:solidFill>
+                      <a:prstDash val="solid"/>
+                      <a:round/>
+                      <a:headEnd type="none" w="med" len="med"/>
+                      <a:tailEnd type="none" w="med" len="med"/>
+                    </a:lnT>
+                    <a:lnB w="6350" cap="flat" cmpd="sng" algn="ctr">
+                      <a:solidFill>
+                        <a:srgbClr val="D6CFC4"/>
+                      </a:solidFill>
+                      <a:prstDash val="solid"/>
+                      <a:round/>
+                      <a:headEnd type="none" w="med" len="med"/>
+                      <a:tailEnd type="none" w="med" len="med"/>
+                    </a:lnB>
+                    <a:solidFill>
+                      <a:srgbClr val="FFFFFF"/>
+                    </a:solidFill>
+                  </a:tcPr>
+                </a:tc>
+                <a:tc>
+                  <a:txBody>
+                    <a:bodyPr/>
+                    <a:lstStyle/>
+                    <a:p>
+                      <a:pPr algn="ctr" indent="0" marL="0">
+                        <a:buNone/>
+                      </a:pPr>
+                      <a:r>
+                        <a:rPr lang="en-US" sz="1200" dirty="0">
+                          <a:solidFill>
+                            <a:srgbClr val="2D2A26"/>
+                          </a:solidFill>
+                          <a:latin typeface="Calibri" pitchFamily="34" charset="0"/>
+                          <a:ea typeface="Calibri" pitchFamily="34" charset="-122"/>
+                          <a:cs typeface="Calibri" pitchFamily="34" charset="-120"/>
+                        </a:rPr>
+                        <a:t>$190,965</a:t>
+                      </a:r>
+                      <a:endParaRPr lang="en-US" sz="1200" dirty="0">
+                        <a:latin typeface="Calibri" charset="0"/>
+                        <a:ea typeface="Calibri" charset="0"/>
+                        <a:cs typeface="Calibri" charset="0"/>
+                      </a:endParaRPr>
+                    </a:p>
+                  </a:txBody>
+                  <a:tcPr marL="91440" marR="91440" marT="45720" marB="45720" anchor="ctr">
+                    <a:lnL w="6350" cap="flat" cmpd="sng" algn="ctr">
+                      <a:solidFill>
+                        <a:srgbClr val="D6CFC4"/>
+                      </a:solidFill>
+                      <a:prstDash val="solid"/>
+                      <a:round/>
+                      <a:headEnd type="none" w="med" len="med"/>
+                      <a:tailEnd type="none" w="med" len="med"/>
+                    </a:lnL>
+                    <a:lnR w="6350" cap="flat" cmpd="sng" algn="ctr">
+                      <a:solidFill>
+                        <a:srgbClr val="D6CFC4"/>
+                      </a:solidFill>
+                      <a:prstDash val="solid"/>
+                      <a:round/>
+                      <a:headEnd type="none" w="med" len="med"/>
+                      <a:tailEnd type="none" w="med" len="med"/>
+                    </a:lnR>
+                    <a:lnT w="6350" cap="flat" cmpd="sng" algn="ctr">
+                      <a:solidFill>
+                        <a:srgbClr val="D6CFC4"/>
+                      </a:solidFill>
+                      <a:prstDash val="solid"/>
+                      <a:round/>
+                      <a:headEnd type="none" w="med" len="med"/>
+                      <a:tailEnd type="none" w="med" len="med"/>
+                    </a:lnT>
+                    <a:lnB w="6350" cap="flat" cmpd="sng" algn="ctr">
+                      <a:solidFill>
+                        <a:srgbClr val="D6CFC4"/>
+                      </a:solidFill>
+                      <a:prstDash val="solid"/>
+                      <a:round/>
+                      <a:headEnd type="none" w="med" len="med"/>
+                      <a:tailEnd type="none" w="med" len="med"/>
+                    </a:lnB>
+                    <a:solidFill>
+                      <a:srgbClr val="FFFFFF"/>
+                    </a:solidFill>
+                  </a:tcPr>
+                </a:tc>
+                <a:tc>
+                  <a:txBody>
+                    <a:bodyPr/>
+                    <a:lstStyle/>
+                    <a:p>
+                      <a:pPr algn="ctr" indent="0" marL="0">
+                        <a:buNone/>
+                      </a:pPr>
+                      <a:r>
+                        <a:rPr lang="en-US" sz="1200" dirty="0">
+                          <a:solidFill>
+                            <a:srgbClr val="2D2A26"/>
+                          </a:solidFill>
+                          <a:latin typeface="Calibri" pitchFamily="34" charset="0"/>
+                          <a:ea typeface="Calibri" pitchFamily="34" charset="-122"/>
+                          <a:cs typeface="Calibri" pitchFamily="34" charset="-120"/>
+                        </a:rPr>
+                        <a:t>$-5,647</a:t>
+                      </a:r>
+                      <a:endParaRPr lang="en-US" sz="1200" dirty="0">
+                        <a:latin typeface="Calibri" charset="0"/>
+                        <a:ea typeface="Calibri" charset="0"/>
+                        <a:cs typeface="Calibri" charset="0"/>
+                      </a:endParaRPr>
+                    </a:p>
+                  </a:txBody>
+                  <a:tcPr marL="91440" marR="91440" marT="45720" marB="45720" anchor="ctr">
+                    <a:lnL w="6350" cap="flat" cmpd="sng" algn="ctr">
+                      <a:solidFill>
+                        <a:srgbClr val="D6CFC4"/>
+                      </a:solidFill>
+                      <a:prstDash val="solid"/>
+                      <a:round/>
+                      <a:headEnd type="none" w="med" len="med"/>
+                      <a:tailEnd type="none" w="med" len="med"/>
+                    </a:lnL>
+                    <a:lnR w="6350" cap="flat" cmpd="sng" algn="ctr">
+                      <a:solidFill>
+                        <a:srgbClr val="D6CFC4"/>
+                      </a:solidFill>
+                      <a:prstDash val="solid"/>
+                      <a:round/>
+                      <a:headEnd type="none" w="med" len="med"/>
+                      <a:tailEnd type="none" w="med" len="med"/>
+                    </a:lnR>
+                    <a:lnT w="6350" cap="flat" cmpd="sng" algn="ctr">
+                      <a:solidFill>
+                        <a:srgbClr val="D6CFC4"/>
+                      </a:solidFill>
+                      <a:prstDash val="solid"/>
+                      <a:round/>
+                      <a:headEnd type="none" w="med" len="med"/>
+                      <a:tailEnd type="none" w="med" len="med"/>
+                    </a:lnT>
+                    <a:lnB w="6350" cap="flat" cmpd="sng" algn="ctr">
+                      <a:solidFill>
+                        <a:srgbClr val="D6CFC4"/>
+                      </a:solidFill>
+                      <a:prstDash val="solid"/>
+                      <a:round/>
+                      <a:headEnd type="none" w="med" len="med"/>
+                      <a:tailEnd type="none" w="med" len="med"/>
+                    </a:lnB>
+                    <a:solidFill>
+                      <a:srgbClr val="FFFFFF"/>
+                    </a:solidFill>
+                  </a:tcPr>
+                </a:tc>
+                <a:tc>
+                  <a:txBody>
+                    <a:bodyPr/>
+                    <a:lstStyle/>
+                    <a:p>
+                      <a:pPr algn="ctr" indent="0" marL="0">
+                        <a:buNone/>
+                      </a:pPr>
+                      <a:r>
+                        <a:rPr lang="en-US" sz="1200" dirty="0">
+                          <a:solidFill>
+                            <a:srgbClr val="2D2A26"/>
+                          </a:solidFill>
+                          <a:latin typeface="Calibri" pitchFamily="34" charset="0"/>
+                          <a:ea typeface="Calibri" pitchFamily="34" charset="-122"/>
+                          <a:cs typeface="Calibri" pitchFamily="34" charset="-120"/>
+                        </a:rPr>
+                        <a:t>$-119,291</a:t>
+                      </a:r>
+                      <a:endParaRPr lang="en-US" sz="1200" dirty="0">
+                        <a:latin typeface="Calibri" charset="0"/>
+                        <a:ea typeface="Calibri" charset="0"/>
+                        <a:cs typeface="Calibri" charset="0"/>
+                      </a:endParaRPr>
+                    </a:p>
+                  </a:txBody>
+                  <a:tcPr marL="91440" marR="91440" marT="45720" marB="45720" anchor="ctr">
+                    <a:lnL w="6350" cap="flat" cmpd="sng" algn="ctr">
+                      <a:solidFill>
+                        <a:srgbClr val="D6CFC4"/>
+                      </a:solidFill>
+                      <a:prstDash val="solid"/>
+                      <a:round/>
+                      <a:headEnd type="none" w="med" len="med"/>
+                      <a:tailEnd type="none" w="med" len="med"/>
+                    </a:lnL>
+                    <a:lnR w="6350" cap="flat" cmpd="sng" algn="ctr">
+                      <a:solidFill>
+                        <a:srgbClr val="D6CFC4"/>
+                      </a:solidFill>
+                      <a:prstDash val="solid"/>
+                      <a:round/>
+                      <a:headEnd type="none" w="med" len="med"/>
+                      <a:tailEnd type="none" w="med" len="med"/>
+                    </a:lnR>
+                    <a:lnT w="6350" cap="flat" cmpd="sng" algn="ctr">
+                      <a:solidFill>
+                        <a:srgbClr val="D6CFC4"/>
+                      </a:solidFill>
+                      <a:prstDash val="solid"/>
+                      <a:round/>
+                      <a:headEnd type="none" w="med" len="med"/>
+                      <a:tailEnd type="none" w="med" len="med"/>
+                    </a:lnT>
+                    <a:lnB w="6350" cap="flat" cmpd="sng" algn="ctr">
+                      <a:solidFill>
+                        <a:srgbClr val="D6CFC4"/>
+                      </a:solidFill>
+                      <a:prstDash val="solid"/>
+                      <a:round/>
+                      <a:headEnd type="none" w="med" len="med"/>
+                      <a:tailEnd type="none" w="med" len="med"/>
+                    </a:lnB>
+                    <a:solidFill>
+                      <a:srgbClr val="FFFFFF"/>
+                    </a:solidFill>
+                  </a:tcPr>
+                </a:tc>
+                <a:tc>
+                  <a:txBody>
+                    <a:bodyPr/>
+                    <a:lstStyle/>
+                    <a:p>
+                      <a:pPr algn="ctr" indent="0" marL="0">
+                        <a:buNone/>
+                      </a:pPr>
+                      <a:r>
+                        <a:rPr lang="en-US" sz="1200" dirty="0">
+                          <a:solidFill>
+                            <a:srgbClr val="2D2A26"/>
+                          </a:solidFill>
+                          <a:latin typeface="Calibri" pitchFamily="34" charset="0"/>
+                          <a:ea typeface="Calibri" pitchFamily="34" charset="-122"/>
+                          <a:cs typeface="Calibri" pitchFamily="34" charset="-120"/>
+                        </a:rPr>
+                        <a:t>$66,026</a:t>
+                      </a:r>
+                      <a:endParaRPr lang="en-US" sz="1200" dirty="0">
+                        <a:latin typeface="Calibri" charset="0"/>
+                        <a:ea typeface="Calibri" charset="0"/>
+                        <a:cs typeface="Calibri" charset="0"/>
+                      </a:endParaRPr>
+                    </a:p>
+                  </a:txBody>
+                  <a:tcPr marL="91440" marR="91440" marT="45720" marB="45720" anchor="ctr">
+                    <a:lnL w="6350" cap="flat" cmpd="sng" algn="ctr">
+                      <a:solidFill>
+                        <a:srgbClr val="D6CFC4"/>
+                      </a:solidFill>
+                      <a:prstDash val="solid"/>
+                      <a:round/>
+                      <a:headEnd type="none" w="med" len="med"/>
+                      <a:tailEnd type="none" w="med" len="med"/>
+                    </a:lnL>
+                    <a:lnR w="6350" cap="flat" cmpd="sng" algn="ctr">
+                      <a:solidFill>
+                        <a:srgbClr val="D6CFC4"/>
+                      </a:solidFill>
+                      <a:prstDash val="solid"/>
+                      <a:round/>
+                      <a:headEnd type="none" w="med" len="med"/>
+                      <a:tailEnd type="none" w="med" len="med"/>
+                    </a:lnR>
+                    <a:lnT w="6350" cap="flat" cmpd="sng" algn="ctr">
+                      <a:solidFill>
+                        <a:srgbClr val="D6CFC4"/>
+                      </a:solidFill>
+                      <a:prstDash val="solid"/>
+                      <a:round/>
+                      <a:headEnd type="none" w="med" len="med"/>
+                      <a:tailEnd type="none" w="med" len="med"/>
+                    </a:lnT>
+                    <a:lnB w="6350" cap="flat" cmpd="sng" algn="ctr">
+                      <a:solidFill>
+                        <a:srgbClr val="D6CFC4"/>
+                      </a:solidFill>
+                      <a:prstDash val="solid"/>
+                      <a:round/>
+                      <a:headEnd type="none" w="med" len="med"/>
+                      <a:tailEnd type="none" w="med" len="med"/>
+                    </a:lnB>
+                    <a:solidFill>
+                      <a:srgbClr val="FFFFFF"/>
+                    </a:solidFill>
+                  </a:tcPr>
+                </a:tc>
+                <a:tc>
+                  <a:txBody>
+                    <a:bodyPr/>
+                    <a:lstStyle/>
+                    <a:p>
+                      <a:pPr algn="ctr" indent="0" marL="0">
+                        <a:buNone/>
+                      </a:pPr>
+                      <a:r>
+                        <a:rPr lang="en-US" sz="1200" dirty="0">
+                          <a:solidFill>
+                            <a:srgbClr val="2D2A26"/>
+                          </a:solidFill>
+                          <a:latin typeface="Calibri" pitchFamily="34" charset="0"/>
+                          <a:ea typeface="Calibri" pitchFamily="34" charset="-122"/>
+                          <a:cs typeface="Calibri" pitchFamily="34" charset="-120"/>
+                        </a:rPr>
+                        <a:t>34.6%</a:t>
+                      </a:r>
+                      <a:endParaRPr lang="en-US" sz="1200" dirty="0">
+                        <a:latin typeface="Calibri" charset="0"/>
+                        <a:ea typeface="Calibri" charset="0"/>
+                        <a:cs typeface="Calibri" charset="0"/>
+                      </a:endParaRPr>
+                    </a:p>
+                  </a:txBody>
+                  <a:tcPr marL="91440" marR="91440" marT="45720" marB="45720" anchor="ctr">
+                    <a:lnL w="6350" cap="flat" cmpd="sng" algn="ctr">
+                      <a:solidFill>
+                        <a:srgbClr val="D6CFC4"/>
+                      </a:solidFill>
+                      <a:prstDash val="solid"/>
+                      <a:round/>
+                      <a:headEnd type="none" w="med" len="med"/>
+                      <a:tailEnd type="none" w="med" len="med"/>
+                    </a:lnL>
+                    <a:lnR w="6350" cap="flat" cmpd="sng" algn="ctr">
+                      <a:solidFill>
+                        <a:srgbClr val="D6CFC4"/>
+                      </a:solidFill>
+                      <a:prstDash val="solid"/>
+                      <a:round/>
+                      <a:headEnd type="none" w="med" len="med"/>
+                      <a:tailEnd type="none" w="med" len="med"/>
+                    </a:lnR>
+                    <a:lnT w="6350" cap="flat" cmpd="sng" algn="ctr">
+                      <a:solidFill>
+                        <a:srgbClr val="D6CFC4"/>
+                      </a:solidFill>
+                      <a:prstDash val="solid"/>
+                      <a:round/>
+                      <a:headEnd type="none" w="med" len="med"/>
+                      <a:tailEnd type="none" w="med" len="med"/>
+                    </a:lnT>
+                    <a:lnB w="6350" cap="flat" cmpd="sng" algn="ctr">
+                      <a:solidFill>
+                        <a:srgbClr val="D6CFC4"/>
+                      </a:solidFill>
+                      <a:prstDash val="solid"/>
+                      <a:round/>
+                      <a:headEnd type="none" w="med" len="med"/>
+                      <a:tailEnd type="none" w="med" len="med"/>
+                    </a:lnB>
+                    <a:solidFill>
+                      <a:srgbClr val="FFFFFF"/>
+                    </a:solidFill>
+                  </a:tcPr>
+                </a:tc>
+                <a:tc>
+                  <a:txBody>
+                    <a:bodyPr/>
+                    <a:lstStyle/>
+                    <a:p>
+                      <a:pPr algn="ctr" indent="0" marL="0">
+                        <a:buNone/>
+                      </a:pPr>
+                      <a:r>
+                        <a:rPr lang="en-US" sz="1200" dirty="0">
+                          <a:solidFill>
+                            <a:srgbClr val="2D2A26"/>
+                          </a:solidFill>
+                          <a:latin typeface="Calibri" pitchFamily="34" charset="0"/>
+                          <a:ea typeface="Calibri" pitchFamily="34" charset="-122"/>
+                          <a:cs typeface="Calibri" pitchFamily="34" charset="-120"/>
+                        </a:rPr>
+                        <a:t>$55,275</a:t>
+                      </a:r>
+                      <a:endParaRPr lang="en-US" sz="1200" dirty="0">
+                        <a:latin typeface="Calibri" charset="0"/>
+                        <a:ea typeface="Calibri" charset="0"/>
+                        <a:cs typeface="Calibri" charset="0"/>
+                      </a:endParaRPr>
+                    </a:p>
+                  </a:txBody>
+                  <a:tcPr marL="91440" marR="91440" marT="45720" marB="45720" anchor="ctr">
+                    <a:lnL w="6350" cap="flat" cmpd="sng" algn="ctr">
+                      <a:solidFill>
+                        <a:srgbClr val="D6CFC4"/>
+                      </a:solidFill>
+                      <a:prstDash val="solid"/>
+                      <a:round/>
+                      <a:headEnd type="none" w="med" len="med"/>
+                      <a:tailEnd type="none" w="med" len="med"/>
+                    </a:lnL>
+                    <a:lnR w="6350" cap="flat" cmpd="sng" algn="ctr">
+                      <a:solidFill>
+                        <a:srgbClr val="D6CFC4"/>
+                      </a:solidFill>
+                      <a:prstDash val="solid"/>
+                      <a:round/>
+                      <a:headEnd type="none" w="med" len="med"/>
+                      <a:tailEnd type="none" w="med" len="med"/>
+                    </a:lnR>
+                    <a:lnT w="6350" cap="flat" cmpd="sng" algn="ctr">
+                      <a:solidFill>
+                        <a:srgbClr val="D6CFC4"/>
+                      </a:solidFill>
+                      <a:prstDash val="solid"/>
+                      <a:round/>
+                      <a:headEnd type="none" w="med" len="med"/>
+                      <a:tailEnd type="none" w="med" len="med"/>
+                    </a:lnT>
+                    <a:lnB w="6350" cap="flat" cmpd="sng" algn="ctr">
+                      <a:solidFill>
+                        <a:srgbClr val="D6CFC4"/>
+                      </a:solidFill>
+                      <a:prstDash val="solid"/>
+                      <a:round/>
+                      <a:headEnd type="none" w="med" len="med"/>
+                      <a:tailEnd type="none" w="med" len="med"/>
+                    </a:lnB>
+                    <a:solidFill>
+                      <a:srgbClr val="FFFFFF"/>
+                    </a:solidFill>
+                  </a:tcPr>
+                </a:tc>
+              </a:tr>
+              <a:tr h="457200">
+                <a:tc>
+                  <a:txBody>
+                    <a:bodyPr/>
+                    <a:lstStyle/>
+                    <a:p>
+                      <a:pPr algn="l" indent="0" marL="0">
+                        <a:buNone/>
+                      </a:pPr>
+                      <a:r>
+                        <a:rPr lang="en-US" sz="1200" b="1" dirty="0">
+                          <a:solidFill>
+                            <a:srgbClr val="2D2A26"/>
+                          </a:solidFill>
+                          <a:latin typeface="Century Gothic" pitchFamily="34" charset="0"/>
+                          <a:ea typeface="Century Gothic" pitchFamily="34" charset="-122"/>
+                          <a:cs typeface="Century Gothic" pitchFamily="34" charset="-120"/>
+                        </a:rPr>
                         <a:t>Uganda</a:t>
                       </a:r>
                       <a:endParaRPr lang="en-US" sz="1200" dirty="0">
@@ -19146,7 +20192,7 @@
                       <a:tailEnd type="none" w="med" len="med"/>
                     </a:lnB>
                     <a:solidFill>
-                      <a:srgbClr val="FFFFFF"/>
+                      <a:srgbClr val="FAF7F2"/>
                     </a:solidFill>
                   </a:tcPr>
                 </a:tc>
@@ -19214,7 +20260,7 @@
                       <a:tailEnd type="none" w="med" len="med"/>
                     </a:lnB>
                     <a:solidFill>
-                      <a:srgbClr val="FFFFFF"/>
+                      <a:srgbClr val="FAF7F2"/>
                     </a:solidFill>
                   </a:tcPr>
                 </a:tc>
@@ -19282,7 +20328,7 @@
                       <a:tailEnd type="none" w="med" len="med"/>
                     </a:lnB>
                     <a:solidFill>
-                      <a:srgbClr val="FFFFFF"/>
+                      <a:srgbClr val="FAF7F2"/>
                     </a:solidFill>
                   </a:tcPr>
                 </a:tc>
@@ -19350,7 +20396,7 @@
                       <a:tailEnd type="none" w="med" len="med"/>
                     </a:lnB>
                     <a:solidFill>
-                      <a:srgbClr val="FFFFFF"/>
+                      <a:srgbClr val="FAF7F2"/>
                     </a:solidFill>
                   </a:tcPr>
                 </a:tc>
@@ -19418,7 +20464,7 @@
                       <a:tailEnd type="none" w="med" len="med"/>
                     </a:lnB>
                     <a:solidFill>
-                      <a:srgbClr val="FFFFFF"/>
+                      <a:srgbClr val="FAF7F2"/>
                     </a:solidFill>
                   </a:tcPr>
                 </a:tc>
@@ -19486,7 +20532,7 @@
                       <a:tailEnd type="none" w="med" len="med"/>
                     </a:lnB>
                     <a:solidFill>
-                      <a:srgbClr val="FFFFFF"/>
+                      <a:srgbClr val="FAF7F2"/>
                     </a:solidFill>
                   </a:tcPr>
                 </a:tc>
@@ -19508,484 +20554,6 @@
                           <a:cs typeface="Calibri" pitchFamily="34" charset="-120"/>
                         </a:rPr>
                         <a:t>$-62,350</a:t>
-                      </a:r>
-                      <a:endParaRPr lang="en-US" sz="1200" dirty="0">
-                        <a:latin typeface="Calibri" charset="0"/>
-                        <a:ea typeface="Calibri" charset="0"/>
-                        <a:cs typeface="Calibri" charset="0"/>
-                      </a:endParaRPr>
-                    </a:p>
-                  </a:txBody>
-                  <a:tcPr marL="91440" marR="91440" marT="45720" marB="45720" anchor="ctr">
-                    <a:lnL w="6350" cap="flat" cmpd="sng" algn="ctr">
-                      <a:solidFill>
-                        <a:srgbClr val="D6CFC4"/>
-                      </a:solidFill>
-                      <a:prstDash val="solid"/>
-                      <a:round/>
-                      <a:headEnd type="none" w="med" len="med"/>
-                      <a:tailEnd type="none" w="med" len="med"/>
-                    </a:lnL>
-                    <a:lnR w="6350" cap="flat" cmpd="sng" algn="ctr">
-                      <a:solidFill>
-                        <a:srgbClr val="D6CFC4"/>
-                      </a:solidFill>
-                      <a:prstDash val="solid"/>
-                      <a:round/>
-                      <a:headEnd type="none" w="med" len="med"/>
-                      <a:tailEnd type="none" w="med" len="med"/>
-                    </a:lnR>
-                    <a:lnT w="6350" cap="flat" cmpd="sng" algn="ctr">
-                      <a:solidFill>
-                        <a:srgbClr val="D6CFC4"/>
-                      </a:solidFill>
-                      <a:prstDash val="solid"/>
-                      <a:round/>
-                      <a:headEnd type="none" w="med" len="med"/>
-                      <a:tailEnd type="none" w="med" len="med"/>
-                    </a:lnT>
-                    <a:lnB w="6350" cap="flat" cmpd="sng" algn="ctr">
-                      <a:solidFill>
-                        <a:srgbClr val="D6CFC4"/>
-                      </a:solidFill>
-                      <a:prstDash val="solid"/>
-                      <a:round/>
-                      <a:headEnd type="none" w="med" len="med"/>
-                      <a:tailEnd type="none" w="med" len="med"/>
-                    </a:lnB>
-                    <a:solidFill>
-                      <a:srgbClr val="FFFFFF"/>
-                    </a:solidFill>
-                  </a:tcPr>
-                </a:tc>
-              </a:tr>
-              <a:tr h="457200">
-                <a:tc>
-                  <a:txBody>
-                    <a:bodyPr/>
-                    <a:lstStyle/>
-                    <a:p>
-                      <a:pPr algn="l" indent="0" marL="0">
-                        <a:buNone/>
-                      </a:pPr>
-                      <a:r>
-                        <a:rPr lang="en-US" sz="1200" b="1" dirty="0">
-                          <a:solidFill>
-                            <a:srgbClr val="2D2A26"/>
-                          </a:solidFill>
-                          <a:latin typeface="Century Gothic" pitchFamily="34" charset="0"/>
-                          <a:ea typeface="Century Gothic" pitchFamily="34" charset="-122"/>
-                          <a:cs typeface="Century Gothic" pitchFamily="34" charset="-120"/>
-                        </a:rPr>
-                        <a:t>Sierra Leone</a:t>
-                      </a:r>
-                      <a:endParaRPr lang="en-US" sz="1200" dirty="0">
-                        <a:latin typeface="Century Gothic" charset="0"/>
-                        <a:ea typeface="Century Gothic" charset="0"/>
-                        <a:cs typeface="Century Gothic" charset="0"/>
-                      </a:endParaRPr>
-                    </a:p>
-                  </a:txBody>
-                  <a:tcPr marL="91440" marR="91440" marT="45720" marB="45720" anchor="ctr">
-                    <a:lnL w="6350" cap="flat" cmpd="sng" algn="ctr">
-                      <a:solidFill>
-                        <a:srgbClr val="D6CFC4"/>
-                      </a:solidFill>
-                      <a:prstDash val="solid"/>
-                      <a:round/>
-                      <a:headEnd type="none" w="med" len="med"/>
-                      <a:tailEnd type="none" w="med" len="med"/>
-                    </a:lnL>
-                    <a:lnR w="6350" cap="flat" cmpd="sng" algn="ctr">
-                      <a:solidFill>
-                        <a:srgbClr val="D6CFC4"/>
-                      </a:solidFill>
-                      <a:prstDash val="solid"/>
-                      <a:round/>
-                      <a:headEnd type="none" w="med" len="med"/>
-                      <a:tailEnd type="none" w="med" len="med"/>
-                    </a:lnR>
-                    <a:lnT w="6350" cap="flat" cmpd="sng" algn="ctr">
-                      <a:solidFill>
-                        <a:srgbClr val="D6CFC4"/>
-                      </a:solidFill>
-                      <a:prstDash val="solid"/>
-                      <a:round/>
-                      <a:headEnd type="none" w="med" len="med"/>
-                      <a:tailEnd type="none" w="med" len="med"/>
-                    </a:lnT>
-                    <a:lnB w="6350" cap="flat" cmpd="sng" algn="ctr">
-                      <a:solidFill>
-                        <a:srgbClr val="D6CFC4"/>
-                      </a:solidFill>
-                      <a:prstDash val="solid"/>
-                      <a:round/>
-                      <a:headEnd type="none" w="med" len="med"/>
-                      <a:tailEnd type="none" w="med" len="med"/>
-                    </a:lnB>
-                    <a:solidFill>
-                      <a:srgbClr val="FAF7F2"/>
-                    </a:solidFill>
-                  </a:tcPr>
-                </a:tc>
-                <a:tc>
-                  <a:txBody>
-                    <a:bodyPr/>
-                    <a:lstStyle/>
-                    <a:p>
-                      <a:pPr algn="ctr" indent="0" marL="0">
-                        <a:buNone/>
-                      </a:pPr>
-                      <a:r>
-                        <a:rPr lang="en-US" sz="1200" dirty="0">
-                          <a:solidFill>
-                            <a:srgbClr val="2D2A26"/>
-                          </a:solidFill>
-                          <a:latin typeface="Calibri" pitchFamily="34" charset="0"/>
-                          <a:ea typeface="Calibri" pitchFamily="34" charset="-122"/>
-                          <a:cs typeface="Calibri" pitchFamily="34" charset="-120"/>
-                        </a:rPr>
-                        <a:t>$190,965</a:t>
-                      </a:r>
-                      <a:endParaRPr lang="en-US" sz="1200" dirty="0">
-                        <a:latin typeface="Calibri" charset="0"/>
-                        <a:ea typeface="Calibri" charset="0"/>
-                        <a:cs typeface="Calibri" charset="0"/>
-                      </a:endParaRPr>
-                    </a:p>
-                  </a:txBody>
-                  <a:tcPr marL="91440" marR="91440" marT="45720" marB="45720" anchor="ctr">
-                    <a:lnL w="6350" cap="flat" cmpd="sng" algn="ctr">
-                      <a:solidFill>
-                        <a:srgbClr val="D6CFC4"/>
-                      </a:solidFill>
-                      <a:prstDash val="solid"/>
-                      <a:round/>
-                      <a:headEnd type="none" w="med" len="med"/>
-                      <a:tailEnd type="none" w="med" len="med"/>
-                    </a:lnL>
-                    <a:lnR w="6350" cap="flat" cmpd="sng" algn="ctr">
-                      <a:solidFill>
-                        <a:srgbClr val="D6CFC4"/>
-                      </a:solidFill>
-                      <a:prstDash val="solid"/>
-                      <a:round/>
-                      <a:headEnd type="none" w="med" len="med"/>
-                      <a:tailEnd type="none" w="med" len="med"/>
-                    </a:lnR>
-                    <a:lnT w="6350" cap="flat" cmpd="sng" algn="ctr">
-                      <a:solidFill>
-                        <a:srgbClr val="D6CFC4"/>
-                      </a:solidFill>
-                      <a:prstDash val="solid"/>
-                      <a:round/>
-                      <a:headEnd type="none" w="med" len="med"/>
-                      <a:tailEnd type="none" w="med" len="med"/>
-                    </a:lnT>
-                    <a:lnB w="6350" cap="flat" cmpd="sng" algn="ctr">
-                      <a:solidFill>
-                        <a:srgbClr val="D6CFC4"/>
-                      </a:solidFill>
-                      <a:prstDash val="solid"/>
-                      <a:round/>
-                      <a:headEnd type="none" w="med" len="med"/>
-                      <a:tailEnd type="none" w="med" len="med"/>
-                    </a:lnB>
-                    <a:solidFill>
-                      <a:srgbClr val="FAF7F2"/>
-                    </a:solidFill>
-                  </a:tcPr>
-                </a:tc>
-                <a:tc>
-                  <a:txBody>
-                    <a:bodyPr/>
-                    <a:lstStyle/>
-                    <a:p>
-                      <a:pPr algn="ctr" indent="0" marL="0">
-                        <a:buNone/>
-                      </a:pPr>
-                      <a:r>
-                        <a:rPr lang="en-US" sz="1200" dirty="0">
-                          <a:solidFill>
-                            <a:srgbClr val="2D2A26"/>
-                          </a:solidFill>
-                          <a:latin typeface="Calibri" pitchFamily="34" charset="0"/>
-                          <a:ea typeface="Calibri" pitchFamily="34" charset="-122"/>
-                          <a:cs typeface="Calibri" pitchFamily="34" charset="-120"/>
-                        </a:rPr>
-                        <a:t>$-5,647</a:t>
-                      </a:r>
-                      <a:endParaRPr lang="en-US" sz="1200" dirty="0">
-                        <a:latin typeface="Calibri" charset="0"/>
-                        <a:ea typeface="Calibri" charset="0"/>
-                        <a:cs typeface="Calibri" charset="0"/>
-                      </a:endParaRPr>
-                    </a:p>
-                  </a:txBody>
-                  <a:tcPr marL="91440" marR="91440" marT="45720" marB="45720" anchor="ctr">
-                    <a:lnL w="6350" cap="flat" cmpd="sng" algn="ctr">
-                      <a:solidFill>
-                        <a:srgbClr val="D6CFC4"/>
-                      </a:solidFill>
-                      <a:prstDash val="solid"/>
-                      <a:round/>
-                      <a:headEnd type="none" w="med" len="med"/>
-                      <a:tailEnd type="none" w="med" len="med"/>
-                    </a:lnL>
-                    <a:lnR w="6350" cap="flat" cmpd="sng" algn="ctr">
-                      <a:solidFill>
-                        <a:srgbClr val="D6CFC4"/>
-                      </a:solidFill>
-                      <a:prstDash val="solid"/>
-                      <a:round/>
-                      <a:headEnd type="none" w="med" len="med"/>
-                      <a:tailEnd type="none" w="med" len="med"/>
-                    </a:lnR>
-                    <a:lnT w="6350" cap="flat" cmpd="sng" algn="ctr">
-                      <a:solidFill>
-                        <a:srgbClr val="D6CFC4"/>
-                      </a:solidFill>
-                      <a:prstDash val="solid"/>
-                      <a:round/>
-                      <a:headEnd type="none" w="med" len="med"/>
-                      <a:tailEnd type="none" w="med" len="med"/>
-                    </a:lnT>
-                    <a:lnB w="6350" cap="flat" cmpd="sng" algn="ctr">
-                      <a:solidFill>
-                        <a:srgbClr val="D6CFC4"/>
-                      </a:solidFill>
-                      <a:prstDash val="solid"/>
-                      <a:round/>
-                      <a:headEnd type="none" w="med" len="med"/>
-                      <a:tailEnd type="none" w="med" len="med"/>
-                    </a:lnB>
-                    <a:solidFill>
-                      <a:srgbClr val="FAF7F2"/>
-                    </a:solidFill>
-                  </a:tcPr>
-                </a:tc>
-                <a:tc>
-                  <a:txBody>
-                    <a:bodyPr/>
-                    <a:lstStyle/>
-                    <a:p>
-                      <a:pPr algn="ctr" indent="0" marL="0">
-                        <a:buNone/>
-                      </a:pPr>
-                      <a:r>
-                        <a:rPr lang="en-US" sz="1200" dirty="0">
-                          <a:solidFill>
-                            <a:srgbClr val="2D2A26"/>
-                          </a:solidFill>
-                          <a:latin typeface="Calibri" pitchFamily="34" charset="0"/>
-                          <a:ea typeface="Calibri" pitchFamily="34" charset="-122"/>
-                          <a:cs typeface="Calibri" pitchFamily="34" charset="-120"/>
-                        </a:rPr>
-                        <a:t>$-119,291</a:t>
-                      </a:r>
-                      <a:endParaRPr lang="en-US" sz="1200" dirty="0">
-                        <a:latin typeface="Calibri" charset="0"/>
-                        <a:ea typeface="Calibri" charset="0"/>
-                        <a:cs typeface="Calibri" charset="0"/>
-                      </a:endParaRPr>
-                    </a:p>
-                  </a:txBody>
-                  <a:tcPr marL="91440" marR="91440" marT="45720" marB="45720" anchor="ctr">
-                    <a:lnL w="6350" cap="flat" cmpd="sng" algn="ctr">
-                      <a:solidFill>
-                        <a:srgbClr val="D6CFC4"/>
-                      </a:solidFill>
-                      <a:prstDash val="solid"/>
-                      <a:round/>
-                      <a:headEnd type="none" w="med" len="med"/>
-                      <a:tailEnd type="none" w="med" len="med"/>
-                    </a:lnL>
-                    <a:lnR w="6350" cap="flat" cmpd="sng" algn="ctr">
-                      <a:solidFill>
-                        <a:srgbClr val="D6CFC4"/>
-                      </a:solidFill>
-                      <a:prstDash val="solid"/>
-                      <a:round/>
-                      <a:headEnd type="none" w="med" len="med"/>
-                      <a:tailEnd type="none" w="med" len="med"/>
-                    </a:lnR>
-                    <a:lnT w="6350" cap="flat" cmpd="sng" algn="ctr">
-                      <a:solidFill>
-                        <a:srgbClr val="D6CFC4"/>
-                      </a:solidFill>
-                      <a:prstDash val="solid"/>
-                      <a:round/>
-                      <a:headEnd type="none" w="med" len="med"/>
-                      <a:tailEnd type="none" w="med" len="med"/>
-                    </a:lnT>
-                    <a:lnB w="6350" cap="flat" cmpd="sng" algn="ctr">
-                      <a:solidFill>
-                        <a:srgbClr val="D6CFC4"/>
-                      </a:solidFill>
-                      <a:prstDash val="solid"/>
-                      <a:round/>
-                      <a:headEnd type="none" w="med" len="med"/>
-                      <a:tailEnd type="none" w="med" len="med"/>
-                    </a:lnB>
-                    <a:solidFill>
-                      <a:srgbClr val="FAF7F2"/>
-                    </a:solidFill>
-                  </a:tcPr>
-                </a:tc>
-                <a:tc>
-                  <a:txBody>
-                    <a:bodyPr/>
-                    <a:lstStyle/>
-                    <a:p>
-                      <a:pPr algn="ctr" indent="0" marL="0">
-                        <a:buNone/>
-                      </a:pPr>
-                      <a:r>
-                        <a:rPr lang="en-US" sz="1200" dirty="0">
-                          <a:solidFill>
-                            <a:srgbClr val="2D2A26"/>
-                          </a:solidFill>
-                          <a:latin typeface="Calibri" pitchFamily="34" charset="0"/>
-                          <a:ea typeface="Calibri" pitchFamily="34" charset="-122"/>
-                          <a:cs typeface="Calibri" pitchFamily="34" charset="-120"/>
-                        </a:rPr>
-                        <a:t>$66,026</a:t>
-                      </a:r>
-                      <a:endParaRPr lang="en-US" sz="1200" dirty="0">
-                        <a:latin typeface="Calibri" charset="0"/>
-                        <a:ea typeface="Calibri" charset="0"/>
-                        <a:cs typeface="Calibri" charset="0"/>
-                      </a:endParaRPr>
-                    </a:p>
-                  </a:txBody>
-                  <a:tcPr marL="91440" marR="91440" marT="45720" marB="45720" anchor="ctr">
-                    <a:lnL w="6350" cap="flat" cmpd="sng" algn="ctr">
-                      <a:solidFill>
-                        <a:srgbClr val="D6CFC4"/>
-                      </a:solidFill>
-                      <a:prstDash val="solid"/>
-                      <a:round/>
-                      <a:headEnd type="none" w="med" len="med"/>
-                      <a:tailEnd type="none" w="med" len="med"/>
-                    </a:lnL>
-                    <a:lnR w="6350" cap="flat" cmpd="sng" algn="ctr">
-                      <a:solidFill>
-                        <a:srgbClr val="D6CFC4"/>
-                      </a:solidFill>
-                      <a:prstDash val="solid"/>
-                      <a:round/>
-                      <a:headEnd type="none" w="med" len="med"/>
-                      <a:tailEnd type="none" w="med" len="med"/>
-                    </a:lnR>
-                    <a:lnT w="6350" cap="flat" cmpd="sng" algn="ctr">
-                      <a:solidFill>
-                        <a:srgbClr val="D6CFC4"/>
-                      </a:solidFill>
-                      <a:prstDash val="solid"/>
-                      <a:round/>
-                      <a:headEnd type="none" w="med" len="med"/>
-                      <a:tailEnd type="none" w="med" len="med"/>
-                    </a:lnT>
-                    <a:lnB w="6350" cap="flat" cmpd="sng" algn="ctr">
-                      <a:solidFill>
-                        <a:srgbClr val="D6CFC4"/>
-                      </a:solidFill>
-                      <a:prstDash val="solid"/>
-                      <a:round/>
-                      <a:headEnd type="none" w="med" len="med"/>
-                      <a:tailEnd type="none" w="med" len="med"/>
-                    </a:lnB>
-                    <a:solidFill>
-                      <a:srgbClr val="FAF7F2"/>
-                    </a:solidFill>
-                  </a:tcPr>
-                </a:tc>
-                <a:tc>
-                  <a:txBody>
-                    <a:bodyPr/>
-                    <a:lstStyle/>
-                    <a:p>
-                      <a:pPr algn="ctr" indent="0" marL="0">
-                        <a:buNone/>
-                      </a:pPr>
-                      <a:r>
-                        <a:rPr lang="en-US" sz="1200" dirty="0">
-                          <a:solidFill>
-                            <a:srgbClr val="2D2A26"/>
-                          </a:solidFill>
-                          <a:latin typeface="Calibri" pitchFamily="34" charset="0"/>
-                          <a:ea typeface="Calibri" pitchFamily="34" charset="-122"/>
-                          <a:cs typeface="Calibri" pitchFamily="34" charset="-120"/>
-                        </a:rPr>
-                        <a:t>34.6%</a:t>
-                      </a:r>
-                      <a:endParaRPr lang="en-US" sz="1200" dirty="0">
-                        <a:latin typeface="Calibri" charset="0"/>
-                        <a:ea typeface="Calibri" charset="0"/>
-                        <a:cs typeface="Calibri" charset="0"/>
-                      </a:endParaRPr>
-                    </a:p>
-                  </a:txBody>
-                  <a:tcPr marL="91440" marR="91440" marT="45720" marB="45720" anchor="ctr">
-                    <a:lnL w="6350" cap="flat" cmpd="sng" algn="ctr">
-                      <a:solidFill>
-                        <a:srgbClr val="D6CFC4"/>
-                      </a:solidFill>
-                      <a:prstDash val="solid"/>
-                      <a:round/>
-                      <a:headEnd type="none" w="med" len="med"/>
-                      <a:tailEnd type="none" w="med" len="med"/>
-                    </a:lnL>
-                    <a:lnR w="6350" cap="flat" cmpd="sng" algn="ctr">
-                      <a:solidFill>
-                        <a:srgbClr val="D6CFC4"/>
-                      </a:solidFill>
-                      <a:prstDash val="solid"/>
-                      <a:round/>
-                      <a:headEnd type="none" w="med" len="med"/>
-                      <a:tailEnd type="none" w="med" len="med"/>
-                    </a:lnR>
-                    <a:lnT w="6350" cap="flat" cmpd="sng" algn="ctr">
-                      <a:solidFill>
-                        <a:srgbClr val="D6CFC4"/>
-                      </a:solidFill>
-                      <a:prstDash val="solid"/>
-                      <a:round/>
-                      <a:headEnd type="none" w="med" len="med"/>
-                      <a:tailEnd type="none" w="med" len="med"/>
-                    </a:lnT>
-                    <a:lnB w="6350" cap="flat" cmpd="sng" algn="ctr">
-                      <a:solidFill>
-                        <a:srgbClr val="D6CFC4"/>
-                      </a:solidFill>
-                      <a:prstDash val="solid"/>
-                      <a:round/>
-                      <a:headEnd type="none" w="med" len="med"/>
-                      <a:tailEnd type="none" w="med" len="med"/>
-                    </a:lnB>
-                    <a:solidFill>
-                      <a:srgbClr val="FAF7F2"/>
-                    </a:solidFill>
-                  </a:tcPr>
-                </a:tc>
-                <a:tc>
-                  <a:txBody>
-                    <a:bodyPr/>
-                    <a:lstStyle/>
-                    <a:p>
-                      <a:pPr algn="ctr" indent="0" marL="0">
-                        <a:buNone/>
-                      </a:pPr>
-                      <a:r>
-                        <a:rPr lang="en-US" sz="1200" dirty="0">
-                          <a:solidFill>
-                            <a:srgbClr val="2D2A26"/>
-                          </a:solidFill>
-                          <a:latin typeface="Calibri" pitchFamily="34" charset="0"/>
-                          <a:ea typeface="Calibri" pitchFamily="34" charset="-122"/>
-                          <a:cs typeface="Calibri" pitchFamily="34" charset="-120"/>
-                        </a:rPr>
-                        <a:t>$55,275</a:t>
                       </a:r>
                       <a:endParaRPr lang="en-US" sz="1200" dirty="0">
                         <a:latin typeface="Calibri" charset="0"/>

</xml_diff>